<commit_message>
docs: add talent development global view slide
</commit_message>
<xml_diff>
--- a/deliverables/talent-development-solution-deck/海格汽车人才发展方案_瑞士风_苹方版.pptx
+++ b/deliverables/talent-development-solution-deck/海格汽车人才发展方案_瑞士风_苹方版.pptx
@@ -6,6 +6,7 @@
   </p:sldMasterIdLst>
   <p:sldIdLst>
     <p:sldId id="256" r:id="rId2"/>
+    <p:sldId id="267" r:id="rId18"/>
     <p:sldId id="257" r:id="rId3"/>
     <p:sldId id="258" r:id="rId4"/>
     <p:sldId id="259" r:id="rId5"/>
@@ -3955,7 +3956,7 @@
                 <a:ea typeface="PingFang SC" pitchFamily="34" charset="-122"/>
                 <a:cs typeface="PingFang SC" pitchFamily="34" charset="-120"/>
               </a:rPr>
-              <a:t>SS · 26.08.27 · 01 / 11</a:t>
+              <a:t>SS · 26.08.27 · 01 / 12</a:t>
             </a:r>
             <a:endParaRPr lang="zh-CN" sz="850" dirty="0"/>
           </a:p>
@@ -4321,7 +4322,7 @@
                 <a:ea typeface="PingFang SC" pitchFamily="34" charset="-122"/>
                 <a:cs typeface="PingFang SC" pitchFamily="34" charset="-120"/>
               </a:rPr>
-              <a:t>10 / 11</a:t>
+              <a:t>11 / 12</a:t>
             </a:r>
             <a:endParaRPr lang="zh-CN" sz="850" dirty="0"/>
           </a:p>
@@ -7016,7 +7017,7 @@
                 <a:ea typeface="PingFang SC" pitchFamily="34" charset="-122"/>
                 <a:cs typeface="PingFang SC" pitchFamily="34" charset="-120"/>
               </a:rPr>
-              <a:t>11 / 11</a:t>
+              <a:t>12 / 12</a:t>
             </a:r>
             <a:endParaRPr lang="zh-CN" sz="850" dirty="0"/>
           </a:p>
@@ -7832,6 +7833,2871 @@
             <a:endParaRPr lang="zh-CN" sz="850" dirty="0"/>
           </a:p>
         </p:txBody>
+      </p:sp>
+    </p:spTree>
+  </p:cSld>
+  <p:clrMapOvr>
+    <a:masterClrMapping/>
+  </p:clrMapOvr>
+</p:sld>
+</file>
+
+<file path=ppt/slides/slide12.xml><?xml version="1.0" encoding="utf-8"?>
+<p:sld xmlns:a="http://schemas.openxmlformats.org/drawingml/2006/main" xmlns:r="http://schemas.openxmlformats.org/officeDocument/2006/relationships" xmlns:p="http://schemas.openxmlformats.org/presentationml/2006/main">
+  <p:cSld name="Slide 2">
+    <p:bg>
+      <p:bgPr>
+        <a:solidFill>
+          <a:srgbClr val="FAFAF8"/>
+        </a:solidFill>
+      </p:bgPr>
+    </p:bg>
+    <p:spTree>
+      <p:nvGrpSpPr>
+        <p:cNvPr id="1" name=""/>
+        <p:cNvGrpSpPr/>
+        <p:nvPr/>
+      </p:nvGrpSpPr>
+      <p:grpSpPr>
+        <a:xfrm>
+          <a:off x="0" y="0"/>
+          <a:ext cx="0" cy="0"/>
+          <a:chOff x="0" y="0"/>
+          <a:chExt cx="0" cy="0"/>
+        </a:xfrm>
+      </p:grpSpPr>
+      <p:sp>
+        <p:nvSpPr>
+          <p:cNvPr id="2" name="Text 0"/>
+          <p:cNvSpPr txBox="1"/>
+          <p:nvPr/>
+        </p:nvSpPr>
+        <p:spPr>
+          <a:xfrm>
+            <a:off x="594360" y="384048"/>
+            <a:ext cx="7498080" cy="219456"/>
+          </a:xfrm>
+          <a:prstGeom prst="rect">
+            <a:avLst/>
+          </a:prstGeom>
+          <a:noFill/>
+          <a:ln/>
+        </p:spPr>
+        <p:txBody>
+          <a:bodyPr wrap="square" lIns="0" tIns="0" rIns="0" bIns="0" rtlCol="0" anchor="ctr"/>
+          <a:lstStyle/>
+          <a:p>
+            <a:pPr algn="l" indent="0" marL="0">
+              <a:buNone/>
+            </a:pPr>
+            <a:r>
+              <a:rPr lang="zh-CN" altLang="en-US" sz="850" b="1" spc="115" kern="0" dirty="0">
+                <a:solidFill>
+                  <a:srgbClr val="737373"/>
+                </a:solidFill>
+                <a:latin typeface="PingFang SC" pitchFamily="34" charset="0"/>
+                <a:ea typeface="PingFang SC" pitchFamily="34" charset="-122"/>
+                <a:cs typeface="PingFang SC" pitchFamily="34" charset="-120"/>
+              </a:rPr>
+              <a:t>00 · 全局视图 / BD × OD × TD × LD</a:t>
+            </a:r>
+            <a:endParaRPr lang="zh-CN" sz="850" dirty="0"/>
+          </a:p>
+        </p:txBody>
+      </p:sp>
+      <p:sp>
+        <p:nvSpPr>
+          <p:cNvPr id="3" name="Text 1"/>
+          <p:cNvSpPr txBox="1"/>
+          <p:nvPr/>
+        </p:nvSpPr>
+        <p:spPr>
+          <a:xfrm>
+            <a:off x="10682935" y="384048"/>
+            <a:ext cx="914400" cy="219456"/>
+          </a:xfrm>
+          <a:prstGeom prst="rect">
+            <a:avLst/>
+          </a:prstGeom>
+          <a:noFill/>
+          <a:ln/>
+        </p:spPr>
+        <p:txBody>
+          <a:bodyPr wrap="square" lIns="0" tIns="0" rIns="0" bIns="0" rtlCol="0" anchor="ctr"/>
+          <a:lstStyle/>
+          <a:p>
+            <a:pPr algn="r" indent="0" marL="0">
+              <a:buNone/>
+            </a:pPr>
+            <a:r>
+              <a:rPr lang="zh-CN" altLang="en-US" sz="850" b="1" spc="115" kern="0" dirty="0">
+                <a:solidFill>
+                  <a:srgbClr val="737373"/>
+                </a:solidFill>
+                <a:latin typeface="PingFang SC" pitchFamily="34" charset="0"/>
+                <a:ea typeface="PingFang SC" pitchFamily="34" charset="-122"/>
+                <a:cs typeface="PingFang SC" pitchFamily="34" charset="-120"/>
+              </a:rPr>
+              <a:t>02 / 12</a:t>
+            </a:r>
+            <a:endParaRPr lang="zh-CN" sz="850" dirty="0"/>
+          </a:p>
+        </p:txBody>
+      </p:sp>
+      <p:sp>
+        <p:nvSpPr>
+          <p:cNvPr id="4" name="Text 2"/>
+          <p:cNvSpPr txBox="1"/>
+          <p:nvPr/>
+        </p:nvSpPr>
+        <p:spPr>
+          <a:xfrm>
+            <a:off x="594360" y="877824"/>
+            <a:ext cx="7315200" cy="219456"/>
+          </a:xfrm>
+          <a:prstGeom prst="rect">
+            <a:avLst/>
+          </a:prstGeom>
+          <a:noFill/>
+          <a:ln/>
+        </p:spPr>
+        <p:txBody>
+          <a:bodyPr wrap="square" lIns="0" tIns="0" rIns="0" bIns="0" rtlCol="0" anchor="ctr"/>
+          <a:lstStyle/>
+          <a:p>
+            <a:pPr algn="l" indent="0" marL="0">
+              <a:buNone/>
+            </a:pPr>
+            <a:r>
+              <a:rPr lang="zh-CN" altLang="en-US" sz="850" b="1" spc="115" kern="0" dirty="0">
+                <a:solidFill>
+                  <a:srgbClr val="737373"/>
+                </a:solidFill>
+                <a:latin typeface="PingFang SC" pitchFamily="34" charset="0"/>
+                <a:ea typeface="PingFang SC" pitchFamily="34" charset="-122"/>
+                <a:cs typeface="PingFang SC" pitchFamily="34" charset="-120"/>
+              </a:rPr>
+              <a:t>从业务战略到组织、人才与学习的一体化链路</a:t>
+            </a:r>
+            <a:endParaRPr lang="zh-CN" sz="850" dirty="0"/>
+          </a:p>
+        </p:txBody>
+      </p:sp>
+      <p:sp>
+        <p:nvSpPr>
+          <p:cNvPr id="5" name="Text 3"/>
+          <p:cNvSpPr txBox="1"/>
+          <p:nvPr/>
+        </p:nvSpPr>
+        <p:spPr>
+          <a:xfrm>
+            <a:off x="594360" y="1078992"/>
+            <a:ext cx="5166360" cy="530352"/>
+          </a:xfrm>
+          <a:prstGeom prst="rect">
+            <a:avLst/>
+          </a:prstGeom>
+          <a:noFill/>
+          <a:ln/>
+        </p:spPr>
+        <p:txBody>
+          <a:bodyPr wrap="square" lIns="0" tIns="0" rIns="0" bIns="0" rtlCol="0" anchor="t">
+            <a:normAutofit/>
+          </a:bodyPr>
+          <a:lstStyle/>
+          <a:p>
+            <a:pPr algn="l" indent="0" marL="0">
+              <a:buNone/>
+            </a:pPr>
+            <a:r>
+              <a:rPr lang="zh-CN" altLang="en-US" sz="3400" dirty="0">
+                <a:solidFill>
+                  <a:srgbClr val="0A0A0A"/>
+                </a:solidFill>
+                <a:latin typeface="PingFang SC" pitchFamily="34" charset="0"/>
+                <a:ea typeface="PingFang SC" pitchFamily="34" charset="-122"/>
+                <a:cs typeface="PingFang SC" pitchFamily="34" charset="-120"/>
+              </a:rPr>
+              <a:t>人才发展全局视图</a:t>
+            </a:r>
+            <a:endParaRPr lang="zh-CN" sz="3400" dirty="0"/>
+          </a:p>
+        </p:txBody>
+      </p:sp>
+      <p:sp>
+        <p:nvSpPr>
+          <p:cNvPr id="6" name="Text 4"/>
+          <p:cNvSpPr txBox="1"/>
+          <p:nvPr/>
+        </p:nvSpPr>
+        <p:spPr>
+          <a:xfrm>
+            <a:off x="5989320" y="1179576"/>
+            <a:ext cx="5605272" cy="310896"/>
+          </a:xfrm>
+          <a:prstGeom prst="rect">
+            <a:avLst/>
+          </a:prstGeom>
+          <a:noFill/>
+          <a:ln/>
+        </p:spPr>
+        <p:txBody>
+          <a:bodyPr wrap="square" lIns="0" tIns="0" rIns="0" bIns="0" rtlCol="0" anchor="t">
+            <a:normAutofit/>
+          </a:bodyPr>
+          <a:lstStyle/>
+          <a:p>
+            <a:pPr algn="r" indent="0" marL="0">
+              <a:buNone/>
+            </a:pPr>
+            <a:r>
+              <a:rPr lang="zh-CN" altLang="en-US" sz="1230" dirty="0">
+                <a:solidFill>
+                  <a:srgbClr val="525252"/>
+                </a:solidFill>
+                <a:latin typeface="PingFang SC" pitchFamily="34" charset="0"/>
+                <a:ea typeface="PingFang SC" pitchFamily="34" charset="-122"/>
+                <a:cs typeface="PingFang SC" pitchFamily="34" charset="-120"/>
+              </a:rPr>
+              <a:t>战略定方向，组织定环境，人才定对象，学习定行动。</a:t>
+            </a:r>
+            <a:endParaRPr lang="zh-CN" sz="1230" dirty="0"/>
+          </a:p>
+        </p:txBody>
+      </p:sp>
+      <p:sp>
+        <p:nvSpPr>
+          <p:cNvPr id="7" name="Shape 5"/>
+          <p:cNvSpPr/>
+          <p:nvPr/>
+        </p:nvSpPr>
+        <p:spPr>
+          <a:xfrm>
+            <a:off x="594360" y="1792224"/>
+            <a:ext cx="1078992" cy="987552"/>
+          </a:xfrm>
+          <a:prstGeom prst="rect">
+            <a:avLst/>
+          </a:prstGeom>
+          <a:solidFill>
+            <a:srgbClr val="E8EDFF"/>
+          </a:solidFill>
+          <a:ln w="6350">
+            <a:solidFill>
+              <a:srgbClr val="E8EDFF">
+                <a:alpha val="0"/>
+              </a:srgbClr>
+            </a:solidFill>
+            <a:prstDash val="solid"/>
+          </a:ln>
+        </p:spPr>
+      </p:sp>
+      <p:sp>
+        <p:nvSpPr>
+          <p:cNvPr id="8" name="Text 6"/>
+          <p:cNvSpPr txBox="1"/>
+          <p:nvPr/>
+        </p:nvSpPr>
+        <p:spPr>
+          <a:xfrm>
+            <a:off x="758952" y="1975104"/>
+            <a:ext cx="749808" cy="219456"/>
+          </a:xfrm>
+          <a:prstGeom prst="rect">
+            <a:avLst/>
+          </a:prstGeom>
+          <a:noFill/>
+          <a:ln/>
+        </p:spPr>
+        <p:txBody>
+          <a:bodyPr wrap="square" lIns="0" tIns="0" rIns="0" bIns="0" rtlCol="0" anchor="ctr"/>
+          <a:lstStyle/>
+          <a:p>
+            <a:pPr algn="l" indent="0" marL="0">
+              <a:buNone/>
+            </a:pPr>
+            <a:r>
+              <a:rPr lang="zh-CN" altLang="en-US" sz="850" b="1" spc="115" kern="0" dirty="0">
+                <a:solidFill>
+                  <a:srgbClr val="002FA7"/>
+                </a:solidFill>
+                <a:latin typeface="PingFang SC" pitchFamily="34" charset="0"/>
+                <a:ea typeface="PingFang SC" pitchFamily="34" charset="-122"/>
+                <a:cs typeface="PingFang SC" pitchFamily="34" charset="-120"/>
+              </a:rPr>
+              <a:t>BD</a:t>
+            </a:r>
+            <a:endParaRPr lang="zh-CN" sz="850" dirty="0"/>
+          </a:p>
+        </p:txBody>
+      </p:sp>
+      <p:sp>
+        <p:nvSpPr>
+          <p:cNvPr id="9" name="Text 7"/>
+          <p:cNvSpPr txBox="1"/>
+          <p:nvPr/>
+        </p:nvSpPr>
+        <p:spPr>
+          <a:xfrm>
+            <a:off x="758952" y="2276856"/>
+            <a:ext cx="749808" cy="274320"/>
+          </a:xfrm>
+          <a:prstGeom prst="rect">
+            <a:avLst/>
+          </a:prstGeom>
+          <a:noFill/>
+          <a:ln/>
+        </p:spPr>
+        <p:txBody>
+          <a:bodyPr wrap="square" lIns="0" tIns="0" rIns="0" bIns="0" rtlCol="0" anchor="t">
+            <a:normAutofit/>
+          </a:bodyPr>
+          <a:lstStyle/>
+          <a:p>
+            <a:pPr algn="l" indent="0" marL="0">
+              <a:buNone/>
+            </a:pPr>
+            <a:r>
+              <a:rPr lang="zh-CN" altLang="en-US" sz="1130" b="1" dirty="0">
+                <a:solidFill>
+                  <a:srgbClr val="002FA7"/>
+                </a:solidFill>
+                <a:latin typeface="PingFang SC" pitchFamily="34" charset="0"/>
+                <a:ea typeface="PingFang SC" pitchFamily="34" charset="-122"/>
+                <a:cs typeface="PingFang SC" pitchFamily="34" charset="-120"/>
+              </a:rPr>
+              <a:t>业务发展</a:t>
+            </a:r>
+            <a:endParaRPr lang="zh-CN" sz="1130" dirty="0"/>
+          </a:p>
+        </p:txBody>
+      </p:sp>
+      <p:sp>
+        <p:nvSpPr>
+          <p:cNvPr id="10" name="Shape 8"/>
+          <p:cNvSpPr/>
+          <p:nvPr/>
+        </p:nvSpPr>
+        <p:spPr>
+          <a:xfrm>
+            <a:off x="594360" y="2871216"/>
+            <a:ext cx="1078992" cy="987552"/>
+          </a:xfrm>
+          <a:prstGeom prst="rect">
+            <a:avLst/>
+          </a:prstGeom>
+          <a:solidFill>
+            <a:srgbClr val="E7F1F0"/>
+          </a:solidFill>
+          <a:ln w="6350">
+            <a:solidFill>
+              <a:srgbClr val="E7F1F0">
+                <a:alpha val="0"/>
+              </a:srgbClr>
+            </a:solidFill>
+            <a:prstDash val="solid"/>
+          </a:ln>
+        </p:spPr>
+      </p:sp>
+      <p:sp>
+        <p:nvSpPr>
+          <p:cNvPr id="11" name="Text 9"/>
+          <p:cNvSpPr txBox="1"/>
+          <p:nvPr/>
+        </p:nvSpPr>
+        <p:spPr>
+          <a:xfrm>
+            <a:off x="758952" y="3054096"/>
+            <a:ext cx="749808" cy="219456"/>
+          </a:xfrm>
+          <a:prstGeom prst="rect">
+            <a:avLst/>
+          </a:prstGeom>
+          <a:noFill/>
+          <a:ln/>
+        </p:spPr>
+        <p:txBody>
+          <a:bodyPr wrap="square" lIns="0" tIns="0" rIns="0" bIns="0" rtlCol="0" anchor="ctr"/>
+          <a:lstStyle/>
+          <a:p>
+            <a:pPr algn="l" indent="0" marL="0">
+              <a:buNone/>
+            </a:pPr>
+            <a:r>
+              <a:rPr lang="zh-CN" altLang="en-US" sz="850" b="1" spc="115" kern="0" dirty="0">
+                <a:solidFill>
+                  <a:srgbClr val="155E63"/>
+                </a:solidFill>
+                <a:latin typeface="PingFang SC" pitchFamily="34" charset="0"/>
+                <a:ea typeface="PingFang SC" pitchFamily="34" charset="-122"/>
+                <a:cs typeface="PingFang SC" pitchFamily="34" charset="-120"/>
+              </a:rPr>
+              <a:t>OD</a:t>
+            </a:r>
+            <a:endParaRPr lang="zh-CN" sz="850" dirty="0"/>
+          </a:p>
+        </p:txBody>
+      </p:sp>
+      <p:sp>
+        <p:nvSpPr>
+          <p:cNvPr id="12" name="Text 10"/>
+          <p:cNvSpPr txBox="1"/>
+          <p:nvPr/>
+        </p:nvSpPr>
+        <p:spPr>
+          <a:xfrm>
+            <a:off x="758952" y="3355848"/>
+            <a:ext cx="749808" cy="274320"/>
+          </a:xfrm>
+          <a:prstGeom prst="rect">
+            <a:avLst/>
+          </a:prstGeom>
+          <a:noFill/>
+          <a:ln/>
+        </p:spPr>
+        <p:txBody>
+          <a:bodyPr wrap="square" lIns="0" tIns="0" rIns="0" bIns="0" rtlCol="0" anchor="t">
+            <a:normAutofit/>
+          </a:bodyPr>
+          <a:lstStyle/>
+          <a:p>
+            <a:pPr algn="l" indent="0" marL="0">
+              <a:buNone/>
+            </a:pPr>
+            <a:r>
+              <a:rPr lang="zh-CN" altLang="en-US" sz="1130" b="1" dirty="0">
+                <a:solidFill>
+                  <a:srgbClr val="155E63"/>
+                </a:solidFill>
+                <a:latin typeface="PingFang SC" pitchFamily="34" charset="0"/>
+                <a:ea typeface="PingFang SC" pitchFamily="34" charset="-122"/>
+                <a:cs typeface="PingFang SC" pitchFamily="34" charset="-120"/>
+              </a:rPr>
+              <a:t>组织发展</a:t>
+            </a:r>
+            <a:endParaRPr lang="zh-CN" sz="1130" dirty="0"/>
+          </a:p>
+        </p:txBody>
+      </p:sp>
+      <p:sp>
+        <p:nvSpPr>
+          <p:cNvPr id="13" name="Shape 11"/>
+          <p:cNvSpPr/>
+          <p:nvPr/>
+        </p:nvSpPr>
+        <p:spPr>
+          <a:xfrm>
+            <a:off x="594360" y="3950208"/>
+            <a:ext cx="1078992" cy="1170432"/>
+          </a:xfrm>
+          <a:prstGeom prst="rect">
+            <a:avLst/>
+          </a:prstGeom>
+          <a:solidFill>
+            <a:srgbClr val="EEF3E8"/>
+          </a:solidFill>
+          <a:ln w="6350">
+            <a:solidFill>
+              <a:srgbClr val="EEF3E8">
+                <a:alpha val="0"/>
+              </a:srgbClr>
+            </a:solidFill>
+            <a:prstDash val="solid"/>
+          </a:ln>
+        </p:spPr>
+      </p:sp>
+      <p:sp>
+        <p:nvSpPr>
+          <p:cNvPr id="14" name="Text 12"/>
+          <p:cNvSpPr txBox="1"/>
+          <p:nvPr/>
+        </p:nvSpPr>
+        <p:spPr>
+          <a:xfrm>
+            <a:off x="758952" y="4133088"/>
+            <a:ext cx="749808" cy="219456"/>
+          </a:xfrm>
+          <a:prstGeom prst="rect">
+            <a:avLst/>
+          </a:prstGeom>
+          <a:noFill/>
+          <a:ln/>
+        </p:spPr>
+        <p:txBody>
+          <a:bodyPr wrap="square" lIns="0" tIns="0" rIns="0" bIns="0" rtlCol="0" anchor="ctr"/>
+          <a:lstStyle/>
+          <a:p>
+            <a:pPr algn="l" indent="0" marL="0">
+              <a:buNone/>
+            </a:pPr>
+            <a:r>
+              <a:rPr lang="zh-CN" altLang="en-US" sz="850" b="1" spc="115" kern="0" dirty="0">
+                <a:solidFill>
+                  <a:srgbClr val="44652B"/>
+                </a:solidFill>
+                <a:latin typeface="PingFang SC" pitchFamily="34" charset="0"/>
+                <a:ea typeface="PingFang SC" pitchFamily="34" charset="-122"/>
+                <a:cs typeface="PingFang SC" pitchFamily="34" charset="-120"/>
+              </a:rPr>
+              <a:t>TD</a:t>
+            </a:r>
+            <a:endParaRPr lang="zh-CN" sz="850" dirty="0"/>
+          </a:p>
+        </p:txBody>
+      </p:sp>
+      <p:sp>
+        <p:nvSpPr>
+          <p:cNvPr id="15" name="Text 13"/>
+          <p:cNvSpPr txBox="1"/>
+          <p:nvPr/>
+        </p:nvSpPr>
+        <p:spPr>
+          <a:xfrm>
+            <a:off x="758952" y="4434840"/>
+            <a:ext cx="749808" cy="274320"/>
+          </a:xfrm>
+          <a:prstGeom prst="rect">
+            <a:avLst/>
+          </a:prstGeom>
+          <a:noFill/>
+          <a:ln/>
+        </p:spPr>
+        <p:txBody>
+          <a:bodyPr wrap="square" lIns="0" tIns="0" rIns="0" bIns="0" rtlCol="0" anchor="t">
+            <a:normAutofit/>
+          </a:bodyPr>
+          <a:lstStyle/>
+          <a:p>
+            <a:pPr algn="l" indent="0" marL="0">
+              <a:buNone/>
+            </a:pPr>
+            <a:r>
+              <a:rPr lang="zh-CN" altLang="en-US" sz="1130" b="1" dirty="0">
+                <a:solidFill>
+                  <a:srgbClr val="44652B"/>
+                </a:solidFill>
+                <a:latin typeface="PingFang SC" pitchFamily="34" charset="0"/>
+                <a:ea typeface="PingFang SC" pitchFamily="34" charset="-122"/>
+                <a:cs typeface="PingFang SC" pitchFamily="34" charset="-120"/>
+              </a:rPr>
+              <a:t>人才发展</a:t>
+            </a:r>
+            <a:endParaRPr lang="zh-CN" sz="1130" dirty="0"/>
+          </a:p>
+        </p:txBody>
+      </p:sp>
+      <p:sp>
+        <p:nvSpPr>
+          <p:cNvPr id="16" name="Shape 14"/>
+          <p:cNvSpPr/>
+          <p:nvPr/>
+        </p:nvSpPr>
+        <p:spPr>
+          <a:xfrm>
+            <a:off x="594360" y="5212080"/>
+            <a:ext cx="1078992" cy="987552"/>
+          </a:xfrm>
+          <a:prstGeom prst="rect">
+            <a:avLst/>
+          </a:prstGeom>
+          <a:solidFill>
+            <a:srgbClr val="F6ECE4"/>
+          </a:solidFill>
+          <a:ln w="6350">
+            <a:solidFill>
+              <a:srgbClr val="F6ECE4">
+                <a:alpha val="0"/>
+              </a:srgbClr>
+            </a:solidFill>
+            <a:prstDash val="solid"/>
+          </a:ln>
+        </p:spPr>
+      </p:sp>
+      <p:sp>
+        <p:nvSpPr>
+          <p:cNvPr id="17" name="Text 15"/>
+          <p:cNvSpPr txBox="1"/>
+          <p:nvPr/>
+        </p:nvSpPr>
+        <p:spPr>
+          <a:xfrm>
+            <a:off x="758952" y="5394960"/>
+            <a:ext cx="749808" cy="219456"/>
+          </a:xfrm>
+          <a:prstGeom prst="rect">
+            <a:avLst/>
+          </a:prstGeom>
+          <a:noFill/>
+          <a:ln/>
+        </p:spPr>
+        <p:txBody>
+          <a:bodyPr wrap="square" lIns="0" tIns="0" rIns="0" bIns="0" rtlCol="0" anchor="ctr"/>
+          <a:lstStyle/>
+          <a:p>
+            <a:pPr algn="l" indent="0" marL="0">
+              <a:buNone/>
+            </a:pPr>
+            <a:r>
+              <a:rPr lang="zh-CN" altLang="en-US" sz="850" b="1" spc="115" kern="0" dirty="0">
+                <a:solidFill>
+                  <a:srgbClr val="8B4A20"/>
+                </a:solidFill>
+                <a:latin typeface="PingFang SC" pitchFamily="34" charset="0"/>
+                <a:ea typeface="PingFang SC" pitchFamily="34" charset="-122"/>
+                <a:cs typeface="PingFang SC" pitchFamily="34" charset="-120"/>
+              </a:rPr>
+              <a:t>LD</a:t>
+            </a:r>
+            <a:endParaRPr lang="zh-CN" sz="850" dirty="0"/>
+          </a:p>
+        </p:txBody>
+      </p:sp>
+      <p:sp>
+        <p:nvSpPr>
+          <p:cNvPr id="18" name="Text 16"/>
+          <p:cNvSpPr txBox="1"/>
+          <p:nvPr/>
+        </p:nvSpPr>
+        <p:spPr>
+          <a:xfrm>
+            <a:off x="758952" y="5696712"/>
+            <a:ext cx="749808" cy="274320"/>
+          </a:xfrm>
+          <a:prstGeom prst="rect">
+            <a:avLst/>
+          </a:prstGeom>
+          <a:noFill/>
+          <a:ln/>
+        </p:spPr>
+        <p:txBody>
+          <a:bodyPr wrap="square" lIns="0" tIns="0" rIns="0" bIns="0" rtlCol="0" anchor="t">
+            <a:normAutofit/>
+          </a:bodyPr>
+          <a:lstStyle/>
+          <a:p>
+            <a:pPr algn="l" indent="0" marL="0">
+              <a:buNone/>
+            </a:pPr>
+            <a:r>
+              <a:rPr lang="zh-CN" altLang="en-US" sz="1130" b="1" dirty="0">
+                <a:solidFill>
+                  <a:srgbClr val="8B4A20"/>
+                </a:solidFill>
+                <a:latin typeface="PingFang SC" pitchFamily="34" charset="0"/>
+                <a:ea typeface="PingFang SC" pitchFamily="34" charset="-122"/>
+                <a:cs typeface="PingFang SC" pitchFamily="34" charset="-120"/>
+              </a:rPr>
+              <a:t>学习发展</a:t>
+            </a:r>
+            <a:endParaRPr lang="zh-CN" sz="1130" dirty="0"/>
+          </a:p>
+        </p:txBody>
+      </p:sp>
+      <p:sp>
+        <p:nvSpPr>
+          <p:cNvPr id="19" name="Shape 17"/>
+          <p:cNvSpPr/>
+          <p:nvPr/>
+        </p:nvSpPr>
+        <p:spPr>
+          <a:xfrm>
+            <a:off x="1874520" y="1792224"/>
+            <a:ext cx="9720072" cy="987552"/>
+          </a:xfrm>
+          <a:prstGeom prst="rect">
+            <a:avLst/>
+          </a:prstGeom>
+          <a:solidFill>
+            <a:srgbClr val="FFFFFF"/>
+          </a:solidFill>
+          <a:ln w="8255">
+            <a:solidFill>
+              <a:srgbClr val="D4D4D2"/>
+            </a:solidFill>
+            <a:prstDash val="solid"/>
+          </a:ln>
+        </p:spPr>
+      </p:sp>
+      <p:sp>
+        <p:nvSpPr>
+          <p:cNvPr id="20" name="Text 18"/>
+          <p:cNvSpPr txBox="1"/>
+          <p:nvPr/>
+        </p:nvSpPr>
+        <p:spPr>
+          <a:xfrm>
+            <a:off x="2103120" y="1993392"/>
+            <a:ext cx="347472" cy="219456"/>
+          </a:xfrm>
+          <a:prstGeom prst="rect">
+            <a:avLst/>
+          </a:prstGeom>
+          <a:noFill/>
+          <a:ln/>
+        </p:spPr>
+        <p:txBody>
+          <a:bodyPr wrap="square" lIns="0" tIns="0" rIns="0" bIns="0" rtlCol="0" anchor="ctr"/>
+          <a:lstStyle/>
+          <a:p>
+            <a:pPr algn="l" indent="0" marL="0">
+              <a:buNone/>
+            </a:pPr>
+            <a:r>
+              <a:rPr lang="zh-CN" altLang="en-US" sz="850" b="1" spc="115" kern="0" dirty="0">
+                <a:solidFill>
+                  <a:srgbClr val="002FA7"/>
+                </a:solidFill>
+                <a:latin typeface="PingFang SC" pitchFamily="34" charset="0"/>
+                <a:ea typeface="PingFang SC" pitchFamily="34" charset="-122"/>
+                <a:cs typeface="PingFang SC" pitchFamily="34" charset="-120"/>
+              </a:rPr>
+              <a:t>01</a:t>
+            </a:r>
+            <a:endParaRPr lang="zh-CN" sz="850" dirty="0"/>
+          </a:p>
+        </p:txBody>
+      </p:sp>
+      <p:sp>
+        <p:nvSpPr>
+          <p:cNvPr id="21" name="Text 19"/>
+          <p:cNvSpPr txBox="1"/>
+          <p:nvPr/>
+        </p:nvSpPr>
+        <p:spPr>
+          <a:xfrm>
+            <a:off x="2542032" y="1929384"/>
+            <a:ext cx="1234440" cy="274320"/>
+          </a:xfrm>
+          <a:prstGeom prst="rect">
+            <a:avLst/>
+          </a:prstGeom>
+          <a:noFill/>
+          <a:ln/>
+        </p:spPr>
+        <p:txBody>
+          <a:bodyPr wrap="square" lIns="0" tIns="0" rIns="0" bIns="0" rtlCol="0" anchor="t">
+            <a:normAutofit/>
+          </a:bodyPr>
+          <a:lstStyle/>
+          <a:p>
+            <a:pPr algn="l" indent="0" marL="0">
+              <a:buNone/>
+            </a:pPr>
+            <a:r>
+              <a:rPr lang="zh-CN" altLang="en-US" sz="1320" b="1" dirty="0">
+                <a:solidFill>
+                  <a:srgbClr val="0A0A0A"/>
+                </a:solidFill>
+                <a:latin typeface="PingFang SC" pitchFamily="34" charset="0"/>
+                <a:ea typeface="PingFang SC" pitchFamily="34" charset="-122"/>
+                <a:cs typeface="PingFang SC" pitchFamily="34" charset="-120"/>
+              </a:rPr>
+              <a:t>业务盘点</a:t>
+            </a:r>
+            <a:endParaRPr lang="zh-CN" sz="1320" dirty="0"/>
+          </a:p>
+        </p:txBody>
+      </p:sp>
+      <p:sp>
+        <p:nvSpPr>
+          <p:cNvPr id="22" name="Text 20"/>
+          <p:cNvSpPr txBox="1"/>
+          <p:nvPr/>
+        </p:nvSpPr>
+        <p:spPr>
+          <a:xfrm>
+            <a:off x="3749040" y="1947672"/>
+            <a:ext cx="1143000" cy="237744"/>
+          </a:xfrm>
+          <a:prstGeom prst="rect">
+            <a:avLst/>
+          </a:prstGeom>
+          <a:noFill/>
+          <a:ln/>
+        </p:spPr>
+        <p:txBody>
+          <a:bodyPr wrap="square" lIns="0" tIns="0" rIns="0" bIns="0" rtlCol="0" anchor="t">
+            <a:normAutofit/>
+          </a:bodyPr>
+          <a:lstStyle/>
+          <a:p>
+            <a:pPr algn="l" indent="0" marL="0">
+              <a:buNone/>
+            </a:pPr>
+            <a:r>
+              <a:rPr lang="zh-CN" altLang="en-US" sz="1020" dirty="0">
+                <a:solidFill>
+                  <a:srgbClr val="737373"/>
+                </a:solidFill>
+                <a:latin typeface="PingFang SC" pitchFamily="34" charset="0"/>
+                <a:ea typeface="PingFang SC" pitchFamily="34" charset="-122"/>
+                <a:cs typeface="PingFang SC" pitchFamily="34" charset="-120"/>
+              </a:rPr>
+              <a:t>看清现状</a:t>
+            </a:r>
+            <a:endParaRPr lang="zh-CN" sz="1020" dirty="0"/>
+          </a:p>
+        </p:txBody>
+      </p:sp>
+      <p:sp>
+        <p:nvSpPr>
+          <p:cNvPr id="23" name="Shape 21"/>
+          <p:cNvSpPr/>
+          <p:nvPr/>
+        </p:nvSpPr>
+        <p:spPr>
+          <a:xfrm>
+            <a:off x="4873752" y="2267712"/>
+            <a:ext cx="283464" cy="0"/>
+          </a:xfrm>
+          <a:prstGeom prst="line">
+            <a:avLst/>
+          </a:prstGeom>
+          <a:noFill/>
+          <a:ln w="11430">
+            <a:solidFill>
+              <a:srgbClr val="002FA7"/>
+            </a:solidFill>
+            <a:prstDash val="solid"/>
+            <a:tailEnd type="triangle"/>
+          </a:ln>
+        </p:spPr>
+      </p:sp>
+      <p:sp>
+        <p:nvSpPr>
+          <p:cNvPr id="24" name="Text 22"/>
+          <p:cNvSpPr txBox="1"/>
+          <p:nvPr/>
+        </p:nvSpPr>
+        <p:spPr>
+          <a:xfrm>
+            <a:off x="5257800" y="1993392"/>
+            <a:ext cx="347472" cy="219456"/>
+          </a:xfrm>
+          <a:prstGeom prst="rect">
+            <a:avLst/>
+          </a:prstGeom>
+          <a:noFill/>
+          <a:ln/>
+        </p:spPr>
+        <p:txBody>
+          <a:bodyPr wrap="square" lIns="0" tIns="0" rIns="0" bIns="0" rtlCol="0" anchor="ctr"/>
+          <a:lstStyle/>
+          <a:p>
+            <a:pPr algn="l" indent="0" marL="0">
+              <a:buNone/>
+            </a:pPr>
+            <a:r>
+              <a:rPr lang="zh-CN" altLang="en-US" sz="850" b="1" spc="115" kern="0" dirty="0">
+                <a:solidFill>
+                  <a:srgbClr val="002FA7"/>
+                </a:solidFill>
+                <a:latin typeface="PingFang SC" pitchFamily="34" charset="0"/>
+                <a:ea typeface="PingFang SC" pitchFamily="34" charset="-122"/>
+                <a:cs typeface="PingFang SC" pitchFamily="34" charset="-120"/>
+              </a:rPr>
+              <a:t>02</a:t>
+            </a:r>
+            <a:endParaRPr lang="zh-CN" sz="850" dirty="0"/>
+          </a:p>
+        </p:txBody>
+      </p:sp>
+      <p:sp>
+        <p:nvSpPr>
+          <p:cNvPr id="25" name="Text 23"/>
+          <p:cNvSpPr txBox="1"/>
+          <p:nvPr/>
+        </p:nvSpPr>
+        <p:spPr>
+          <a:xfrm>
+            <a:off x="5696712" y="1929384"/>
+            <a:ext cx="1234440" cy="274320"/>
+          </a:xfrm>
+          <a:prstGeom prst="rect">
+            <a:avLst/>
+          </a:prstGeom>
+          <a:noFill/>
+          <a:ln/>
+        </p:spPr>
+        <p:txBody>
+          <a:bodyPr wrap="square" lIns="0" tIns="0" rIns="0" bIns="0" rtlCol="0" anchor="t">
+            <a:normAutofit/>
+          </a:bodyPr>
+          <a:lstStyle/>
+          <a:p>
+            <a:pPr algn="l" indent="0" marL="0">
+              <a:buNone/>
+            </a:pPr>
+            <a:r>
+              <a:rPr lang="zh-CN" altLang="en-US" sz="1320" b="1" dirty="0">
+                <a:solidFill>
+                  <a:srgbClr val="0A0A0A"/>
+                </a:solidFill>
+                <a:latin typeface="PingFang SC" pitchFamily="34" charset="0"/>
+                <a:ea typeface="PingFang SC" pitchFamily="34" charset="-122"/>
+                <a:cs typeface="PingFang SC" pitchFamily="34" charset="-120"/>
+              </a:rPr>
+              <a:t>战略规划</a:t>
+            </a:r>
+            <a:endParaRPr lang="zh-CN" sz="1320" dirty="0"/>
+          </a:p>
+        </p:txBody>
+      </p:sp>
+      <p:sp>
+        <p:nvSpPr>
+          <p:cNvPr id="26" name="Text 24"/>
+          <p:cNvSpPr txBox="1"/>
+          <p:nvPr/>
+        </p:nvSpPr>
+        <p:spPr>
+          <a:xfrm>
+            <a:off x="6903720" y="1947672"/>
+            <a:ext cx="1143000" cy="237744"/>
+          </a:xfrm>
+          <a:prstGeom prst="rect">
+            <a:avLst/>
+          </a:prstGeom>
+          <a:noFill/>
+          <a:ln/>
+        </p:spPr>
+        <p:txBody>
+          <a:bodyPr wrap="square" lIns="0" tIns="0" rIns="0" bIns="0" rtlCol="0" anchor="t">
+            <a:normAutofit/>
+          </a:bodyPr>
+          <a:lstStyle/>
+          <a:p>
+            <a:pPr algn="l" indent="0" marL="0">
+              <a:buNone/>
+            </a:pPr>
+            <a:r>
+              <a:rPr lang="zh-CN" altLang="en-US" sz="1020" dirty="0">
+                <a:solidFill>
+                  <a:srgbClr val="737373"/>
+                </a:solidFill>
+                <a:latin typeface="PingFang SC" pitchFamily="34" charset="0"/>
+                <a:ea typeface="PingFang SC" pitchFamily="34" charset="-122"/>
+                <a:cs typeface="PingFang SC" pitchFamily="34" charset="-120"/>
+              </a:rPr>
+              <a:t>明确方向</a:t>
+            </a:r>
+            <a:endParaRPr lang="zh-CN" sz="1020" dirty="0"/>
+          </a:p>
+        </p:txBody>
+      </p:sp>
+      <p:sp>
+        <p:nvSpPr>
+          <p:cNvPr id="27" name="Shape 25"/>
+          <p:cNvSpPr/>
+          <p:nvPr/>
+        </p:nvSpPr>
+        <p:spPr>
+          <a:xfrm>
+            <a:off x="8028432" y="2267712"/>
+            <a:ext cx="283464" cy="0"/>
+          </a:xfrm>
+          <a:prstGeom prst="line">
+            <a:avLst/>
+          </a:prstGeom>
+          <a:noFill/>
+          <a:ln w="11430">
+            <a:solidFill>
+              <a:srgbClr val="002FA7"/>
+            </a:solidFill>
+            <a:prstDash val="solid"/>
+            <a:tailEnd type="triangle"/>
+          </a:ln>
+        </p:spPr>
+      </p:sp>
+      <p:sp>
+        <p:nvSpPr>
+          <p:cNvPr id="28" name="Text 26"/>
+          <p:cNvSpPr txBox="1"/>
+          <p:nvPr/>
+        </p:nvSpPr>
+        <p:spPr>
+          <a:xfrm>
+            <a:off x="8412480" y="1993392"/>
+            <a:ext cx="347472" cy="219456"/>
+          </a:xfrm>
+          <a:prstGeom prst="rect">
+            <a:avLst/>
+          </a:prstGeom>
+          <a:noFill/>
+          <a:ln/>
+        </p:spPr>
+        <p:txBody>
+          <a:bodyPr wrap="square" lIns="0" tIns="0" rIns="0" bIns="0" rtlCol="0" anchor="ctr"/>
+          <a:lstStyle/>
+          <a:p>
+            <a:pPr algn="l" indent="0" marL="0">
+              <a:buNone/>
+            </a:pPr>
+            <a:r>
+              <a:rPr lang="zh-CN" altLang="en-US" sz="850" b="1" spc="115" kern="0" dirty="0">
+                <a:solidFill>
+                  <a:srgbClr val="002FA7"/>
+                </a:solidFill>
+                <a:latin typeface="PingFang SC" pitchFamily="34" charset="0"/>
+                <a:ea typeface="PingFang SC" pitchFamily="34" charset="-122"/>
+                <a:cs typeface="PingFang SC" pitchFamily="34" charset="-120"/>
+              </a:rPr>
+              <a:t>03</a:t>
+            </a:r>
+            <a:endParaRPr lang="zh-CN" sz="850" dirty="0"/>
+          </a:p>
+        </p:txBody>
+      </p:sp>
+      <p:sp>
+        <p:nvSpPr>
+          <p:cNvPr id="29" name="Text 27"/>
+          <p:cNvSpPr txBox="1"/>
+          <p:nvPr/>
+        </p:nvSpPr>
+        <p:spPr>
+          <a:xfrm>
+            <a:off x="8851392" y="1929384"/>
+            <a:ext cx="1234440" cy="274320"/>
+          </a:xfrm>
+          <a:prstGeom prst="rect">
+            <a:avLst/>
+          </a:prstGeom>
+          <a:noFill/>
+          <a:ln/>
+        </p:spPr>
+        <p:txBody>
+          <a:bodyPr wrap="square" lIns="0" tIns="0" rIns="0" bIns="0" rtlCol="0" anchor="t">
+            <a:normAutofit/>
+          </a:bodyPr>
+          <a:lstStyle/>
+          <a:p>
+            <a:pPr algn="l" indent="0" marL="0">
+              <a:buNone/>
+            </a:pPr>
+            <a:r>
+              <a:rPr lang="zh-CN" altLang="en-US" sz="1320" b="1" dirty="0">
+                <a:solidFill>
+                  <a:srgbClr val="0A0A0A"/>
+                </a:solidFill>
+                <a:latin typeface="PingFang SC" pitchFamily="34" charset="0"/>
+                <a:ea typeface="PingFang SC" pitchFamily="34" charset="-122"/>
+                <a:cs typeface="PingFang SC" pitchFamily="34" charset="-120"/>
+              </a:rPr>
+              <a:t>战略解码</a:t>
+            </a:r>
+            <a:endParaRPr lang="zh-CN" sz="1320" dirty="0"/>
+          </a:p>
+        </p:txBody>
+      </p:sp>
+      <p:sp>
+        <p:nvSpPr>
+          <p:cNvPr id="30" name="Text 28"/>
+          <p:cNvSpPr txBox="1"/>
+          <p:nvPr/>
+        </p:nvSpPr>
+        <p:spPr>
+          <a:xfrm>
+            <a:off x="10058400" y="1947672"/>
+            <a:ext cx="1143000" cy="237744"/>
+          </a:xfrm>
+          <a:prstGeom prst="rect">
+            <a:avLst/>
+          </a:prstGeom>
+          <a:noFill/>
+          <a:ln/>
+        </p:spPr>
+        <p:txBody>
+          <a:bodyPr wrap="square" lIns="0" tIns="0" rIns="0" bIns="0" rtlCol="0" anchor="t">
+            <a:normAutofit/>
+          </a:bodyPr>
+          <a:lstStyle/>
+          <a:p>
+            <a:pPr algn="l" indent="0" marL="0">
+              <a:buNone/>
+            </a:pPr>
+            <a:r>
+              <a:rPr lang="zh-CN" altLang="en-US" sz="1020" dirty="0">
+                <a:solidFill>
+                  <a:srgbClr val="737373"/>
+                </a:solidFill>
+                <a:latin typeface="PingFang SC" pitchFamily="34" charset="0"/>
+                <a:ea typeface="PingFang SC" pitchFamily="34" charset="-122"/>
+                <a:cs typeface="PingFang SC" pitchFamily="34" charset="-120"/>
+              </a:rPr>
+              <a:t>转为组织任务</a:t>
+            </a:r>
+            <a:endParaRPr lang="zh-CN" sz="1020" dirty="0"/>
+          </a:p>
+        </p:txBody>
+      </p:sp>
+      <p:sp>
+        <p:nvSpPr>
+          <p:cNvPr id="31" name="Shape 29"/>
+          <p:cNvSpPr/>
+          <p:nvPr/>
+        </p:nvSpPr>
+        <p:spPr>
+          <a:xfrm>
+            <a:off x="2103120" y="2395728"/>
+            <a:ext cx="9262872" cy="201168"/>
+          </a:xfrm>
+          <a:prstGeom prst="rect">
+            <a:avLst/>
+          </a:prstGeom>
+          <a:solidFill>
+            <a:srgbClr val="E8EDFF"/>
+          </a:solidFill>
+          <a:ln w="6350">
+            <a:solidFill>
+              <a:srgbClr val="E8EDFF">
+                <a:alpha val="0"/>
+              </a:srgbClr>
+            </a:solidFill>
+            <a:prstDash val="solid"/>
+          </a:ln>
+        </p:spPr>
+      </p:sp>
+      <p:sp>
+        <p:nvSpPr>
+          <p:cNvPr id="32" name="Text 30"/>
+          <p:cNvSpPr txBox="1"/>
+          <p:nvPr/>
+        </p:nvSpPr>
+        <p:spPr>
+          <a:xfrm>
+            <a:off x="2258568" y="2423160"/>
+            <a:ext cx="8951976" cy="219456"/>
+          </a:xfrm>
+          <a:prstGeom prst="rect">
+            <a:avLst/>
+          </a:prstGeom>
+          <a:noFill/>
+          <a:ln/>
+        </p:spPr>
+        <p:txBody>
+          <a:bodyPr wrap="square" lIns="0" tIns="0" rIns="0" bIns="0" rtlCol="0" anchor="ctr"/>
+          <a:lstStyle/>
+          <a:p>
+            <a:pPr algn="ctr" indent="0" marL="0">
+              <a:buNone/>
+            </a:pPr>
+            <a:r>
+              <a:rPr lang="zh-CN" altLang="en-US" sz="850" b="1" spc="115" kern="0" dirty="0">
+                <a:solidFill>
+                  <a:srgbClr val="002FA7"/>
+                </a:solidFill>
+                <a:latin typeface="PingFang SC" pitchFamily="34" charset="0"/>
+                <a:ea typeface="PingFang SC" pitchFamily="34" charset="-122"/>
+                <a:cs typeface="PingFang SC" pitchFamily="34" charset="-120"/>
+              </a:rPr>
+              <a:t>业务方向向下解码，组织与人才发展反向支撑业务结果</a:t>
+            </a:r>
+            <a:endParaRPr lang="zh-CN" sz="850" dirty="0"/>
+          </a:p>
+        </p:txBody>
+      </p:sp>
+      <p:sp>
+        <p:nvSpPr>
+          <p:cNvPr id="33" name="Shape 31"/>
+          <p:cNvSpPr/>
+          <p:nvPr/>
+        </p:nvSpPr>
+        <p:spPr>
+          <a:xfrm>
+            <a:off x="1874520" y="2871216"/>
+            <a:ext cx="3154680" cy="987552"/>
+          </a:xfrm>
+          <a:prstGeom prst="rect">
+            <a:avLst/>
+          </a:prstGeom>
+          <a:solidFill>
+            <a:srgbClr val="FFFFFF"/>
+          </a:solidFill>
+          <a:ln w="8255">
+            <a:solidFill>
+              <a:srgbClr val="D4D4D2"/>
+            </a:solidFill>
+            <a:prstDash val="solid"/>
+          </a:ln>
+        </p:spPr>
+      </p:sp>
+      <p:sp>
+        <p:nvSpPr>
+          <p:cNvPr id="34" name="Text 32"/>
+          <p:cNvSpPr txBox="1"/>
+          <p:nvPr/>
+        </p:nvSpPr>
+        <p:spPr>
+          <a:xfrm>
+            <a:off x="2075688" y="3127248"/>
+            <a:ext cx="2752344" cy="256032"/>
+          </a:xfrm>
+          <a:prstGeom prst="rect">
+            <a:avLst/>
+          </a:prstGeom>
+          <a:noFill/>
+          <a:ln/>
+        </p:spPr>
+        <p:txBody>
+          <a:bodyPr wrap="square" lIns="0" tIns="0" rIns="0" bIns="0" rtlCol="0" anchor="t">
+            <a:normAutofit/>
+          </a:bodyPr>
+          <a:lstStyle/>
+          <a:p>
+            <a:pPr algn="ctr" indent="0" marL="0">
+              <a:buNone/>
+            </a:pPr>
+            <a:r>
+              <a:rPr lang="zh-CN" altLang="en-US" sz="1320" b="1" dirty="0">
+                <a:solidFill>
+                  <a:srgbClr val="0A0A0A"/>
+                </a:solidFill>
+                <a:latin typeface="PingFang SC" pitchFamily="34" charset="0"/>
+                <a:ea typeface="PingFang SC" pitchFamily="34" charset="-122"/>
+                <a:cs typeface="PingFang SC" pitchFamily="34" charset="-120"/>
+              </a:rPr>
+              <a:t>组织结构与机制</a:t>
+            </a:r>
+            <a:endParaRPr lang="zh-CN" sz="1320" dirty="0"/>
+          </a:p>
+        </p:txBody>
+      </p:sp>
+      <p:sp>
+        <p:nvSpPr>
+          <p:cNvPr id="35" name="Text 33"/>
+          <p:cNvSpPr txBox="1"/>
+          <p:nvPr/>
+        </p:nvSpPr>
+        <p:spPr>
+          <a:xfrm>
+            <a:off x="2075688" y="3465576"/>
+            <a:ext cx="2752344" cy="219456"/>
+          </a:xfrm>
+          <a:prstGeom prst="rect">
+            <a:avLst/>
+          </a:prstGeom>
+          <a:noFill/>
+          <a:ln/>
+        </p:spPr>
+        <p:txBody>
+          <a:bodyPr wrap="square" lIns="0" tIns="0" rIns="0" bIns="0" rtlCol="0" anchor="ctr"/>
+          <a:lstStyle/>
+          <a:p>
+            <a:pPr algn="ctr" indent="0" marL="0">
+              <a:buNone/>
+            </a:pPr>
+            <a:r>
+              <a:rPr lang="zh-CN" altLang="en-US" sz="850" b="1" spc="115" kern="0" dirty="0">
+                <a:solidFill>
+                  <a:srgbClr val="737373"/>
+                </a:solidFill>
+                <a:latin typeface="PingFang SC" pitchFamily="34" charset="0"/>
+                <a:ea typeface="PingFang SC" pitchFamily="34" charset="-122"/>
+                <a:cs typeface="PingFang SC" pitchFamily="34" charset="-120"/>
+              </a:rPr>
+              <a:t>STRUCTURE</a:t>
+            </a:r>
+            <a:endParaRPr lang="zh-CN" sz="850" dirty="0"/>
+          </a:p>
+        </p:txBody>
+      </p:sp>
+      <p:sp>
+        <p:nvSpPr>
+          <p:cNvPr id="36" name="Shape 34"/>
+          <p:cNvSpPr/>
+          <p:nvPr/>
+        </p:nvSpPr>
+        <p:spPr>
+          <a:xfrm>
+            <a:off x="5148072" y="2871216"/>
+            <a:ext cx="3154680" cy="987552"/>
+          </a:xfrm>
+          <a:prstGeom prst="rect">
+            <a:avLst/>
+          </a:prstGeom>
+          <a:solidFill>
+            <a:srgbClr val="E8EDFF"/>
+          </a:solidFill>
+          <a:ln w="12700">
+            <a:solidFill>
+              <a:srgbClr val="002FA7"/>
+            </a:solidFill>
+            <a:prstDash val="solid"/>
+          </a:ln>
+        </p:spPr>
+      </p:sp>
+      <p:sp>
+        <p:nvSpPr>
+          <p:cNvPr id="37" name="Text 35"/>
+          <p:cNvSpPr txBox="1"/>
+          <p:nvPr/>
+        </p:nvSpPr>
+        <p:spPr>
+          <a:xfrm>
+            <a:off x="5349240" y="3127248"/>
+            <a:ext cx="2752344" cy="256032"/>
+          </a:xfrm>
+          <a:prstGeom prst="rect">
+            <a:avLst/>
+          </a:prstGeom>
+          <a:noFill/>
+          <a:ln/>
+        </p:spPr>
+        <p:txBody>
+          <a:bodyPr wrap="square" lIns="0" tIns="0" rIns="0" bIns="0" rtlCol="0" anchor="t">
+            <a:normAutofit/>
+          </a:bodyPr>
+          <a:lstStyle/>
+          <a:p>
+            <a:pPr algn="ctr" indent="0" marL="0">
+              <a:buNone/>
+            </a:pPr>
+            <a:r>
+              <a:rPr lang="zh-CN" altLang="en-US" sz="1320" b="1" dirty="0">
+                <a:solidFill>
+                  <a:srgbClr val="0A0A0A"/>
+                </a:solidFill>
+                <a:latin typeface="PingFang SC" pitchFamily="34" charset="0"/>
+                <a:ea typeface="PingFang SC" pitchFamily="34" charset="-122"/>
+                <a:cs typeface="PingFang SC" pitchFamily="34" charset="-120"/>
+              </a:rPr>
+              <a:t>目标与绩效</a:t>
+            </a:r>
+            <a:endParaRPr lang="zh-CN" sz="1320" dirty="0"/>
+          </a:p>
+        </p:txBody>
+      </p:sp>
+      <p:sp>
+        <p:nvSpPr>
+          <p:cNvPr id="38" name="Text 36"/>
+          <p:cNvSpPr txBox="1"/>
+          <p:nvPr/>
+        </p:nvSpPr>
+        <p:spPr>
+          <a:xfrm>
+            <a:off x="5349240" y="3465576"/>
+            <a:ext cx="2752344" cy="219456"/>
+          </a:xfrm>
+          <a:prstGeom prst="rect">
+            <a:avLst/>
+          </a:prstGeom>
+          <a:noFill/>
+          <a:ln/>
+        </p:spPr>
+        <p:txBody>
+          <a:bodyPr wrap="square" lIns="0" tIns="0" rIns="0" bIns="0" rtlCol="0" anchor="ctr"/>
+          <a:lstStyle/>
+          <a:p>
+            <a:pPr algn="ctr" indent="0" marL="0">
+              <a:buNone/>
+            </a:pPr>
+            <a:r>
+              <a:rPr lang="zh-CN" altLang="en-US" sz="850" b="1" spc="115" kern="0" dirty="0">
+                <a:solidFill>
+                  <a:srgbClr val="002FA7"/>
+                </a:solidFill>
+                <a:latin typeface="PingFang SC" pitchFamily="34" charset="0"/>
+                <a:ea typeface="PingFang SC" pitchFamily="34" charset="-122"/>
+                <a:cs typeface="PingFang SC" pitchFamily="34" charset="-120"/>
+              </a:rPr>
+              <a:t>OBJECT</a:t>
+            </a:r>
+            <a:endParaRPr lang="zh-CN" sz="850" dirty="0"/>
+          </a:p>
+        </p:txBody>
+      </p:sp>
+      <p:sp>
+        <p:nvSpPr>
+          <p:cNvPr id="39" name="Shape 37"/>
+          <p:cNvSpPr/>
+          <p:nvPr/>
+        </p:nvSpPr>
+        <p:spPr>
+          <a:xfrm>
+            <a:off x="8421624" y="2871216"/>
+            <a:ext cx="3154680" cy="987552"/>
+          </a:xfrm>
+          <a:prstGeom prst="rect">
+            <a:avLst/>
+          </a:prstGeom>
+          <a:solidFill>
+            <a:srgbClr val="FFFFFF"/>
+          </a:solidFill>
+          <a:ln w="8255">
+            <a:solidFill>
+              <a:srgbClr val="D4D4D2"/>
+            </a:solidFill>
+            <a:prstDash val="solid"/>
+          </a:ln>
+        </p:spPr>
+      </p:sp>
+      <p:sp>
+        <p:nvSpPr>
+          <p:cNvPr id="40" name="Text 38"/>
+          <p:cNvSpPr txBox="1"/>
+          <p:nvPr/>
+        </p:nvSpPr>
+        <p:spPr>
+          <a:xfrm>
+            <a:off x="8622792" y="3127248"/>
+            <a:ext cx="2752344" cy="256032"/>
+          </a:xfrm>
+          <a:prstGeom prst="rect">
+            <a:avLst/>
+          </a:prstGeom>
+          <a:noFill/>
+          <a:ln/>
+        </p:spPr>
+        <p:txBody>
+          <a:bodyPr wrap="square" lIns="0" tIns="0" rIns="0" bIns="0" rtlCol="0" anchor="t">
+            <a:normAutofit/>
+          </a:bodyPr>
+          <a:lstStyle/>
+          <a:p>
+            <a:pPr algn="ctr" indent="0" marL="0">
+              <a:buNone/>
+            </a:pPr>
+            <a:r>
+              <a:rPr lang="zh-CN" altLang="en-US" sz="1320" b="1" dirty="0">
+                <a:solidFill>
+                  <a:srgbClr val="0A0A0A"/>
+                </a:solidFill>
+                <a:latin typeface="PingFang SC" pitchFamily="34" charset="0"/>
+                <a:ea typeface="PingFang SC" pitchFamily="34" charset="-122"/>
+                <a:cs typeface="PingFang SC" pitchFamily="34" charset="-120"/>
+              </a:rPr>
+              <a:t>文化与氛围</a:t>
+            </a:r>
+            <a:endParaRPr lang="zh-CN" sz="1320" dirty="0"/>
+          </a:p>
+        </p:txBody>
+      </p:sp>
+      <p:sp>
+        <p:nvSpPr>
+          <p:cNvPr id="41" name="Text 39"/>
+          <p:cNvSpPr txBox="1"/>
+          <p:nvPr/>
+        </p:nvSpPr>
+        <p:spPr>
+          <a:xfrm>
+            <a:off x="8622792" y="3465576"/>
+            <a:ext cx="2752344" cy="219456"/>
+          </a:xfrm>
+          <a:prstGeom prst="rect">
+            <a:avLst/>
+          </a:prstGeom>
+          <a:noFill/>
+          <a:ln/>
+        </p:spPr>
+        <p:txBody>
+          <a:bodyPr wrap="square" lIns="0" tIns="0" rIns="0" bIns="0" rtlCol="0" anchor="ctr"/>
+          <a:lstStyle/>
+          <a:p>
+            <a:pPr algn="ctr" indent="0" marL="0">
+              <a:buNone/>
+            </a:pPr>
+            <a:r>
+              <a:rPr lang="zh-CN" altLang="en-US" sz="850" b="1" spc="115" kern="0" dirty="0">
+                <a:solidFill>
+                  <a:srgbClr val="737373"/>
+                </a:solidFill>
+                <a:latin typeface="PingFang SC" pitchFamily="34" charset="0"/>
+                <a:ea typeface="PingFang SC" pitchFamily="34" charset="-122"/>
+                <a:cs typeface="PingFang SC" pitchFamily="34" charset="-120"/>
+              </a:rPr>
+              <a:t>CULTURE</a:t>
+            </a:r>
+            <a:endParaRPr lang="zh-CN" sz="850" dirty="0"/>
+          </a:p>
+        </p:txBody>
+      </p:sp>
+      <p:sp>
+        <p:nvSpPr>
+          <p:cNvPr id="42" name="Shape 40"/>
+          <p:cNvSpPr/>
+          <p:nvPr/>
+        </p:nvSpPr>
+        <p:spPr>
+          <a:xfrm>
+            <a:off x="1874520" y="3950208"/>
+            <a:ext cx="3154680" cy="283464"/>
+          </a:xfrm>
+          <a:prstGeom prst="rect">
+            <a:avLst/>
+          </a:prstGeom>
+          <a:solidFill>
+            <a:srgbClr val="EEF3E8"/>
+          </a:solidFill>
+          <a:ln w="6350">
+            <a:solidFill>
+              <a:srgbClr val="EEF3E8">
+                <a:alpha val="0"/>
+              </a:srgbClr>
+            </a:solidFill>
+            <a:prstDash val="solid"/>
+          </a:ln>
+        </p:spPr>
+      </p:sp>
+      <p:sp>
+        <p:nvSpPr>
+          <p:cNvPr id="43" name="Text 41"/>
+          <p:cNvSpPr txBox="1"/>
+          <p:nvPr/>
+        </p:nvSpPr>
+        <p:spPr>
+          <a:xfrm>
+            <a:off x="2011680" y="4005072"/>
+            <a:ext cx="2880360" cy="219456"/>
+          </a:xfrm>
+          <a:prstGeom prst="rect">
+            <a:avLst/>
+          </a:prstGeom>
+          <a:noFill/>
+          <a:ln/>
+        </p:spPr>
+        <p:txBody>
+          <a:bodyPr wrap="square" lIns="0" tIns="0" rIns="0" bIns="0" rtlCol="0" anchor="ctr"/>
+          <a:lstStyle/>
+          <a:p>
+            <a:pPr algn="ctr" indent="0" marL="0">
+              <a:buNone/>
+            </a:pPr>
+            <a:r>
+              <a:rPr lang="zh-CN" altLang="en-US" sz="850" b="1" spc="115" kern="0" dirty="0">
+                <a:solidFill>
+                  <a:srgbClr val="44652B"/>
+                </a:solidFill>
+                <a:latin typeface="PingFang SC" pitchFamily="34" charset="0"/>
+                <a:ea typeface="PingFang SC" pitchFamily="34" charset="-122"/>
+                <a:cs typeface="PingFang SC" pitchFamily="34" charset="-120"/>
+              </a:rPr>
+              <a:t>DEFINE · 定标准</a:t>
+            </a:r>
+            <a:endParaRPr lang="zh-CN" sz="850" dirty="0"/>
+          </a:p>
+        </p:txBody>
+      </p:sp>
+      <p:sp>
+        <p:nvSpPr>
+          <p:cNvPr id="44" name="Shape 42"/>
+          <p:cNvSpPr/>
+          <p:nvPr/>
+        </p:nvSpPr>
+        <p:spPr>
+          <a:xfrm>
+            <a:off x="5148072" y="3950208"/>
+            <a:ext cx="3154680" cy="283464"/>
+          </a:xfrm>
+          <a:prstGeom prst="rect">
+            <a:avLst/>
+          </a:prstGeom>
+          <a:solidFill>
+            <a:srgbClr val="002FA7"/>
+          </a:solidFill>
+          <a:ln w="6350">
+            <a:solidFill>
+              <a:srgbClr val="002FA7">
+                <a:alpha val="0"/>
+              </a:srgbClr>
+            </a:solidFill>
+            <a:prstDash val="solid"/>
+          </a:ln>
+        </p:spPr>
+      </p:sp>
+      <p:sp>
+        <p:nvSpPr>
+          <p:cNvPr id="45" name="Text 43"/>
+          <p:cNvSpPr txBox="1"/>
+          <p:nvPr/>
+        </p:nvSpPr>
+        <p:spPr>
+          <a:xfrm>
+            <a:off x="5285232" y="4005072"/>
+            <a:ext cx="2880360" cy="219456"/>
+          </a:xfrm>
+          <a:prstGeom prst="rect">
+            <a:avLst/>
+          </a:prstGeom>
+          <a:noFill/>
+          <a:ln/>
+        </p:spPr>
+        <p:txBody>
+          <a:bodyPr wrap="square" lIns="0" tIns="0" rIns="0" bIns="0" rtlCol="0" anchor="ctr"/>
+          <a:lstStyle/>
+          <a:p>
+            <a:pPr algn="ctr" indent="0" marL="0">
+              <a:buNone/>
+            </a:pPr>
+            <a:r>
+              <a:rPr lang="zh-CN" altLang="en-US" sz="850" b="1" spc="115" kern="0" dirty="0">
+                <a:solidFill>
+                  <a:srgbClr val="FFFFFF"/>
+                </a:solidFill>
+                <a:latin typeface="PingFang SC" pitchFamily="34" charset="0"/>
+                <a:ea typeface="PingFang SC" pitchFamily="34" charset="-122"/>
+                <a:cs typeface="PingFang SC" pitchFamily="34" charset="-120"/>
+              </a:rPr>
+              <a:t>DISCOVER · 识人才</a:t>
+            </a:r>
+            <a:endParaRPr lang="zh-CN" sz="850" dirty="0"/>
+          </a:p>
+        </p:txBody>
+      </p:sp>
+      <p:sp>
+        <p:nvSpPr>
+          <p:cNvPr id="46" name="Shape 44"/>
+          <p:cNvSpPr/>
+          <p:nvPr/>
+        </p:nvSpPr>
+        <p:spPr>
+          <a:xfrm>
+            <a:off x="8421624" y="3950208"/>
+            <a:ext cx="3154680" cy="283464"/>
+          </a:xfrm>
+          <a:prstGeom prst="rect">
+            <a:avLst/>
+          </a:prstGeom>
+          <a:solidFill>
+            <a:srgbClr val="EEF3E8"/>
+          </a:solidFill>
+          <a:ln w="6350">
+            <a:solidFill>
+              <a:srgbClr val="EEF3E8">
+                <a:alpha val="0"/>
+              </a:srgbClr>
+            </a:solidFill>
+            <a:prstDash val="solid"/>
+          </a:ln>
+        </p:spPr>
+      </p:sp>
+      <p:sp>
+        <p:nvSpPr>
+          <p:cNvPr id="47" name="Text 45"/>
+          <p:cNvSpPr txBox="1"/>
+          <p:nvPr/>
+        </p:nvSpPr>
+        <p:spPr>
+          <a:xfrm>
+            <a:off x="8558784" y="4005072"/>
+            <a:ext cx="2880360" cy="219456"/>
+          </a:xfrm>
+          <a:prstGeom prst="rect">
+            <a:avLst/>
+          </a:prstGeom>
+          <a:noFill/>
+          <a:ln/>
+        </p:spPr>
+        <p:txBody>
+          <a:bodyPr wrap="square" lIns="0" tIns="0" rIns="0" bIns="0" rtlCol="0" anchor="ctr"/>
+          <a:lstStyle/>
+          <a:p>
+            <a:pPr algn="ctr" indent="0" marL="0">
+              <a:buNone/>
+            </a:pPr>
+            <a:r>
+              <a:rPr lang="zh-CN" altLang="en-US" sz="850" b="1" spc="115" kern="0" dirty="0">
+                <a:solidFill>
+                  <a:srgbClr val="44652B"/>
+                </a:solidFill>
+                <a:latin typeface="PingFang SC" pitchFamily="34" charset="0"/>
+                <a:ea typeface="PingFang SC" pitchFamily="34" charset="-122"/>
+                <a:cs typeface="PingFang SC" pitchFamily="34" charset="-120"/>
+              </a:rPr>
+              <a:t>DRIVE · 促发展</a:t>
+            </a:r>
+            <a:endParaRPr lang="zh-CN" sz="850" dirty="0"/>
+          </a:p>
+        </p:txBody>
+      </p:sp>
+      <p:sp>
+        <p:nvSpPr>
+          <p:cNvPr id="48" name="Shape 46"/>
+          <p:cNvSpPr/>
+          <p:nvPr/>
+        </p:nvSpPr>
+        <p:spPr>
+          <a:xfrm>
+            <a:off x="1874520" y="4315968"/>
+            <a:ext cx="3154680" cy="320040"/>
+          </a:xfrm>
+          <a:prstGeom prst="rect">
+            <a:avLst/>
+          </a:prstGeom>
+          <a:solidFill>
+            <a:srgbClr val="FFFFFF"/>
+          </a:solidFill>
+          <a:ln w="6985">
+            <a:solidFill>
+              <a:srgbClr val="D4D4D2"/>
+            </a:solidFill>
+            <a:prstDash val="solid"/>
+          </a:ln>
+        </p:spPr>
+      </p:sp>
+      <p:sp>
+        <p:nvSpPr>
+          <p:cNvPr id="49" name="Text 47"/>
+          <p:cNvSpPr txBox="1"/>
+          <p:nvPr/>
+        </p:nvSpPr>
+        <p:spPr>
+          <a:xfrm>
+            <a:off x="2011680" y="4389120"/>
+            <a:ext cx="1700784" cy="173736"/>
+          </a:xfrm>
+          <a:prstGeom prst="rect">
+            <a:avLst/>
+          </a:prstGeom>
+          <a:noFill/>
+          <a:ln/>
+        </p:spPr>
+        <p:txBody>
+          <a:bodyPr wrap="square" lIns="0" tIns="0" rIns="0" bIns="0" rtlCol="0" anchor="ctr">
+            <a:normAutofit/>
+          </a:bodyPr>
+          <a:lstStyle/>
+          <a:p>
+            <a:pPr algn="l" indent="0" marL="0">
+              <a:buNone/>
+            </a:pPr>
+            <a:r>
+              <a:rPr lang="zh-CN" altLang="en-US" sz="1020" b="1" dirty="0">
+                <a:solidFill>
+                  <a:srgbClr val="0A0A0A"/>
+                </a:solidFill>
+                <a:latin typeface="PingFang SC" pitchFamily="34" charset="0"/>
+                <a:ea typeface="PingFang SC" pitchFamily="34" charset="-122"/>
+                <a:cs typeface="PingFang SC" pitchFamily="34" charset="-120"/>
+              </a:rPr>
+              <a:t>组织 / 关键岗位分析</a:t>
+            </a:r>
+            <a:endParaRPr lang="zh-CN" sz="1020" dirty="0"/>
+          </a:p>
+        </p:txBody>
+      </p:sp>
+      <p:sp>
+        <p:nvSpPr>
+          <p:cNvPr id="50" name="Text 48"/>
+          <p:cNvSpPr txBox="1"/>
+          <p:nvPr/>
+        </p:nvSpPr>
+        <p:spPr>
+          <a:xfrm>
+            <a:off x="3584448" y="4389120"/>
+            <a:ext cx="1298448" cy="173736"/>
+          </a:xfrm>
+          <a:prstGeom prst="rect">
+            <a:avLst/>
+          </a:prstGeom>
+          <a:noFill/>
+          <a:ln/>
+        </p:spPr>
+        <p:txBody>
+          <a:bodyPr wrap="square" lIns="0" tIns="0" rIns="0" bIns="0" rtlCol="0" anchor="ctr">
+            <a:normAutofit/>
+          </a:bodyPr>
+          <a:lstStyle/>
+          <a:p>
+            <a:pPr algn="r" indent="0" marL="0">
+              <a:buNone/>
+            </a:pPr>
+            <a:r>
+              <a:rPr lang="zh-CN" altLang="en-US" sz="850" dirty="0">
+                <a:solidFill>
+                  <a:srgbClr val="737373"/>
+                </a:solidFill>
+                <a:latin typeface="PingFang SC" pitchFamily="34" charset="0"/>
+                <a:ea typeface="PingFang SC" pitchFamily="34" charset="-122"/>
+                <a:cs typeface="PingFang SC" pitchFamily="34" charset="-120"/>
+              </a:rPr>
+              <a:t>确定优先范围</a:t>
+            </a:r>
+            <a:endParaRPr lang="zh-CN" sz="850" dirty="0"/>
+          </a:p>
+        </p:txBody>
+      </p:sp>
+      <p:sp>
+        <p:nvSpPr>
+          <p:cNvPr id="51" name="Shape 49"/>
+          <p:cNvSpPr/>
+          <p:nvPr/>
+        </p:nvSpPr>
+        <p:spPr>
+          <a:xfrm>
+            <a:off x="1874520" y="4709160"/>
+            <a:ext cx="3154680" cy="320040"/>
+          </a:xfrm>
+          <a:prstGeom prst="rect">
+            <a:avLst/>
+          </a:prstGeom>
+          <a:solidFill>
+            <a:srgbClr val="FFFFFF"/>
+          </a:solidFill>
+          <a:ln w="6985">
+            <a:solidFill>
+              <a:srgbClr val="D4D4D2"/>
+            </a:solidFill>
+            <a:prstDash val="solid"/>
+          </a:ln>
+        </p:spPr>
+      </p:sp>
+      <p:sp>
+        <p:nvSpPr>
+          <p:cNvPr id="52" name="Text 50"/>
+          <p:cNvSpPr txBox="1"/>
+          <p:nvPr/>
+        </p:nvSpPr>
+        <p:spPr>
+          <a:xfrm>
+            <a:off x="2011680" y="4782312"/>
+            <a:ext cx="1700784" cy="173736"/>
+          </a:xfrm>
+          <a:prstGeom prst="rect">
+            <a:avLst/>
+          </a:prstGeom>
+          <a:noFill/>
+          <a:ln/>
+        </p:spPr>
+        <p:txBody>
+          <a:bodyPr wrap="square" lIns="0" tIns="0" rIns="0" bIns="0" rtlCol="0" anchor="ctr">
+            <a:normAutofit/>
+          </a:bodyPr>
+          <a:lstStyle/>
+          <a:p>
+            <a:pPr algn="l" indent="0" marL="0">
+              <a:buNone/>
+            </a:pPr>
+            <a:r>
+              <a:rPr lang="zh-CN" altLang="en-US" sz="1020" b="1" dirty="0">
+                <a:solidFill>
+                  <a:srgbClr val="0A0A0A"/>
+                </a:solidFill>
+                <a:latin typeface="PingFang SC" pitchFamily="34" charset="0"/>
+                <a:ea typeface="PingFang SC" pitchFamily="34" charset="-122"/>
+                <a:cs typeface="PingFang SC" pitchFamily="34" charset="-120"/>
+              </a:rPr>
+              <a:t>岗位标准</a:t>
+            </a:r>
+            <a:endParaRPr lang="zh-CN" sz="1020" dirty="0"/>
+          </a:p>
+        </p:txBody>
+      </p:sp>
+      <p:sp>
+        <p:nvSpPr>
+          <p:cNvPr id="53" name="Text 51"/>
+          <p:cNvSpPr txBox="1"/>
+          <p:nvPr/>
+        </p:nvSpPr>
+        <p:spPr>
+          <a:xfrm>
+            <a:off x="3584448" y="4782312"/>
+            <a:ext cx="1298448" cy="173736"/>
+          </a:xfrm>
+          <a:prstGeom prst="rect">
+            <a:avLst/>
+          </a:prstGeom>
+          <a:noFill/>
+          <a:ln/>
+        </p:spPr>
+        <p:txBody>
+          <a:bodyPr wrap="square" lIns="0" tIns="0" rIns="0" bIns="0" rtlCol="0" anchor="ctr">
+            <a:normAutofit/>
+          </a:bodyPr>
+          <a:lstStyle/>
+          <a:p>
+            <a:pPr algn="r" indent="0" marL="0">
+              <a:buNone/>
+            </a:pPr>
+            <a:r>
+              <a:rPr lang="zh-CN" altLang="en-US" sz="850" dirty="0">
+                <a:solidFill>
+                  <a:srgbClr val="737373"/>
+                </a:solidFill>
+                <a:latin typeface="PingFang SC" pitchFamily="34" charset="0"/>
+                <a:ea typeface="PingFang SC" pitchFamily="34" charset="-122"/>
+                <a:cs typeface="PingFang SC" pitchFamily="34" charset="-120"/>
+              </a:rPr>
+              <a:t>建立统一尺子</a:t>
+            </a:r>
+            <a:endParaRPr lang="zh-CN" sz="850" dirty="0"/>
+          </a:p>
+        </p:txBody>
+      </p:sp>
+      <p:sp>
+        <p:nvSpPr>
+          <p:cNvPr id="54" name="Shape 52"/>
+          <p:cNvSpPr/>
+          <p:nvPr/>
+        </p:nvSpPr>
+        <p:spPr>
+          <a:xfrm>
+            <a:off x="5148072" y="4315968"/>
+            <a:ext cx="3154680" cy="320040"/>
+          </a:xfrm>
+          <a:prstGeom prst="rect">
+            <a:avLst/>
+          </a:prstGeom>
+          <a:solidFill>
+            <a:srgbClr val="FFFFFF"/>
+          </a:solidFill>
+          <a:ln w="6985">
+            <a:solidFill>
+              <a:srgbClr val="D4D4D2"/>
+            </a:solidFill>
+            <a:prstDash val="solid"/>
+          </a:ln>
+        </p:spPr>
+      </p:sp>
+      <p:sp>
+        <p:nvSpPr>
+          <p:cNvPr id="55" name="Text 53"/>
+          <p:cNvSpPr txBox="1"/>
+          <p:nvPr/>
+        </p:nvSpPr>
+        <p:spPr>
+          <a:xfrm>
+            <a:off x="5285232" y="4389120"/>
+            <a:ext cx="1700784" cy="173736"/>
+          </a:xfrm>
+          <a:prstGeom prst="rect">
+            <a:avLst/>
+          </a:prstGeom>
+          <a:noFill/>
+          <a:ln/>
+        </p:spPr>
+        <p:txBody>
+          <a:bodyPr wrap="square" lIns="0" tIns="0" rIns="0" bIns="0" rtlCol="0" anchor="ctr">
+            <a:normAutofit/>
+          </a:bodyPr>
+          <a:lstStyle/>
+          <a:p>
+            <a:pPr algn="l" indent="0" marL="0">
+              <a:buNone/>
+            </a:pPr>
+            <a:r>
+              <a:rPr lang="zh-CN" altLang="en-US" sz="1020" b="1" dirty="0">
+                <a:solidFill>
+                  <a:srgbClr val="0A0A0A"/>
+                </a:solidFill>
+                <a:latin typeface="PingFang SC" pitchFamily="34" charset="0"/>
+                <a:ea typeface="PingFang SC" pitchFamily="34" charset="-122"/>
+                <a:cs typeface="PingFang SC" pitchFamily="34" charset="-120"/>
+              </a:rPr>
+              <a:t>评鉴工具</a:t>
+            </a:r>
+            <a:endParaRPr lang="zh-CN" sz="1020" dirty="0"/>
+          </a:p>
+        </p:txBody>
+      </p:sp>
+      <p:sp>
+        <p:nvSpPr>
+          <p:cNvPr id="56" name="Text 54"/>
+          <p:cNvSpPr txBox="1"/>
+          <p:nvPr/>
+        </p:nvSpPr>
+        <p:spPr>
+          <a:xfrm>
+            <a:off x="6858000" y="4389120"/>
+            <a:ext cx="1298448" cy="173736"/>
+          </a:xfrm>
+          <a:prstGeom prst="rect">
+            <a:avLst/>
+          </a:prstGeom>
+          <a:noFill/>
+          <a:ln/>
+        </p:spPr>
+        <p:txBody>
+          <a:bodyPr wrap="square" lIns="0" tIns="0" rIns="0" bIns="0" rtlCol="0" anchor="ctr">
+            <a:normAutofit/>
+          </a:bodyPr>
+          <a:lstStyle/>
+          <a:p>
+            <a:pPr algn="r" indent="0" marL="0">
+              <a:buNone/>
+            </a:pPr>
+            <a:r>
+              <a:rPr lang="zh-CN" altLang="en-US" sz="850" dirty="0">
+                <a:solidFill>
+                  <a:srgbClr val="737373"/>
+                </a:solidFill>
+                <a:latin typeface="PingFang SC" pitchFamily="34" charset="0"/>
+                <a:ea typeface="PingFang SC" pitchFamily="34" charset="-122"/>
+                <a:cs typeface="PingFang SC" pitchFamily="34" charset="-120"/>
+              </a:rPr>
+              <a:t>收集能力、动力、潜力</a:t>
+            </a:r>
+            <a:endParaRPr lang="zh-CN" sz="850" dirty="0"/>
+          </a:p>
+        </p:txBody>
+      </p:sp>
+      <p:sp>
+        <p:nvSpPr>
+          <p:cNvPr id="57" name="Shape 55"/>
+          <p:cNvSpPr/>
+          <p:nvPr/>
+        </p:nvSpPr>
+        <p:spPr>
+          <a:xfrm>
+            <a:off x="5148072" y="4709160"/>
+            <a:ext cx="3154680" cy="320040"/>
+          </a:xfrm>
+          <a:prstGeom prst="rect">
+            <a:avLst/>
+          </a:prstGeom>
+          <a:solidFill>
+            <a:srgbClr val="FFFFFF"/>
+          </a:solidFill>
+          <a:ln w="6985">
+            <a:solidFill>
+              <a:srgbClr val="D4D4D2"/>
+            </a:solidFill>
+            <a:prstDash val="solid"/>
+          </a:ln>
+        </p:spPr>
+      </p:sp>
+      <p:sp>
+        <p:nvSpPr>
+          <p:cNvPr id="58" name="Text 56"/>
+          <p:cNvSpPr txBox="1"/>
+          <p:nvPr/>
+        </p:nvSpPr>
+        <p:spPr>
+          <a:xfrm>
+            <a:off x="5285232" y="4782312"/>
+            <a:ext cx="1700784" cy="173736"/>
+          </a:xfrm>
+          <a:prstGeom prst="rect">
+            <a:avLst/>
+          </a:prstGeom>
+          <a:noFill/>
+          <a:ln/>
+        </p:spPr>
+        <p:txBody>
+          <a:bodyPr wrap="square" lIns="0" tIns="0" rIns="0" bIns="0" rtlCol="0" anchor="ctr">
+            <a:normAutofit/>
+          </a:bodyPr>
+          <a:lstStyle/>
+          <a:p>
+            <a:pPr algn="l" indent="0" marL="0">
+              <a:buNone/>
+            </a:pPr>
+            <a:r>
+              <a:rPr lang="zh-CN" altLang="en-US" sz="1020" b="1" dirty="0">
+                <a:solidFill>
+                  <a:srgbClr val="0A0A0A"/>
+                </a:solidFill>
+                <a:latin typeface="PingFang SC" pitchFamily="34" charset="0"/>
+                <a:ea typeface="PingFang SC" pitchFamily="34" charset="-122"/>
+                <a:cs typeface="PingFang SC" pitchFamily="34" charset="-120"/>
+              </a:rPr>
+              <a:t>人才盘点</a:t>
+            </a:r>
+            <a:endParaRPr lang="zh-CN" sz="1020" dirty="0"/>
+          </a:p>
+        </p:txBody>
+      </p:sp>
+      <p:sp>
+        <p:nvSpPr>
+          <p:cNvPr id="59" name="Text 57"/>
+          <p:cNvSpPr txBox="1"/>
+          <p:nvPr/>
+        </p:nvSpPr>
+        <p:spPr>
+          <a:xfrm>
+            <a:off x="6858000" y="4782312"/>
+            <a:ext cx="1298448" cy="173736"/>
+          </a:xfrm>
+          <a:prstGeom prst="rect">
+            <a:avLst/>
+          </a:prstGeom>
+          <a:noFill/>
+          <a:ln/>
+        </p:spPr>
+        <p:txBody>
+          <a:bodyPr wrap="square" lIns="0" tIns="0" rIns="0" bIns="0" rtlCol="0" anchor="ctr">
+            <a:normAutofit/>
+          </a:bodyPr>
+          <a:lstStyle/>
+          <a:p>
+            <a:pPr algn="r" indent="0" marL="0">
+              <a:buNone/>
+            </a:pPr>
+            <a:r>
+              <a:rPr lang="zh-CN" altLang="en-US" sz="850" dirty="0">
+                <a:solidFill>
+                  <a:srgbClr val="737373"/>
+                </a:solidFill>
+                <a:latin typeface="PingFang SC" pitchFamily="34" charset="0"/>
+                <a:ea typeface="PingFang SC" pitchFamily="34" charset="-122"/>
+                <a:cs typeface="PingFang SC" pitchFamily="34" charset="-120"/>
+              </a:rPr>
+              <a:t>看清群体与个人</a:t>
+            </a:r>
+            <a:endParaRPr lang="zh-CN" sz="850" dirty="0"/>
+          </a:p>
+        </p:txBody>
+      </p:sp>
+      <p:sp>
+        <p:nvSpPr>
+          <p:cNvPr id="60" name="Shape 58"/>
+          <p:cNvSpPr/>
+          <p:nvPr/>
+        </p:nvSpPr>
+        <p:spPr>
+          <a:xfrm>
+            <a:off x="8421624" y="4315968"/>
+            <a:ext cx="3154680" cy="320040"/>
+          </a:xfrm>
+          <a:prstGeom prst="rect">
+            <a:avLst/>
+          </a:prstGeom>
+          <a:solidFill>
+            <a:srgbClr val="FFFFFF"/>
+          </a:solidFill>
+          <a:ln w="6985">
+            <a:solidFill>
+              <a:srgbClr val="D4D4D2"/>
+            </a:solidFill>
+            <a:prstDash val="solid"/>
+          </a:ln>
+        </p:spPr>
+      </p:sp>
+      <p:sp>
+        <p:nvSpPr>
+          <p:cNvPr id="61" name="Text 59"/>
+          <p:cNvSpPr txBox="1"/>
+          <p:nvPr/>
+        </p:nvSpPr>
+        <p:spPr>
+          <a:xfrm>
+            <a:off x="8558784" y="4389120"/>
+            <a:ext cx="1700784" cy="173736"/>
+          </a:xfrm>
+          <a:prstGeom prst="rect">
+            <a:avLst/>
+          </a:prstGeom>
+          <a:noFill/>
+          <a:ln/>
+        </p:spPr>
+        <p:txBody>
+          <a:bodyPr wrap="square" lIns="0" tIns="0" rIns="0" bIns="0" rtlCol="0" anchor="ctr">
+            <a:normAutofit/>
+          </a:bodyPr>
+          <a:lstStyle/>
+          <a:p>
+            <a:pPr algn="l" indent="0" marL="0">
+              <a:buNone/>
+            </a:pPr>
+            <a:r>
+              <a:rPr lang="zh-CN" altLang="en-US" sz="1020" b="1" dirty="0">
+                <a:solidFill>
+                  <a:srgbClr val="0A0A0A"/>
+                </a:solidFill>
+                <a:latin typeface="PingFang SC" pitchFamily="34" charset="0"/>
+                <a:ea typeface="PingFang SC" pitchFamily="34" charset="-122"/>
+                <a:cs typeface="PingFang SC" pitchFamily="34" charset="-120"/>
+              </a:rPr>
+              <a:t>人岗匹配</a:t>
+            </a:r>
+            <a:endParaRPr lang="zh-CN" sz="1020" dirty="0"/>
+          </a:p>
+        </p:txBody>
+      </p:sp>
+      <p:sp>
+        <p:nvSpPr>
+          <p:cNvPr id="62" name="Text 60"/>
+          <p:cNvSpPr txBox="1"/>
+          <p:nvPr/>
+        </p:nvSpPr>
+        <p:spPr>
+          <a:xfrm>
+            <a:off x="10131552" y="4389120"/>
+            <a:ext cx="1298448" cy="173736"/>
+          </a:xfrm>
+          <a:prstGeom prst="rect">
+            <a:avLst/>
+          </a:prstGeom>
+          <a:noFill/>
+          <a:ln/>
+        </p:spPr>
+        <p:txBody>
+          <a:bodyPr wrap="square" lIns="0" tIns="0" rIns="0" bIns="0" rtlCol="0" anchor="ctr">
+            <a:normAutofit/>
+          </a:bodyPr>
+          <a:lstStyle/>
+          <a:p>
+            <a:pPr algn="r" indent="0" marL="0">
+              <a:buNone/>
+            </a:pPr>
+            <a:r>
+              <a:rPr lang="zh-CN" altLang="en-US" sz="850" dirty="0">
+                <a:solidFill>
+                  <a:srgbClr val="737373"/>
+                </a:solidFill>
+                <a:latin typeface="PingFang SC" pitchFamily="34" charset="0"/>
+                <a:ea typeface="PingFang SC" pitchFamily="34" charset="-122"/>
+                <a:cs typeface="PingFang SC" pitchFamily="34" charset="-120"/>
+              </a:rPr>
+              <a:t>识别差距</a:t>
+            </a:r>
+            <a:endParaRPr lang="zh-CN" sz="850" dirty="0"/>
+          </a:p>
+        </p:txBody>
+      </p:sp>
+      <p:sp>
+        <p:nvSpPr>
+          <p:cNvPr id="63" name="Shape 61"/>
+          <p:cNvSpPr/>
+          <p:nvPr/>
+        </p:nvSpPr>
+        <p:spPr>
+          <a:xfrm>
+            <a:off x="8421624" y="4709160"/>
+            <a:ext cx="3154680" cy="320040"/>
+          </a:xfrm>
+          <a:prstGeom prst="rect">
+            <a:avLst/>
+          </a:prstGeom>
+          <a:solidFill>
+            <a:srgbClr val="FFFFFF"/>
+          </a:solidFill>
+          <a:ln w="6985">
+            <a:solidFill>
+              <a:srgbClr val="D4D4D2"/>
+            </a:solidFill>
+            <a:prstDash val="solid"/>
+          </a:ln>
+        </p:spPr>
+      </p:sp>
+      <p:sp>
+        <p:nvSpPr>
+          <p:cNvPr id="64" name="Text 62"/>
+          <p:cNvSpPr txBox="1"/>
+          <p:nvPr/>
+        </p:nvSpPr>
+        <p:spPr>
+          <a:xfrm>
+            <a:off x="8558784" y="4782312"/>
+            <a:ext cx="1700784" cy="173736"/>
+          </a:xfrm>
+          <a:prstGeom prst="rect">
+            <a:avLst/>
+          </a:prstGeom>
+          <a:noFill/>
+          <a:ln/>
+        </p:spPr>
+        <p:txBody>
+          <a:bodyPr wrap="square" lIns="0" tIns="0" rIns="0" bIns="0" rtlCol="0" anchor="ctr">
+            <a:normAutofit/>
+          </a:bodyPr>
+          <a:lstStyle/>
+          <a:p>
+            <a:pPr algn="l" indent="0" marL="0">
+              <a:buNone/>
+            </a:pPr>
+            <a:r>
+              <a:rPr lang="zh-CN" altLang="en-US" sz="1020" b="1" dirty="0">
+                <a:solidFill>
+                  <a:srgbClr val="0A0A0A"/>
+                </a:solidFill>
+                <a:latin typeface="PingFang SC" pitchFamily="34" charset="0"/>
+                <a:ea typeface="PingFang SC" pitchFamily="34" charset="-122"/>
+                <a:cs typeface="PingFang SC" pitchFamily="34" charset="-120"/>
+              </a:rPr>
+              <a:t>个人 IDP / 组织培养</a:t>
+            </a:r>
+            <a:endParaRPr lang="zh-CN" sz="1020" dirty="0"/>
+          </a:p>
+        </p:txBody>
+      </p:sp>
+      <p:sp>
+        <p:nvSpPr>
+          <p:cNvPr id="65" name="Text 63"/>
+          <p:cNvSpPr txBox="1"/>
+          <p:nvPr/>
+        </p:nvSpPr>
+        <p:spPr>
+          <a:xfrm>
+            <a:off x="10131552" y="4782312"/>
+            <a:ext cx="1298448" cy="173736"/>
+          </a:xfrm>
+          <a:prstGeom prst="rect">
+            <a:avLst/>
+          </a:prstGeom>
+          <a:noFill/>
+          <a:ln/>
+        </p:spPr>
+        <p:txBody>
+          <a:bodyPr wrap="square" lIns="0" tIns="0" rIns="0" bIns="0" rtlCol="0" anchor="ctr">
+            <a:normAutofit/>
+          </a:bodyPr>
+          <a:lstStyle/>
+          <a:p>
+            <a:pPr algn="r" indent="0" marL="0">
+              <a:buNone/>
+            </a:pPr>
+            <a:r>
+              <a:rPr lang="zh-CN" altLang="en-US" sz="850" dirty="0">
+                <a:solidFill>
+                  <a:srgbClr val="737373"/>
+                </a:solidFill>
+                <a:latin typeface="PingFang SC" pitchFamily="34" charset="0"/>
+                <a:ea typeface="PingFang SC" pitchFamily="34" charset="-122"/>
+                <a:cs typeface="PingFang SC" pitchFamily="34" charset="-120"/>
+              </a:rPr>
+              <a:t>把差距变成行动</a:t>
+            </a:r>
+            <a:endParaRPr lang="zh-CN" sz="850" dirty="0"/>
+          </a:p>
+        </p:txBody>
+      </p:sp>
+      <p:sp>
+        <p:nvSpPr>
+          <p:cNvPr id="66" name="Shape 64"/>
+          <p:cNvSpPr/>
+          <p:nvPr/>
+        </p:nvSpPr>
+        <p:spPr>
+          <a:xfrm>
+            <a:off x="5029200" y="4480560"/>
+            <a:ext cx="118872" cy="0"/>
+          </a:xfrm>
+          <a:prstGeom prst="line">
+            <a:avLst/>
+          </a:prstGeom>
+          <a:noFill/>
+          <a:ln w="12700">
+            <a:solidFill>
+              <a:srgbClr val="002FA7"/>
+            </a:solidFill>
+            <a:prstDash val="solid"/>
+            <a:tailEnd type="triangle"/>
+          </a:ln>
+        </p:spPr>
+      </p:sp>
+      <p:sp>
+        <p:nvSpPr>
+          <p:cNvPr id="67" name="Shape 65"/>
+          <p:cNvSpPr/>
+          <p:nvPr/>
+        </p:nvSpPr>
+        <p:spPr>
+          <a:xfrm>
+            <a:off x="8302752" y="4480560"/>
+            <a:ext cx="118872" cy="0"/>
+          </a:xfrm>
+          <a:prstGeom prst="line">
+            <a:avLst/>
+          </a:prstGeom>
+          <a:noFill/>
+          <a:ln w="12700">
+            <a:solidFill>
+              <a:srgbClr val="002FA7"/>
+            </a:solidFill>
+            <a:prstDash val="solid"/>
+            <a:tailEnd type="triangle"/>
+          </a:ln>
+        </p:spPr>
+      </p:sp>
+      <p:sp>
+        <p:nvSpPr>
+          <p:cNvPr id="68" name="Text 66"/>
+          <p:cNvSpPr txBox="1"/>
+          <p:nvPr/>
+        </p:nvSpPr>
+        <p:spPr>
+          <a:xfrm>
+            <a:off x="2002536" y="5385816"/>
+            <a:ext cx="2880360" cy="219456"/>
+          </a:xfrm>
+          <a:prstGeom prst="rect">
+            <a:avLst/>
+          </a:prstGeom>
+          <a:noFill/>
+          <a:ln/>
+        </p:spPr>
+        <p:txBody>
+          <a:bodyPr wrap="square" lIns="0" tIns="0" rIns="0" bIns="0" rtlCol="0" anchor="ctr"/>
+          <a:lstStyle/>
+          <a:p>
+            <a:pPr algn="ctr" indent="0" marL="0">
+              <a:buNone/>
+            </a:pPr>
+            <a:r>
+              <a:rPr lang="zh-CN" altLang="en-US" sz="850" b="1" spc="115" kern="0" dirty="0">
+                <a:solidFill>
+                  <a:srgbClr val="8B4A20"/>
+                </a:solidFill>
+                <a:latin typeface="PingFang SC" pitchFamily="34" charset="0"/>
+                <a:ea typeface="PingFang SC" pitchFamily="34" charset="-122"/>
+                <a:cs typeface="PingFang SC" pitchFamily="34" charset="-120"/>
+              </a:rPr>
+              <a:t>CONDUCT · 学</a:t>
+            </a:r>
+            <a:endParaRPr lang="zh-CN" sz="850" dirty="0"/>
+          </a:p>
+        </p:txBody>
+      </p:sp>
+      <p:sp>
+        <p:nvSpPr>
+          <p:cNvPr id="69" name="Shape 67"/>
+          <p:cNvSpPr/>
+          <p:nvPr/>
+        </p:nvSpPr>
+        <p:spPr>
+          <a:xfrm>
+            <a:off x="1874520" y="5641848"/>
+            <a:ext cx="3154680" cy="329184"/>
+          </a:xfrm>
+          <a:prstGeom prst="rect">
+            <a:avLst/>
+          </a:prstGeom>
+          <a:solidFill>
+            <a:srgbClr val="FFFFFF"/>
+          </a:solidFill>
+          <a:ln w="6985">
+            <a:solidFill>
+              <a:srgbClr val="D4D4D2"/>
+            </a:solidFill>
+            <a:prstDash val="solid"/>
+          </a:ln>
+        </p:spPr>
+      </p:sp>
+      <p:sp>
+        <p:nvSpPr>
+          <p:cNvPr id="70" name="Text 68"/>
+          <p:cNvSpPr txBox="1"/>
+          <p:nvPr/>
+        </p:nvSpPr>
+        <p:spPr>
+          <a:xfrm>
+            <a:off x="2039112" y="5715000"/>
+            <a:ext cx="2825496" cy="182880"/>
+          </a:xfrm>
+          <a:prstGeom prst="rect">
+            <a:avLst/>
+          </a:prstGeom>
+          <a:noFill/>
+          <a:ln/>
+        </p:spPr>
+        <p:txBody>
+          <a:bodyPr wrap="square" lIns="0" tIns="0" rIns="0" bIns="0" rtlCol="0" anchor="ctr">
+            <a:normAutofit/>
+          </a:bodyPr>
+          <a:lstStyle/>
+          <a:p>
+            <a:pPr algn="ctr" indent="0" marL="0">
+              <a:buNone/>
+            </a:pPr>
+            <a:r>
+              <a:rPr lang="zh-CN" altLang="en-US" sz="1080" b="1" dirty="0">
+                <a:solidFill>
+                  <a:srgbClr val="0A0A0A"/>
+                </a:solidFill>
+                <a:latin typeface="PingFang SC" pitchFamily="34" charset="0"/>
+                <a:ea typeface="PingFang SC" pitchFamily="34" charset="-122"/>
+                <a:cs typeface="PingFang SC" pitchFamily="34" charset="-120"/>
+              </a:rPr>
+              <a:t>在线学习</a:t>
+            </a:r>
+            <a:endParaRPr lang="zh-CN" sz="1080" dirty="0"/>
+          </a:p>
+        </p:txBody>
+      </p:sp>
+      <p:sp>
+        <p:nvSpPr>
+          <p:cNvPr id="71" name="Shape 69"/>
+          <p:cNvSpPr/>
+          <p:nvPr/>
+        </p:nvSpPr>
+        <p:spPr>
+          <a:xfrm>
+            <a:off x="5029200" y="5806440"/>
+            <a:ext cx="118872" cy="0"/>
+          </a:xfrm>
+          <a:prstGeom prst="line">
+            <a:avLst/>
+          </a:prstGeom>
+          <a:noFill/>
+          <a:ln w="11430">
+            <a:solidFill>
+              <a:srgbClr val="8B4A20"/>
+            </a:solidFill>
+            <a:prstDash val="solid"/>
+            <a:tailEnd type="triangle"/>
+          </a:ln>
+        </p:spPr>
+      </p:sp>
+      <p:sp>
+        <p:nvSpPr>
+          <p:cNvPr id="72" name="Text 70"/>
+          <p:cNvSpPr txBox="1"/>
+          <p:nvPr/>
+        </p:nvSpPr>
+        <p:spPr>
+          <a:xfrm>
+            <a:off x="5276088" y="5385816"/>
+            <a:ext cx="2880360" cy="219456"/>
+          </a:xfrm>
+          <a:prstGeom prst="rect">
+            <a:avLst/>
+          </a:prstGeom>
+          <a:noFill/>
+          <a:ln/>
+        </p:spPr>
+        <p:txBody>
+          <a:bodyPr wrap="square" lIns="0" tIns="0" rIns="0" bIns="0" rtlCol="0" anchor="ctr"/>
+          <a:lstStyle/>
+          <a:p>
+            <a:pPr algn="ctr" indent="0" marL="0">
+              <a:buNone/>
+            </a:pPr>
+            <a:r>
+              <a:rPr lang="zh-CN" altLang="en-US" sz="850" b="1" spc="115" kern="0" dirty="0">
+                <a:solidFill>
+                  <a:srgbClr val="8B4A20"/>
+                </a:solidFill>
+                <a:latin typeface="PingFang SC" pitchFamily="34" charset="0"/>
+                <a:ea typeface="PingFang SC" pitchFamily="34" charset="-122"/>
+                <a:cs typeface="PingFang SC" pitchFamily="34" charset="-120"/>
+              </a:rPr>
+              <a:t>CONSTRUCT · 习</a:t>
+            </a:r>
+            <a:endParaRPr lang="zh-CN" sz="850" dirty="0"/>
+          </a:p>
+        </p:txBody>
+      </p:sp>
+      <p:sp>
+        <p:nvSpPr>
+          <p:cNvPr id="73" name="Shape 71"/>
+          <p:cNvSpPr/>
+          <p:nvPr/>
+        </p:nvSpPr>
+        <p:spPr>
+          <a:xfrm>
+            <a:off x="5148072" y="5641848"/>
+            <a:ext cx="3154680" cy="329184"/>
+          </a:xfrm>
+          <a:prstGeom prst="rect">
+            <a:avLst/>
+          </a:prstGeom>
+          <a:solidFill>
+            <a:srgbClr val="FFFFFF"/>
+          </a:solidFill>
+          <a:ln w="6985">
+            <a:solidFill>
+              <a:srgbClr val="D4D4D2"/>
+            </a:solidFill>
+            <a:prstDash val="solid"/>
+          </a:ln>
+        </p:spPr>
+      </p:sp>
+      <p:sp>
+        <p:nvSpPr>
+          <p:cNvPr id="74" name="Text 72"/>
+          <p:cNvSpPr txBox="1"/>
+          <p:nvPr/>
+        </p:nvSpPr>
+        <p:spPr>
+          <a:xfrm>
+            <a:off x="5312664" y="5715000"/>
+            <a:ext cx="2825496" cy="182880"/>
+          </a:xfrm>
+          <a:prstGeom prst="rect">
+            <a:avLst/>
+          </a:prstGeom>
+          <a:noFill/>
+          <a:ln/>
+        </p:spPr>
+        <p:txBody>
+          <a:bodyPr wrap="square" lIns="0" tIns="0" rIns="0" bIns="0" rtlCol="0" anchor="ctr">
+            <a:normAutofit/>
+          </a:bodyPr>
+          <a:lstStyle/>
+          <a:p>
+            <a:pPr algn="ctr" indent="0" marL="0">
+              <a:buNone/>
+            </a:pPr>
+            <a:r>
+              <a:rPr lang="zh-CN" altLang="en-US" sz="1080" b="1" dirty="0">
+                <a:solidFill>
+                  <a:srgbClr val="0A0A0A"/>
+                </a:solidFill>
+                <a:latin typeface="PingFang SC" pitchFamily="34" charset="0"/>
+                <a:ea typeface="PingFang SC" pitchFamily="34" charset="-122"/>
+                <a:cs typeface="PingFang SC" pitchFamily="34" charset="-120"/>
+              </a:rPr>
+              <a:t>AI 陪练</a:t>
+            </a:r>
+            <a:endParaRPr lang="zh-CN" sz="1080" dirty="0"/>
+          </a:p>
+        </p:txBody>
+      </p:sp>
+      <p:sp>
+        <p:nvSpPr>
+          <p:cNvPr id="75" name="Shape 73"/>
+          <p:cNvSpPr/>
+          <p:nvPr/>
+        </p:nvSpPr>
+        <p:spPr>
+          <a:xfrm>
+            <a:off x="8302752" y="5806440"/>
+            <a:ext cx="118872" cy="0"/>
+          </a:xfrm>
+          <a:prstGeom prst="line">
+            <a:avLst/>
+          </a:prstGeom>
+          <a:noFill/>
+          <a:ln w="11430">
+            <a:solidFill>
+              <a:srgbClr val="8B4A20"/>
+            </a:solidFill>
+            <a:prstDash val="solid"/>
+            <a:tailEnd type="triangle"/>
+          </a:ln>
+        </p:spPr>
+      </p:sp>
+      <p:sp>
+        <p:nvSpPr>
+          <p:cNvPr id="76" name="Text 74"/>
+          <p:cNvSpPr txBox="1"/>
+          <p:nvPr/>
+        </p:nvSpPr>
+        <p:spPr>
+          <a:xfrm>
+            <a:off x="8549640" y="5385816"/>
+            <a:ext cx="2880360" cy="219456"/>
+          </a:xfrm>
+          <a:prstGeom prst="rect">
+            <a:avLst/>
+          </a:prstGeom>
+          <a:noFill/>
+          <a:ln/>
+        </p:spPr>
+        <p:txBody>
+          <a:bodyPr wrap="square" lIns="0" tIns="0" rIns="0" bIns="0" rtlCol="0" anchor="ctr"/>
+          <a:lstStyle/>
+          <a:p>
+            <a:pPr algn="ctr" indent="0" marL="0">
+              <a:buNone/>
+            </a:pPr>
+            <a:r>
+              <a:rPr lang="zh-CN" altLang="en-US" sz="850" b="1" spc="115" kern="0" dirty="0">
+                <a:solidFill>
+                  <a:srgbClr val="8B4A20"/>
+                </a:solidFill>
+                <a:latin typeface="PingFang SC" pitchFamily="34" charset="0"/>
+                <a:ea typeface="PingFang SC" pitchFamily="34" charset="-122"/>
+                <a:cs typeface="PingFang SC" pitchFamily="34" charset="-120"/>
+              </a:rPr>
+              <a:t>CONVERT · 变</a:t>
+            </a:r>
+            <a:endParaRPr lang="zh-CN" sz="850" dirty="0"/>
+          </a:p>
+        </p:txBody>
+      </p:sp>
+      <p:sp>
+        <p:nvSpPr>
+          <p:cNvPr id="77" name="Shape 75"/>
+          <p:cNvSpPr/>
+          <p:nvPr/>
+        </p:nvSpPr>
+        <p:spPr>
+          <a:xfrm>
+            <a:off x="8421624" y="5641848"/>
+            <a:ext cx="3154680" cy="329184"/>
+          </a:xfrm>
+          <a:prstGeom prst="rect">
+            <a:avLst/>
+          </a:prstGeom>
+          <a:solidFill>
+            <a:srgbClr val="FFFFFF"/>
+          </a:solidFill>
+          <a:ln w="6985">
+            <a:solidFill>
+              <a:srgbClr val="D4D4D2"/>
+            </a:solidFill>
+            <a:prstDash val="solid"/>
+          </a:ln>
+        </p:spPr>
+      </p:sp>
+      <p:sp>
+        <p:nvSpPr>
+          <p:cNvPr id="78" name="Text 76"/>
+          <p:cNvSpPr txBox="1"/>
+          <p:nvPr/>
+        </p:nvSpPr>
+        <p:spPr>
+          <a:xfrm>
+            <a:off x="8586216" y="5715000"/>
+            <a:ext cx="2825496" cy="182880"/>
+          </a:xfrm>
+          <a:prstGeom prst="rect">
+            <a:avLst/>
+          </a:prstGeom>
+          <a:noFill/>
+          <a:ln/>
+        </p:spPr>
+        <p:txBody>
+          <a:bodyPr wrap="square" lIns="0" tIns="0" rIns="0" bIns="0" rtlCol="0" anchor="ctr">
+            <a:normAutofit/>
+          </a:bodyPr>
+          <a:lstStyle/>
+          <a:p>
+            <a:pPr algn="ctr" indent="0" marL="0">
+              <a:buNone/>
+            </a:pPr>
+            <a:r>
+              <a:rPr lang="zh-CN" altLang="en-US" sz="1080" b="1" dirty="0">
+                <a:solidFill>
+                  <a:srgbClr val="0A0A0A"/>
+                </a:solidFill>
+                <a:latin typeface="PingFang SC" pitchFamily="34" charset="0"/>
+                <a:ea typeface="PingFang SC" pitchFamily="34" charset="-122"/>
+                <a:cs typeface="PingFang SC" pitchFamily="34" charset="-120"/>
+              </a:rPr>
+              <a:t>行动学习</a:t>
+            </a:r>
+            <a:endParaRPr lang="zh-CN" sz="1080" dirty="0"/>
+          </a:p>
+        </p:txBody>
+      </p:sp>
+      <p:sp>
+        <p:nvSpPr>
+          <p:cNvPr id="79" name="Shape 77"/>
+          <p:cNvSpPr/>
+          <p:nvPr/>
+        </p:nvSpPr>
+        <p:spPr>
+          <a:xfrm>
+            <a:off x="1874520" y="6025896"/>
+            <a:ext cx="9720072" cy="228600"/>
+          </a:xfrm>
+          <a:prstGeom prst="rect">
+            <a:avLst/>
+          </a:prstGeom>
+          <a:solidFill>
+            <a:srgbClr val="F6ECE4"/>
+          </a:solidFill>
+          <a:ln w="6350">
+            <a:solidFill>
+              <a:srgbClr val="F6ECE4">
+                <a:alpha val="0"/>
+              </a:srgbClr>
+            </a:solidFill>
+            <a:prstDash val="solid"/>
+          </a:ln>
+        </p:spPr>
+      </p:sp>
+      <p:sp>
+        <p:nvSpPr>
+          <p:cNvPr id="80" name="Text 78"/>
+          <p:cNvSpPr txBox="1"/>
+          <p:nvPr/>
+        </p:nvSpPr>
+        <p:spPr>
+          <a:xfrm>
+            <a:off x="2057400" y="6053328"/>
+            <a:ext cx="9354312" cy="219456"/>
+          </a:xfrm>
+          <a:prstGeom prst="rect">
+            <a:avLst/>
+          </a:prstGeom>
+          <a:noFill/>
+          <a:ln/>
+        </p:spPr>
+        <p:txBody>
+          <a:bodyPr wrap="square" lIns="0" tIns="0" rIns="0" bIns="0" rtlCol="0" anchor="ctr"/>
+          <a:lstStyle/>
+          <a:p>
+            <a:pPr algn="ctr" indent="0" marL="0">
+              <a:buNone/>
+            </a:pPr>
+            <a:r>
+              <a:rPr lang="zh-CN" altLang="en-US" sz="850" b="1" spc="115" kern="0" dirty="0">
+                <a:solidFill>
+                  <a:srgbClr val="8B4A20"/>
+                </a:solidFill>
+                <a:latin typeface="PingFang SC" pitchFamily="34" charset="0"/>
+                <a:ea typeface="PingFang SC" pitchFamily="34" charset="-122"/>
+                <a:cs typeface="PingFang SC" pitchFamily="34" charset="-120"/>
+              </a:rPr>
+              <a:t>数字化培训管理 · 承接个人与组织培养任务</a:t>
+            </a:r>
+            <a:endParaRPr lang="zh-CN" sz="850" dirty="0"/>
+          </a:p>
+        </p:txBody>
+      </p:sp>
+      <p:sp>
+        <p:nvSpPr>
+          <p:cNvPr id="81" name="Shape 79"/>
+          <p:cNvSpPr/>
+          <p:nvPr/>
+        </p:nvSpPr>
+        <p:spPr>
+          <a:xfrm>
+            <a:off x="6693408" y="2615184"/>
+            <a:ext cx="0" cy="274320"/>
+          </a:xfrm>
+          <a:prstGeom prst="line">
+            <a:avLst/>
+          </a:prstGeom>
+          <a:noFill/>
+          <a:ln w="13335">
+            <a:solidFill>
+              <a:srgbClr val="002FA7"/>
+            </a:solidFill>
+            <a:prstDash val="solid"/>
+            <a:tailEnd type="triangle"/>
+          </a:ln>
+        </p:spPr>
+      </p:sp>
+      <p:sp>
+        <p:nvSpPr>
+          <p:cNvPr id="82" name="Shape 80"/>
+          <p:cNvSpPr/>
+          <p:nvPr/>
+        </p:nvSpPr>
+        <p:spPr>
+          <a:xfrm>
+            <a:off x="6693408" y="3849624"/>
+            <a:ext cx="0" cy="100584"/>
+          </a:xfrm>
+          <a:prstGeom prst="line">
+            <a:avLst/>
+          </a:prstGeom>
+          <a:noFill/>
+          <a:ln w="13335">
+            <a:solidFill>
+              <a:srgbClr val="002FA7"/>
+            </a:solidFill>
+            <a:prstDash val="solid"/>
+            <a:tailEnd type="triangle"/>
+          </a:ln>
+        </p:spPr>
+      </p:sp>
+      <p:sp>
+        <p:nvSpPr>
+          <p:cNvPr id="83" name="Shape 81"/>
+          <p:cNvSpPr/>
+          <p:nvPr/>
+        </p:nvSpPr>
+        <p:spPr>
+          <a:xfrm>
+            <a:off x="6693408" y="5111496"/>
+            <a:ext cx="0" cy="100584"/>
+          </a:xfrm>
+          <a:prstGeom prst="line">
+            <a:avLst/>
+          </a:prstGeom>
+          <a:noFill/>
+          <a:ln w="13335">
+            <a:solidFill>
+              <a:srgbClr val="002FA7"/>
+            </a:solidFill>
+            <a:prstDash val="solid"/>
+            <a:tailEnd type="triangle"/>
+          </a:ln>
+        </p:spPr>
       </p:sp>
     </p:spTree>
   </p:cSld>
@@ -7937,7 +10803,7 @@
                 <a:ea typeface="PingFang SC" pitchFamily="34" charset="-122"/>
                 <a:cs typeface="PingFang SC" pitchFamily="34" charset="-120"/>
               </a:rPr>
-              <a:t>02 / 11</a:t>
+              <a:t>03 / 12</a:t>
             </a:r>
             <a:endParaRPr lang="zh-CN" sz="850" dirty="0"/>
           </a:p>
@@ -8266,7 +11132,7 @@
                 <a:ea typeface="PingFang SC" pitchFamily="34" charset="-122"/>
                 <a:cs typeface="PingFang SC" pitchFamily="34" charset="-120"/>
               </a:rPr>
-              <a:t>03 / 11</a:t>
+              <a:t>04 / 12</a:t>
             </a:r>
             <a:endParaRPr lang="zh-CN" sz="850" dirty="0"/>
           </a:p>
@@ -9382,7 +12248,7 @@
                 <a:ea typeface="PingFang SC" pitchFamily="34" charset="-122"/>
                 <a:cs typeface="PingFang SC" pitchFamily="34" charset="-120"/>
               </a:rPr>
-              <a:t>04 / 11</a:t>
+              <a:t>05 / 12</a:t>
             </a:r>
             <a:endParaRPr lang="zh-CN" sz="850" dirty="0"/>
           </a:p>
@@ -10231,7 +13097,7 @@
                 <a:ea typeface="PingFang SC" pitchFamily="34" charset="-122"/>
                 <a:cs typeface="PingFang SC" pitchFamily="34" charset="-120"/>
               </a:rPr>
-              <a:t>05 / 11</a:t>
+              <a:t>06 / 12</a:t>
             </a:r>
             <a:endParaRPr lang="zh-CN" sz="850" dirty="0"/>
           </a:p>
@@ -11319,7 +14185,7 @@
                 <a:ea typeface="PingFang SC" pitchFamily="34" charset="-122"/>
                 <a:cs typeface="PingFang SC" pitchFamily="34" charset="-120"/>
               </a:rPr>
-              <a:t>06 / 11</a:t>
+              <a:t>07 / 12</a:t>
             </a:r>
             <a:endParaRPr lang="zh-CN" sz="850" dirty="0"/>
           </a:p>
@@ -12061,7 +14927,7 @@
                 <a:ea typeface="PingFang SC" pitchFamily="34" charset="-122"/>
                 <a:cs typeface="PingFang SC" pitchFamily="34" charset="-120"/>
               </a:rPr>
-              <a:t>07 / 11</a:t>
+              <a:t>08 / 12</a:t>
             </a:r>
             <a:endParaRPr lang="zh-CN" sz="850" dirty="0"/>
           </a:p>
@@ -13030,7 +15896,7 @@
                 <a:ea typeface="PingFang SC" pitchFamily="34" charset="-122"/>
                 <a:cs typeface="PingFang SC" pitchFamily="34" charset="-120"/>
               </a:rPr>
-              <a:t>08 / 11</a:t>
+              <a:t>09 / 12</a:t>
             </a:r>
             <a:endParaRPr lang="zh-CN" sz="850" dirty="0"/>
           </a:p>
@@ -14467,7 +17333,7 @@
                 <a:ea typeface="PingFang SC" pitchFamily="34" charset="-122"/>
                 <a:cs typeface="PingFang SC" pitchFamily="34" charset="-120"/>
               </a:rPr>
-              <a:t>09 / 11</a:t>
+              <a:t>10 / 12</a:t>
             </a:r>
             <a:endParaRPr lang="zh-CN" sz="850" dirty="0"/>
           </a:p>

</xml_diff>

<commit_message>
docs: align global view slide with guizang style
</commit_message>
<xml_diff>
--- a/deliverables/talent-development-solution-deck/海格汽车人才发展方案_瑞士风_苹方版.pptx
+++ b/deliverables/talent-development-solution-deck/海格汽车人才发展方案_瑞士风_苹方版.pptx
@@ -7844,7 +7844,7 @@
 
 <file path=ppt/slides/slide12.xml><?xml version="1.0" encoding="utf-8"?>
 <p:sld xmlns:a="http://schemas.openxmlformats.org/drawingml/2006/main" xmlns:r="http://schemas.openxmlformats.org/officeDocument/2006/relationships" xmlns:p="http://schemas.openxmlformats.org/presentationml/2006/main">
-  <p:cSld name="Slide 2">
+  <p:cSld name="Slide 1">
     <p:bg>
       <p:bgPr>
         <a:solidFill>
@@ -7875,7 +7875,7 @@
         <p:spPr>
           <a:xfrm>
             <a:off x="594360" y="384048"/>
-            <a:ext cx="7498080" cy="219456"/>
+            <a:ext cx="8046720" cy="219456"/>
           </a:xfrm>
           <a:prstGeom prst="rect">
             <a:avLst/>
@@ -7891,7 +7891,7 @@
               <a:buNone/>
             </a:pPr>
             <a:r>
-              <a:rPr lang="zh-CN" altLang="en-US" sz="850" b="1" spc="115" kern="0" dirty="0">
+              <a:rPr lang="zh-CN" altLang="en-US" sz="880" b="1" spc="120" kern="0" dirty="0">
                 <a:solidFill>
                   <a:srgbClr val="737373"/>
                 </a:solidFill>
@@ -7899,9 +7899,9 @@
                 <a:ea typeface="PingFang SC" pitchFamily="34" charset="-122"/>
                 <a:cs typeface="PingFang SC" pitchFamily="34" charset="-120"/>
               </a:rPr>
-              <a:t>00 · 全局视图 / BD × OD × TD × LD</a:t>
-            </a:r>
-            <a:endParaRPr lang="zh-CN" sz="850" dirty="0"/>
+              <a:t>00 · 全局视图 / BUSINESS TO CAPABILITY</a:t>
+            </a:r>
+            <a:endParaRPr lang="zh-CN" sz="880" dirty="0"/>
           </a:p>
         </p:txBody>
       </p:sp>
@@ -7930,7 +7930,7 @@
               <a:buNone/>
             </a:pPr>
             <a:r>
-              <a:rPr lang="zh-CN" altLang="en-US" sz="850" b="1" spc="115" kern="0" dirty="0">
+              <a:rPr lang="zh-CN" altLang="en-US" sz="880" b="1" spc="120" kern="0" dirty="0">
                 <a:solidFill>
                   <a:srgbClr val="737373"/>
                 </a:solidFill>
@@ -7940,7 +7940,7 @@
               </a:rPr>
               <a:t>02 / 12</a:t>
             </a:r>
-            <a:endParaRPr lang="zh-CN" sz="850" dirty="0"/>
+            <a:endParaRPr lang="zh-CN" sz="880" dirty="0"/>
           </a:p>
         </p:txBody>
       </p:sp>
@@ -7953,7 +7953,7 @@
         <p:spPr>
           <a:xfrm>
             <a:off x="594360" y="877824"/>
-            <a:ext cx="7315200" cy="219456"/>
+            <a:ext cx="6858000" cy="219456"/>
           </a:xfrm>
           <a:prstGeom prst="rect">
             <a:avLst/>
@@ -7969,7 +7969,7 @@
               <a:buNone/>
             </a:pPr>
             <a:r>
-              <a:rPr lang="zh-CN" altLang="en-US" sz="850" b="1" spc="115" kern="0" dirty="0">
+              <a:rPr lang="zh-CN" altLang="en-US" sz="880" b="1" spc="120" kern="0" dirty="0">
                 <a:solidFill>
                   <a:srgbClr val="737373"/>
                 </a:solidFill>
@@ -7979,7 +7979,7 @@
               </a:rPr>
               <a:t>从业务战略到组织、人才与学习的一体化链路</a:t>
             </a:r>
-            <a:endParaRPr lang="zh-CN" sz="850" dirty="0"/>
+            <a:endParaRPr lang="zh-CN" sz="880" dirty="0"/>
           </a:p>
         </p:txBody>
       </p:sp>
@@ -7992,7 +7992,7 @@
         <p:spPr>
           <a:xfrm>
             <a:off x="594360" y="1078992"/>
-            <a:ext cx="5166360" cy="530352"/>
+            <a:ext cx="5212080" cy="502920"/>
           </a:xfrm>
           <a:prstGeom prst="rect">
             <a:avLst/>
@@ -8032,8 +8032,8 @@
         </p:nvSpPr>
         <p:spPr>
           <a:xfrm>
-            <a:off x="5989320" y="1179576"/>
-            <a:ext cx="5605272" cy="310896"/>
+            <a:off x="6537960" y="1179576"/>
+            <a:ext cx="5056632" cy="274320"/>
           </a:xfrm>
           <a:prstGeom prst="rect">
             <a:avLst/>
@@ -8051,7 +8051,7 @@
               <a:buNone/>
             </a:pPr>
             <a:r>
-              <a:rPr lang="zh-CN" altLang="en-US" sz="1230" dirty="0">
+              <a:rPr lang="zh-CN" altLang="en-US" sz="1180" dirty="0">
                 <a:solidFill>
                   <a:srgbClr val="525252"/>
                 </a:solidFill>
@@ -8061,7 +8061,7 @@
               </a:rPr>
               <a:t>战略定方向，组织定环境，人才定对象，学习定行动。</a:t>
             </a:r>
-            <a:endParaRPr lang="zh-CN" sz="1230" dirty="0"/>
+            <a:endParaRPr lang="zh-CN" sz="1180" dirty="0"/>
           </a:p>
         </p:txBody>
       </p:sp>
@@ -8073,20 +8073,18 @@
         </p:nvSpPr>
         <p:spPr>
           <a:xfrm>
-            <a:off x="594360" y="1792224"/>
-            <a:ext cx="1078992" cy="987552"/>
-          </a:xfrm>
-          <a:prstGeom prst="rect">
-            <a:avLst/>
-          </a:prstGeom>
-          <a:solidFill>
-            <a:srgbClr val="E8EDFF"/>
-          </a:solidFill>
-          <a:ln w="6350">
-            <a:solidFill>
-              <a:srgbClr val="E8EDFF">
-                <a:alpha val="0"/>
-              </a:srgbClr>
+            <a:off x="594360" y="1901952"/>
+            <a:ext cx="1691640" cy="941832"/>
+          </a:xfrm>
+          <a:prstGeom prst="rect">
+            <a:avLst/>
+          </a:prstGeom>
+          <a:solidFill>
+            <a:srgbClr val="0A0A0A"/>
+          </a:solidFill>
+          <a:ln w="5715">
+            <a:solidFill>
+              <a:srgbClr val="D4D4D2"/>
             </a:solidFill>
             <a:prstDash val="solid"/>
           </a:ln>
@@ -8100,8 +8098,8 @@
         </p:nvSpPr>
         <p:spPr>
           <a:xfrm>
-            <a:off x="758952" y="1975104"/>
-            <a:ext cx="749808" cy="219456"/>
+            <a:off x="758952" y="2057400"/>
+            <a:ext cx="566928" cy="219456"/>
           </a:xfrm>
           <a:prstGeom prst="rect">
             <a:avLst/>
@@ -8117,9 +8115,9 @@
               <a:buNone/>
             </a:pPr>
             <a:r>
-              <a:rPr lang="zh-CN" altLang="en-US" sz="850" b="1" spc="115" kern="0" dirty="0">
-                <a:solidFill>
-                  <a:srgbClr val="002FA7"/>
+              <a:rPr lang="zh-CN" altLang="en-US" sz="920" b="1" spc="120" kern="0" dirty="0">
+                <a:solidFill>
+                  <a:srgbClr val="BEBEBA"/>
                 </a:solidFill>
                 <a:latin typeface="PingFang SC" pitchFamily="34" charset="0"/>
                 <a:ea typeface="PingFang SC" pitchFamily="34" charset="-122"/>
@@ -8127,7 +8125,7 @@
               </a:rPr>
               <a:t>BD</a:t>
             </a:r>
-            <a:endParaRPr lang="zh-CN" sz="850" dirty="0"/>
+            <a:endParaRPr lang="zh-CN" sz="920" dirty="0"/>
           </a:p>
         </p:txBody>
       </p:sp>
@@ -8139,8 +8137,8 @@
         </p:nvSpPr>
         <p:spPr>
           <a:xfrm>
-            <a:off x="758952" y="2276856"/>
-            <a:ext cx="749808" cy="274320"/>
+            <a:off x="758952" y="2331720"/>
+            <a:ext cx="1261872" cy="246888"/>
           </a:xfrm>
           <a:prstGeom prst="rect">
             <a:avLst/>
@@ -8158,9 +8156,9 @@
               <a:buNone/>
             </a:pPr>
             <a:r>
-              <a:rPr lang="zh-CN" altLang="en-US" sz="1130" b="1" dirty="0">
-                <a:solidFill>
-                  <a:srgbClr val="002FA7"/>
+              <a:rPr lang="zh-CN" altLang="en-US" sz="1450" dirty="0">
+                <a:solidFill>
+                  <a:srgbClr val="FFFFFF"/>
                 </a:solidFill>
                 <a:latin typeface="PingFang SC" pitchFamily="34" charset="0"/>
                 <a:ea typeface="PingFang SC" pitchFamily="34" charset="-122"/>
@@ -8168,47 +8166,20 @@
               </a:rPr>
               <a:t>业务发展</a:t>
             </a:r>
-            <a:endParaRPr lang="zh-CN" sz="1130" dirty="0"/>
-          </a:p>
-        </p:txBody>
-      </p:sp>
-      <p:sp>
-        <p:nvSpPr>
-          <p:cNvPr id="10" name="Shape 8"/>
-          <p:cNvSpPr/>
-          <p:nvPr/>
-        </p:nvSpPr>
-        <p:spPr>
-          <a:xfrm>
-            <a:off x="594360" y="2871216"/>
-            <a:ext cx="1078992" cy="987552"/>
-          </a:xfrm>
-          <a:prstGeom prst="rect">
-            <a:avLst/>
-          </a:prstGeom>
-          <a:solidFill>
-            <a:srgbClr val="E7F1F0"/>
-          </a:solidFill>
-          <a:ln w="6350">
-            <a:solidFill>
-              <a:srgbClr val="E7F1F0">
-                <a:alpha val="0"/>
-              </a:srgbClr>
-            </a:solidFill>
-            <a:prstDash val="solid"/>
-          </a:ln>
-        </p:spPr>
-      </p:sp>
-      <p:sp>
-        <p:nvSpPr>
-          <p:cNvPr id="11" name="Text 9"/>
-          <p:cNvSpPr txBox="1"/>
-          <p:nvPr/>
-        </p:nvSpPr>
-        <p:spPr>
-          <a:xfrm>
-            <a:off x="758952" y="3054096"/>
-            <a:ext cx="749808" cy="219456"/>
+            <a:endParaRPr lang="zh-CN" sz="1450" dirty="0"/>
+          </a:p>
+        </p:txBody>
+      </p:sp>
+      <p:sp>
+        <p:nvSpPr>
+          <p:cNvPr id="10" name="Text 8"/>
+          <p:cNvSpPr txBox="1"/>
+          <p:nvPr/>
+        </p:nvSpPr>
+        <p:spPr>
+          <a:xfrm>
+            <a:off x="758952" y="2624328"/>
+            <a:ext cx="1243584" cy="219456"/>
           </a:xfrm>
           <a:prstGeom prst="rect">
             <a:avLst/>
@@ -8224,15 +8195,15 @@
               <a:buNone/>
             </a:pPr>
             <a:r>
-              <a:rPr lang="zh-CN" altLang="en-US" sz="850" b="1" spc="115" kern="0" dirty="0">
-                <a:solidFill>
-                  <a:srgbClr val="155E63"/>
-                </a:solidFill>
-                <a:latin typeface="PingFang SC" pitchFamily="34" charset="0"/>
-                <a:ea typeface="PingFang SC" pitchFamily="34" charset="-122"/>
-                <a:cs typeface="PingFang SC" pitchFamily="34" charset="-120"/>
-              </a:rPr>
-              <a:t>OD</a:t>
+              <a:rPr lang="zh-CN" altLang="en-US" sz="850" b="1" spc="120" kern="0" dirty="0">
+                <a:solidFill>
+                  <a:srgbClr val="AFAFAC"/>
+                </a:solidFill>
+                <a:latin typeface="PingFang SC" pitchFamily="34" charset="0"/>
+                <a:ea typeface="PingFang SC" pitchFamily="34" charset="-122"/>
+                <a:cs typeface="PingFang SC" pitchFamily="34" charset="-120"/>
+              </a:rPr>
+              <a:t>定方向</a:t>
             </a:r>
             <a:endParaRPr lang="zh-CN" sz="850" dirty="0"/>
           </a:p>
@@ -8240,14 +8211,78 @@
       </p:sp>
       <p:sp>
         <p:nvSpPr>
+          <p:cNvPr id="11" name="Shape 9"/>
+          <p:cNvSpPr/>
+          <p:nvPr/>
+        </p:nvSpPr>
+        <p:spPr>
+          <a:xfrm>
+            <a:off x="2286000" y="1901952"/>
+            <a:ext cx="3102864" cy="941832"/>
+          </a:xfrm>
+          <a:prstGeom prst="rect">
+            <a:avLst/>
+          </a:prstGeom>
+          <a:solidFill>
+            <a:srgbClr val="FAFAF8"/>
+          </a:solidFill>
+          <a:ln w="5715">
+            <a:solidFill>
+              <a:srgbClr val="D4D4D2"/>
+            </a:solidFill>
+            <a:prstDash val="solid"/>
+          </a:ln>
+        </p:spPr>
+      </p:sp>
+      <p:sp>
+        <p:nvSpPr>
           <p:cNvPr id="12" name="Text 10"/>
           <p:cNvSpPr txBox="1"/>
           <p:nvPr/>
         </p:nvSpPr>
         <p:spPr>
           <a:xfrm>
-            <a:off x="758952" y="3355848"/>
-            <a:ext cx="749808" cy="274320"/>
+            <a:off x="2450592" y="2039112"/>
+            <a:ext cx="804672" cy="219456"/>
+          </a:xfrm>
+          <a:prstGeom prst="rect">
+            <a:avLst/>
+          </a:prstGeom>
+          <a:noFill/>
+          <a:ln/>
+        </p:spPr>
+        <p:txBody>
+          <a:bodyPr wrap="square" lIns="0" tIns="0" rIns="0" bIns="0" rtlCol="0" anchor="ctr"/>
+          <a:lstStyle/>
+          <a:p>
+            <a:pPr algn="l" indent="0" marL="0">
+              <a:buNone/>
+            </a:pPr>
+            <a:r>
+              <a:rPr lang="zh-CN" altLang="en-US" sz="820" b="1" spc="120" kern="0" dirty="0">
+                <a:solidFill>
+                  <a:srgbClr val="737373"/>
+                </a:solidFill>
+                <a:latin typeface="PingFang SC" pitchFamily="34" charset="0"/>
+                <a:ea typeface="PingFang SC" pitchFamily="34" charset="-122"/>
+                <a:cs typeface="PingFang SC" pitchFamily="34" charset="-120"/>
+              </a:rPr>
+              <a:t>01 / BD</a:t>
+            </a:r>
+            <a:endParaRPr lang="zh-CN" sz="820" dirty="0"/>
+          </a:p>
+        </p:txBody>
+      </p:sp>
+      <p:sp>
+        <p:nvSpPr>
+          <p:cNvPr id="13" name="Text 11"/>
+          <p:cNvSpPr txBox="1"/>
+          <p:nvPr/>
+        </p:nvSpPr>
+        <p:spPr>
+          <a:xfrm>
+            <a:off x="2450592" y="2276856"/>
+            <a:ext cx="2773680" cy="246888"/>
           </a:xfrm>
           <a:prstGeom prst="rect">
             <a:avLst/>
@@ -8265,46 +8300,19 @@
               <a:buNone/>
             </a:pPr>
             <a:r>
-              <a:rPr lang="zh-CN" altLang="en-US" sz="1130" b="1" dirty="0">
-                <a:solidFill>
-                  <a:srgbClr val="155E63"/>
-                </a:solidFill>
-                <a:latin typeface="PingFang SC" pitchFamily="34" charset="0"/>
-                <a:ea typeface="PingFang SC" pitchFamily="34" charset="-122"/>
-                <a:cs typeface="PingFang SC" pitchFamily="34" charset="-120"/>
-              </a:rPr>
-              <a:t>组织发展</a:t>
-            </a:r>
-            <a:endParaRPr lang="zh-CN" sz="1130" dirty="0"/>
-          </a:p>
-        </p:txBody>
-      </p:sp>
-      <p:sp>
-        <p:nvSpPr>
-          <p:cNvPr id="13" name="Shape 11"/>
-          <p:cNvSpPr/>
-          <p:nvPr/>
-        </p:nvSpPr>
-        <p:spPr>
-          <a:xfrm>
-            <a:off x="594360" y="3950208"/>
-            <a:ext cx="1078992" cy="1170432"/>
-          </a:xfrm>
-          <a:prstGeom prst="rect">
-            <a:avLst/>
-          </a:prstGeom>
-          <a:solidFill>
-            <a:srgbClr val="EEF3E8"/>
-          </a:solidFill>
-          <a:ln w="6350">
-            <a:solidFill>
-              <a:srgbClr val="EEF3E8">
-                <a:alpha val="0"/>
-              </a:srgbClr>
-            </a:solidFill>
-            <a:prstDash val="solid"/>
-          </a:ln>
-        </p:spPr>
+              <a:rPr lang="zh-CN" altLang="en-US" sz="1360" dirty="0">
+                <a:solidFill>
+                  <a:srgbClr val="0A0A0A"/>
+                </a:solidFill>
+                <a:latin typeface="PingFang SC" pitchFamily="34" charset="0"/>
+                <a:ea typeface="PingFang SC" pitchFamily="34" charset="-122"/>
+                <a:cs typeface="PingFang SC" pitchFamily="34" charset="-120"/>
+              </a:rPr>
+              <a:t>业务盘点</a:t>
+            </a:r>
+            <a:endParaRPr lang="zh-CN" sz="1360" dirty="0"/>
+          </a:p>
+        </p:txBody>
       </p:sp>
       <p:sp>
         <p:nvSpPr>
@@ -8314,8 +8322,74 @@
         </p:nvSpPr>
         <p:spPr>
           <a:xfrm>
-            <a:off x="758952" y="4133088"/>
-            <a:ext cx="749808" cy="219456"/>
+            <a:off x="2450592" y="2578608"/>
+            <a:ext cx="2773680" cy="210312"/>
+          </a:xfrm>
+          <a:prstGeom prst="rect">
+            <a:avLst/>
+          </a:prstGeom>
+          <a:noFill/>
+          <a:ln/>
+        </p:spPr>
+        <p:txBody>
+          <a:bodyPr wrap="square" lIns="0" tIns="0" rIns="0" bIns="0" rtlCol="0" anchor="ctr">
+            <a:normAutofit/>
+          </a:bodyPr>
+          <a:lstStyle/>
+          <a:p>
+            <a:pPr algn="l" indent="0" marL="0">
+              <a:buNone/>
+            </a:pPr>
+            <a:r>
+              <a:rPr lang="zh-CN" altLang="en-US" sz="960" dirty="0">
+                <a:solidFill>
+                  <a:srgbClr val="525252"/>
+                </a:solidFill>
+                <a:latin typeface="PingFang SC" pitchFamily="34" charset="0"/>
+                <a:ea typeface="PingFang SC" pitchFamily="34" charset="-122"/>
+                <a:cs typeface="PingFang SC" pitchFamily="34" charset="-120"/>
+              </a:rPr>
+              <a:t>看清当前业务与人才现状</a:t>
+            </a:r>
+            <a:endParaRPr lang="zh-CN" sz="960" dirty="0"/>
+          </a:p>
+        </p:txBody>
+      </p:sp>
+      <p:sp>
+        <p:nvSpPr>
+          <p:cNvPr id="15" name="Shape 13"/>
+          <p:cNvSpPr/>
+          <p:nvPr/>
+        </p:nvSpPr>
+        <p:spPr>
+          <a:xfrm>
+            <a:off x="5388864" y="1901952"/>
+            <a:ext cx="3102864" cy="941832"/>
+          </a:xfrm>
+          <a:prstGeom prst="rect">
+            <a:avLst/>
+          </a:prstGeom>
+          <a:solidFill>
+            <a:srgbClr val="FAFAF8"/>
+          </a:solidFill>
+          <a:ln w="5715">
+            <a:solidFill>
+              <a:srgbClr val="D4D4D2"/>
+            </a:solidFill>
+            <a:prstDash val="solid"/>
+          </a:ln>
+        </p:spPr>
+      </p:sp>
+      <p:sp>
+        <p:nvSpPr>
+          <p:cNvPr id="16" name="Text 14"/>
+          <p:cNvSpPr txBox="1"/>
+          <p:nvPr/>
+        </p:nvSpPr>
+        <p:spPr>
+          <a:xfrm>
+            <a:off x="5553456" y="2039112"/>
+            <a:ext cx="804672" cy="219456"/>
           </a:xfrm>
           <a:prstGeom prst="rect">
             <a:avLst/>
@@ -8331,30 +8405,30 @@
               <a:buNone/>
             </a:pPr>
             <a:r>
-              <a:rPr lang="zh-CN" altLang="en-US" sz="850" b="1" spc="115" kern="0" dirty="0">
-                <a:solidFill>
-                  <a:srgbClr val="44652B"/>
-                </a:solidFill>
-                <a:latin typeface="PingFang SC" pitchFamily="34" charset="0"/>
-                <a:ea typeface="PingFang SC" pitchFamily="34" charset="-122"/>
-                <a:cs typeface="PingFang SC" pitchFamily="34" charset="-120"/>
-              </a:rPr>
-              <a:t>TD</a:t>
-            </a:r>
-            <a:endParaRPr lang="zh-CN" sz="850" dirty="0"/>
-          </a:p>
-        </p:txBody>
-      </p:sp>
-      <p:sp>
-        <p:nvSpPr>
-          <p:cNvPr id="15" name="Text 13"/>
-          <p:cNvSpPr txBox="1"/>
-          <p:nvPr/>
-        </p:nvSpPr>
-        <p:spPr>
-          <a:xfrm>
-            <a:off x="758952" y="4434840"/>
-            <a:ext cx="749808" cy="274320"/>
+              <a:rPr lang="zh-CN" altLang="en-US" sz="820" b="1" spc="120" kern="0" dirty="0">
+                <a:solidFill>
+                  <a:srgbClr val="737373"/>
+                </a:solidFill>
+                <a:latin typeface="PingFang SC" pitchFamily="34" charset="0"/>
+                <a:ea typeface="PingFang SC" pitchFamily="34" charset="-122"/>
+                <a:cs typeface="PingFang SC" pitchFamily="34" charset="-120"/>
+              </a:rPr>
+              <a:t>02 / BD</a:t>
+            </a:r>
+            <a:endParaRPr lang="zh-CN" sz="820" dirty="0"/>
+          </a:p>
+        </p:txBody>
+      </p:sp>
+      <p:sp>
+        <p:nvSpPr>
+          <p:cNvPr id="17" name="Text 15"/>
+          <p:cNvSpPr txBox="1"/>
+          <p:nvPr/>
+        </p:nvSpPr>
+        <p:spPr>
+          <a:xfrm>
+            <a:off x="5553456" y="2276856"/>
+            <a:ext cx="2773680" cy="246888"/>
           </a:xfrm>
           <a:prstGeom prst="rect">
             <a:avLst/>
@@ -8372,57 +8446,96 @@
               <a:buNone/>
             </a:pPr>
             <a:r>
-              <a:rPr lang="zh-CN" altLang="en-US" sz="1130" b="1" dirty="0">
-                <a:solidFill>
-                  <a:srgbClr val="44652B"/>
-                </a:solidFill>
-                <a:latin typeface="PingFang SC" pitchFamily="34" charset="0"/>
-                <a:ea typeface="PingFang SC" pitchFamily="34" charset="-122"/>
-                <a:cs typeface="PingFang SC" pitchFamily="34" charset="-120"/>
-              </a:rPr>
-              <a:t>人才发展</a:t>
-            </a:r>
-            <a:endParaRPr lang="zh-CN" sz="1130" dirty="0"/>
-          </a:p>
-        </p:txBody>
-      </p:sp>
-      <p:sp>
-        <p:nvSpPr>
-          <p:cNvPr id="16" name="Shape 14"/>
-          <p:cNvSpPr/>
-          <p:nvPr/>
-        </p:nvSpPr>
-        <p:spPr>
-          <a:xfrm>
-            <a:off x="594360" y="5212080"/>
-            <a:ext cx="1078992" cy="987552"/>
-          </a:xfrm>
-          <a:prstGeom prst="rect">
-            <a:avLst/>
-          </a:prstGeom>
-          <a:solidFill>
-            <a:srgbClr val="F6ECE4"/>
-          </a:solidFill>
-          <a:ln w="6350">
-            <a:solidFill>
-              <a:srgbClr val="F6ECE4">
-                <a:alpha val="0"/>
-              </a:srgbClr>
-            </a:solidFill>
-            <a:prstDash val="solid"/>
-          </a:ln>
-        </p:spPr>
-      </p:sp>
-      <p:sp>
-        <p:nvSpPr>
-          <p:cNvPr id="17" name="Text 15"/>
-          <p:cNvSpPr txBox="1"/>
-          <p:nvPr/>
-        </p:nvSpPr>
-        <p:spPr>
-          <a:xfrm>
-            <a:off x="758952" y="5394960"/>
-            <a:ext cx="749808" cy="219456"/>
+              <a:rPr lang="zh-CN" altLang="en-US" sz="1360" dirty="0">
+                <a:solidFill>
+                  <a:srgbClr val="0A0A0A"/>
+                </a:solidFill>
+                <a:latin typeface="PingFang SC" pitchFamily="34" charset="0"/>
+                <a:ea typeface="PingFang SC" pitchFamily="34" charset="-122"/>
+                <a:cs typeface="PingFang SC" pitchFamily="34" charset="-120"/>
+              </a:rPr>
+              <a:t>战略规划</a:t>
+            </a:r>
+            <a:endParaRPr lang="zh-CN" sz="1360" dirty="0"/>
+          </a:p>
+        </p:txBody>
+      </p:sp>
+      <p:sp>
+        <p:nvSpPr>
+          <p:cNvPr id="18" name="Text 16"/>
+          <p:cNvSpPr txBox="1"/>
+          <p:nvPr/>
+        </p:nvSpPr>
+        <p:spPr>
+          <a:xfrm>
+            <a:off x="5553456" y="2578608"/>
+            <a:ext cx="2773680" cy="210312"/>
+          </a:xfrm>
+          <a:prstGeom prst="rect">
+            <a:avLst/>
+          </a:prstGeom>
+          <a:noFill/>
+          <a:ln/>
+        </p:spPr>
+        <p:txBody>
+          <a:bodyPr wrap="square" lIns="0" tIns="0" rIns="0" bIns="0" rtlCol="0" anchor="ctr">
+            <a:normAutofit/>
+          </a:bodyPr>
+          <a:lstStyle/>
+          <a:p>
+            <a:pPr algn="l" indent="0" marL="0">
+              <a:buNone/>
+            </a:pPr>
+            <a:r>
+              <a:rPr lang="zh-CN" altLang="en-US" sz="960" dirty="0">
+                <a:solidFill>
+                  <a:srgbClr val="525252"/>
+                </a:solidFill>
+                <a:latin typeface="PingFang SC" pitchFamily="34" charset="0"/>
+                <a:ea typeface="PingFang SC" pitchFamily="34" charset="-122"/>
+                <a:cs typeface="PingFang SC" pitchFamily="34" charset="-120"/>
+              </a:rPr>
+              <a:t>明确业务重点与优先级</a:t>
+            </a:r>
+            <a:endParaRPr lang="zh-CN" sz="960" dirty="0"/>
+          </a:p>
+        </p:txBody>
+      </p:sp>
+      <p:sp>
+        <p:nvSpPr>
+          <p:cNvPr id="19" name="Shape 17"/>
+          <p:cNvSpPr/>
+          <p:nvPr/>
+        </p:nvSpPr>
+        <p:spPr>
+          <a:xfrm>
+            <a:off x="8491728" y="1901952"/>
+            <a:ext cx="3102864" cy="941832"/>
+          </a:xfrm>
+          <a:prstGeom prst="rect">
+            <a:avLst/>
+          </a:prstGeom>
+          <a:solidFill>
+            <a:srgbClr val="FAFAF8"/>
+          </a:solidFill>
+          <a:ln w="5715">
+            <a:solidFill>
+              <a:srgbClr val="D4D4D2"/>
+            </a:solidFill>
+            <a:prstDash val="solid"/>
+          </a:ln>
+        </p:spPr>
+      </p:sp>
+      <p:sp>
+        <p:nvSpPr>
+          <p:cNvPr id="20" name="Text 18"/>
+          <p:cNvSpPr txBox="1"/>
+          <p:nvPr/>
+        </p:nvSpPr>
+        <p:spPr>
+          <a:xfrm>
+            <a:off x="8656320" y="2039112"/>
+            <a:ext cx="804672" cy="219456"/>
           </a:xfrm>
           <a:prstGeom prst="rect">
             <a:avLst/>
@@ -8438,30 +8551,30 @@
               <a:buNone/>
             </a:pPr>
             <a:r>
-              <a:rPr lang="zh-CN" altLang="en-US" sz="850" b="1" spc="115" kern="0" dirty="0">
-                <a:solidFill>
-                  <a:srgbClr val="8B4A20"/>
-                </a:solidFill>
-                <a:latin typeface="PingFang SC" pitchFamily="34" charset="0"/>
-                <a:ea typeface="PingFang SC" pitchFamily="34" charset="-122"/>
-                <a:cs typeface="PingFang SC" pitchFamily="34" charset="-120"/>
-              </a:rPr>
-              <a:t>LD</a:t>
-            </a:r>
-            <a:endParaRPr lang="zh-CN" sz="850" dirty="0"/>
-          </a:p>
-        </p:txBody>
-      </p:sp>
-      <p:sp>
-        <p:nvSpPr>
-          <p:cNvPr id="18" name="Text 16"/>
-          <p:cNvSpPr txBox="1"/>
-          <p:nvPr/>
-        </p:nvSpPr>
-        <p:spPr>
-          <a:xfrm>
-            <a:off x="758952" y="5696712"/>
-            <a:ext cx="749808" cy="274320"/>
+              <a:rPr lang="zh-CN" altLang="en-US" sz="820" b="1" spc="120" kern="0" dirty="0">
+                <a:solidFill>
+                  <a:srgbClr val="737373"/>
+                </a:solidFill>
+                <a:latin typeface="PingFang SC" pitchFamily="34" charset="0"/>
+                <a:ea typeface="PingFang SC" pitchFamily="34" charset="-122"/>
+                <a:cs typeface="PingFang SC" pitchFamily="34" charset="-120"/>
+              </a:rPr>
+              <a:t>03 / BD</a:t>
+            </a:r>
+            <a:endParaRPr lang="zh-CN" sz="820" dirty="0"/>
+          </a:p>
+        </p:txBody>
+      </p:sp>
+      <p:sp>
+        <p:nvSpPr>
+          <p:cNvPr id="21" name="Text 19"/>
+          <p:cNvSpPr txBox="1"/>
+          <p:nvPr/>
+        </p:nvSpPr>
+        <p:spPr>
+          <a:xfrm>
+            <a:off x="8656320" y="2276856"/>
+            <a:ext cx="2773680" cy="246888"/>
           </a:xfrm>
           <a:prstGeom prst="rect">
             <a:avLst/>
@@ -8479,38 +8592,79 @@
               <a:buNone/>
             </a:pPr>
             <a:r>
-              <a:rPr lang="zh-CN" altLang="en-US" sz="1130" b="1" dirty="0">
-                <a:solidFill>
-                  <a:srgbClr val="8B4A20"/>
-                </a:solidFill>
-                <a:latin typeface="PingFang SC" pitchFamily="34" charset="0"/>
-                <a:ea typeface="PingFang SC" pitchFamily="34" charset="-122"/>
-                <a:cs typeface="PingFang SC" pitchFamily="34" charset="-120"/>
-              </a:rPr>
-              <a:t>学习发展</a:t>
-            </a:r>
-            <a:endParaRPr lang="zh-CN" sz="1130" dirty="0"/>
-          </a:p>
-        </p:txBody>
-      </p:sp>
-      <p:sp>
-        <p:nvSpPr>
-          <p:cNvPr id="19" name="Shape 17"/>
-          <p:cNvSpPr/>
-          <p:nvPr/>
-        </p:nvSpPr>
-        <p:spPr>
-          <a:xfrm>
-            <a:off x="1874520" y="1792224"/>
-            <a:ext cx="9720072" cy="987552"/>
-          </a:xfrm>
-          <a:prstGeom prst="rect">
-            <a:avLst/>
-          </a:prstGeom>
-          <a:solidFill>
-            <a:srgbClr val="FFFFFF"/>
-          </a:solidFill>
-          <a:ln w="8255">
+              <a:rPr lang="zh-CN" altLang="en-US" sz="1360" dirty="0">
+                <a:solidFill>
+                  <a:srgbClr val="0A0A0A"/>
+                </a:solidFill>
+                <a:latin typeface="PingFang SC" pitchFamily="34" charset="0"/>
+                <a:ea typeface="PingFang SC" pitchFamily="34" charset="-122"/>
+                <a:cs typeface="PingFang SC" pitchFamily="34" charset="-120"/>
+              </a:rPr>
+              <a:t>战略解码</a:t>
+            </a:r>
+            <a:endParaRPr lang="zh-CN" sz="1360" dirty="0"/>
+          </a:p>
+        </p:txBody>
+      </p:sp>
+      <p:sp>
+        <p:nvSpPr>
+          <p:cNvPr id="22" name="Text 20"/>
+          <p:cNvSpPr txBox="1"/>
+          <p:nvPr/>
+        </p:nvSpPr>
+        <p:spPr>
+          <a:xfrm>
+            <a:off x="8656320" y="2578608"/>
+            <a:ext cx="2773680" cy="210312"/>
+          </a:xfrm>
+          <a:prstGeom prst="rect">
+            <a:avLst/>
+          </a:prstGeom>
+          <a:noFill/>
+          <a:ln/>
+        </p:spPr>
+        <p:txBody>
+          <a:bodyPr wrap="square" lIns="0" tIns="0" rIns="0" bIns="0" rtlCol="0" anchor="ctr">
+            <a:normAutofit/>
+          </a:bodyPr>
+          <a:lstStyle/>
+          <a:p>
+            <a:pPr algn="l" indent="0" marL="0">
+              <a:buNone/>
+            </a:pPr>
+            <a:r>
+              <a:rPr lang="zh-CN" altLang="en-US" sz="960" dirty="0">
+                <a:solidFill>
+                  <a:srgbClr val="525252"/>
+                </a:solidFill>
+                <a:latin typeface="PingFang SC" pitchFamily="34" charset="0"/>
+                <a:ea typeface="PingFang SC" pitchFamily="34" charset="-122"/>
+                <a:cs typeface="PingFang SC" pitchFamily="34" charset="-120"/>
+              </a:rPr>
+              <a:t>转为组织与人才任务</a:t>
+            </a:r>
+            <a:endParaRPr lang="zh-CN" sz="960" dirty="0"/>
+          </a:p>
+        </p:txBody>
+      </p:sp>
+      <p:sp>
+        <p:nvSpPr>
+          <p:cNvPr id="23" name="Shape 21"/>
+          <p:cNvSpPr/>
+          <p:nvPr/>
+        </p:nvSpPr>
+        <p:spPr>
+          <a:xfrm>
+            <a:off x="594360" y="2843784"/>
+            <a:ext cx="1691640" cy="941832"/>
+          </a:xfrm>
+          <a:prstGeom prst="rect">
+            <a:avLst/>
+          </a:prstGeom>
+          <a:solidFill>
+            <a:srgbClr val="0A0A0A"/>
+          </a:solidFill>
+          <a:ln w="5715">
             <a:solidFill>
               <a:srgbClr val="D4D4D2"/>
             </a:solidFill>
@@ -8520,14 +8674,14 @@
       </p:sp>
       <p:sp>
         <p:nvSpPr>
-          <p:cNvPr id="20" name="Text 18"/>
-          <p:cNvSpPr txBox="1"/>
-          <p:nvPr/>
-        </p:nvSpPr>
-        <p:spPr>
-          <a:xfrm>
-            <a:off x="2103120" y="1993392"/>
-            <a:ext cx="347472" cy="219456"/>
+          <p:cNvPr id="24" name="Text 22"/>
+          <p:cNvSpPr txBox="1"/>
+          <p:nvPr/>
+        </p:nvSpPr>
+        <p:spPr>
+          <a:xfrm>
+            <a:off x="758952" y="2999232"/>
+            <a:ext cx="566928" cy="219456"/>
           </a:xfrm>
           <a:prstGeom prst="rect">
             <a:avLst/>
@@ -8543,30 +8697,30 @@
               <a:buNone/>
             </a:pPr>
             <a:r>
-              <a:rPr lang="zh-CN" altLang="en-US" sz="850" b="1" spc="115" kern="0" dirty="0">
-                <a:solidFill>
-                  <a:srgbClr val="002FA7"/>
-                </a:solidFill>
-                <a:latin typeface="PingFang SC" pitchFamily="34" charset="0"/>
-                <a:ea typeface="PingFang SC" pitchFamily="34" charset="-122"/>
-                <a:cs typeface="PingFang SC" pitchFamily="34" charset="-120"/>
-              </a:rPr>
-              <a:t>01</a:t>
-            </a:r>
-            <a:endParaRPr lang="zh-CN" sz="850" dirty="0"/>
-          </a:p>
-        </p:txBody>
-      </p:sp>
-      <p:sp>
-        <p:nvSpPr>
-          <p:cNvPr id="21" name="Text 19"/>
-          <p:cNvSpPr txBox="1"/>
-          <p:nvPr/>
-        </p:nvSpPr>
-        <p:spPr>
-          <a:xfrm>
-            <a:off x="2542032" y="1929384"/>
-            <a:ext cx="1234440" cy="274320"/>
+              <a:rPr lang="zh-CN" altLang="en-US" sz="920" b="1" spc="120" kern="0" dirty="0">
+                <a:solidFill>
+                  <a:srgbClr val="BEBEBA"/>
+                </a:solidFill>
+                <a:latin typeface="PingFang SC" pitchFamily="34" charset="0"/>
+                <a:ea typeface="PingFang SC" pitchFamily="34" charset="-122"/>
+                <a:cs typeface="PingFang SC" pitchFamily="34" charset="-120"/>
+              </a:rPr>
+              <a:t>OD</a:t>
+            </a:r>
+            <a:endParaRPr lang="zh-CN" sz="920" dirty="0"/>
+          </a:p>
+        </p:txBody>
+      </p:sp>
+      <p:sp>
+        <p:nvSpPr>
+          <p:cNvPr id="25" name="Text 23"/>
+          <p:cNvSpPr txBox="1"/>
+          <p:nvPr/>
+        </p:nvSpPr>
+        <p:spPr>
+          <a:xfrm>
+            <a:off x="758952" y="3273552"/>
+            <a:ext cx="1261872" cy="246888"/>
           </a:xfrm>
           <a:prstGeom prst="rect">
             <a:avLst/>
@@ -8584,30 +8738,133 @@
               <a:buNone/>
             </a:pPr>
             <a:r>
-              <a:rPr lang="zh-CN" altLang="en-US" sz="1320" b="1" dirty="0">
-                <a:solidFill>
-                  <a:srgbClr val="0A0A0A"/>
-                </a:solidFill>
-                <a:latin typeface="PingFang SC" pitchFamily="34" charset="0"/>
-                <a:ea typeface="PingFang SC" pitchFamily="34" charset="-122"/>
-                <a:cs typeface="PingFang SC" pitchFamily="34" charset="-120"/>
-              </a:rPr>
-              <a:t>业务盘点</a:t>
-            </a:r>
-            <a:endParaRPr lang="zh-CN" sz="1320" dirty="0"/>
-          </a:p>
-        </p:txBody>
-      </p:sp>
-      <p:sp>
-        <p:nvSpPr>
-          <p:cNvPr id="22" name="Text 20"/>
-          <p:cNvSpPr txBox="1"/>
-          <p:nvPr/>
-        </p:nvSpPr>
-        <p:spPr>
-          <a:xfrm>
-            <a:off x="3749040" y="1947672"/>
-            <a:ext cx="1143000" cy="237744"/>
+              <a:rPr lang="zh-CN" altLang="en-US" sz="1450" dirty="0">
+                <a:solidFill>
+                  <a:srgbClr val="FFFFFF"/>
+                </a:solidFill>
+                <a:latin typeface="PingFang SC" pitchFamily="34" charset="0"/>
+                <a:ea typeface="PingFang SC" pitchFamily="34" charset="-122"/>
+                <a:cs typeface="PingFang SC" pitchFamily="34" charset="-120"/>
+              </a:rPr>
+              <a:t>组织发展</a:t>
+            </a:r>
+            <a:endParaRPr lang="zh-CN" sz="1450" dirty="0"/>
+          </a:p>
+        </p:txBody>
+      </p:sp>
+      <p:sp>
+        <p:nvSpPr>
+          <p:cNvPr id="26" name="Text 24"/>
+          <p:cNvSpPr txBox="1"/>
+          <p:nvPr/>
+        </p:nvSpPr>
+        <p:spPr>
+          <a:xfrm>
+            <a:off x="758952" y="3566160"/>
+            <a:ext cx="1243584" cy="219456"/>
+          </a:xfrm>
+          <a:prstGeom prst="rect">
+            <a:avLst/>
+          </a:prstGeom>
+          <a:noFill/>
+          <a:ln/>
+        </p:spPr>
+        <p:txBody>
+          <a:bodyPr wrap="square" lIns="0" tIns="0" rIns="0" bIns="0" rtlCol="0" anchor="ctr"/>
+          <a:lstStyle/>
+          <a:p>
+            <a:pPr algn="l" indent="0" marL="0">
+              <a:buNone/>
+            </a:pPr>
+            <a:r>
+              <a:rPr lang="zh-CN" altLang="en-US" sz="850" b="1" spc="120" kern="0" dirty="0">
+                <a:solidFill>
+                  <a:srgbClr val="AFAFAC"/>
+                </a:solidFill>
+                <a:latin typeface="PingFang SC" pitchFamily="34" charset="0"/>
+                <a:ea typeface="PingFang SC" pitchFamily="34" charset="-122"/>
+                <a:cs typeface="PingFang SC" pitchFamily="34" charset="-120"/>
+              </a:rPr>
+              <a:t>定环境</a:t>
+            </a:r>
+            <a:endParaRPr lang="zh-CN" sz="850" dirty="0"/>
+          </a:p>
+        </p:txBody>
+      </p:sp>
+      <p:sp>
+        <p:nvSpPr>
+          <p:cNvPr id="27" name="Shape 25"/>
+          <p:cNvSpPr/>
+          <p:nvPr/>
+        </p:nvSpPr>
+        <p:spPr>
+          <a:xfrm>
+            <a:off x="2286000" y="2843784"/>
+            <a:ext cx="3102864" cy="941832"/>
+          </a:xfrm>
+          <a:prstGeom prst="rect">
+            <a:avLst/>
+          </a:prstGeom>
+          <a:solidFill>
+            <a:srgbClr val="F0F0EE"/>
+          </a:solidFill>
+          <a:ln w="5715">
+            <a:solidFill>
+              <a:srgbClr val="D4D4D2"/>
+            </a:solidFill>
+            <a:prstDash val="solid"/>
+          </a:ln>
+        </p:spPr>
+      </p:sp>
+      <p:sp>
+        <p:nvSpPr>
+          <p:cNvPr id="28" name="Text 26"/>
+          <p:cNvSpPr txBox="1"/>
+          <p:nvPr/>
+        </p:nvSpPr>
+        <p:spPr>
+          <a:xfrm>
+            <a:off x="2450592" y="2980944"/>
+            <a:ext cx="804672" cy="219456"/>
+          </a:xfrm>
+          <a:prstGeom prst="rect">
+            <a:avLst/>
+          </a:prstGeom>
+          <a:noFill/>
+          <a:ln/>
+        </p:spPr>
+        <p:txBody>
+          <a:bodyPr wrap="square" lIns="0" tIns="0" rIns="0" bIns="0" rtlCol="0" anchor="ctr"/>
+          <a:lstStyle/>
+          <a:p>
+            <a:pPr algn="l" indent="0" marL="0">
+              <a:buNone/>
+            </a:pPr>
+            <a:r>
+              <a:rPr lang="zh-CN" altLang="en-US" sz="820" b="1" spc="120" kern="0" dirty="0">
+                <a:solidFill>
+                  <a:srgbClr val="737373"/>
+                </a:solidFill>
+                <a:latin typeface="PingFang SC" pitchFamily="34" charset="0"/>
+                <a:ea typeface="PingFang SC" pitchFamily="34" charset="-122"/>
+                <a:cs typeface="PingFang SC" pitchFamily="34" charset="-120"/>
+              </a:rPr>
+              <a:t>01 / OD</a:t>
+            </a:r>
+            <a:endParaRPr lang="zh-CN" sz="820" dirty="0"/>
+          </a:p>
+        </p:txBody>
+      </p:sp>
+      <p:sp>
+        <p:nvSpPr>
+          <p:cNvPr id="29" name="Text 27"/>
+          <p:cNvSpPr txBox="1"/>
+          <p:nvPr/>
+        </p:nvSpPr>
+        <p:spPr>
+          <a:xfrm>
+            <a:off x="2450592" y="3218688"/>
+            <a:ext cx="2773680" cy="246888"/>
           </a:xfrm>
           <a:prstGeom prst="rect">
             <a:avLst/>
@@ -8625,7 +8882,112 @@
               <a:buNone/>
             </a:pPr>
             <a:r>
-              <a:rPr lang="zh-CN" altLang="en-US" sz="1020" dirty="0">
+              <a:rPr lang="zh-CN" altLang="en-US" sz="1360" dirty="0">
+                <a:solidFill>
+                  <a:srgbClr val="0A0A0A"/>
+                </a:solidFill>
+                <a:latin typeface="PingFang SC" pitchFamily="34" charset="0"/>
+                <a:ea typeface="PingFang SC" pitchFamily="34" charset="-122"/>
+                <a:cs typeface="PingFang SC" pitchFamily="34" charset="-120"/>
+              </a:rPr>
+              <a:t>结构与机制</a:t>
+            </a:r>
+            <a:endParaRPr lang="zh-CN" sz="1360" dirty="0"/>
+          </a:p>
+        </p:txBody>
+      </p:sp>
+      <p:sp>
+        <p:nvSpPr>
+          <p:cNvPr id="30" name="Text 28"/>
+          <p:cNvSpPr txBox="1"/>
+          <p:nvPr/>
+        </p:nvSpPr>
+        <p:spPr>
+          <a:xfrm>
+            <a:off x="2450592" y="3520440"/>
+            <a:ext cx="2773680" cy="210312"/>
+          </a:xfrm>
+          <a:prstGeom prst="rect">
+            <a:avLst/>
+          </a:prstGeom>
+          <a:noFill/>
+          <a:ln/>
+        </p:spPr>
+        <p:txBody>
+          <a:bodyPr wrap="square" lIns="0" tIns="0" rIns="0" bIns="0" rtlCol="0" anchor="ctr">
+            <a:normAutofit/>
+          </a:bodyPr>
+          <a:lstStyle/>
+          <a:p>
+            <a:pPr algn="l" indent="0" marL="0">
+              <a:buNone/>
+            </a:pPr>
+            <a:r>
+              <a:rPr lang="zh-CN" altLang="en-US" sz="960" dirty="0">
+                <a:solidFill>
+                  <a:srgbClr val="525252"/>
+                </a:solidFill>
+                <a:latin typeface="PingFang SC" pitchFamily="34" charset="0"/>
+                <a:ea typeface="PingFang SC" pitchFamily="34" charset="-122"/>
+                <a:cs typeface="PingFang SC" pitchFamily="34" charset="-120"/>
+              </a:rPr>
+              <a:t>组织结构、岗位分布与关键机制</a:t>
+            </a:r>
+            <a:endParaRPr lang="zh-CN" sz="960" dirty="0"/>
+          </a:p>
+        </p:txBody>
+      </p:sp>
+      <p:sp>
+        <p:nvSpPr>
+          <p:cNvPr id="31" name="Shape 29"/>
+          <p:cNvSpPr/>
+          <p:nvPr/>
+        </p:nvSpPr>
+        <p:spPr>
+          <a:xfrm>
+            <a:off x="5388864" y="2843784"/>
+            <a:ext cx="3102864" cy="941832"/>
+          </a:xfrm>
+          <a:prstGeom prst="rect">
+            <a:avLst/>
+          </a:prstGeom>
+          <a:solidFill>
+            <a:srgbClr val="F0F0EE"/>
+          </a:solidFill>
+          <a:ln w="5715">
+            <a:solidFill>
+              <a:srgbClr val="D4D4D2"/>
+            </a:solidFill>
+            <a:prstDash val="solid"/>
+          </a:ln>
+        </p:spPr>
+      </p:sp>
+      <p:sp>
+        <p:nvSpPr>
+          <p:cNvPr id="32" name="Text 30"/>
+          <p:cNvSpPr txBox="1"/>
+          <p:nvPr/>
+        </p:nvSpPr>
+        <p:spPr>
+          <a:xfrm>
+            <a:off x="5553456" y="2980944"/>
+            <a:ext cx="804672" cy="219456"/>
+          </a:xfrm>
+          <a:prstGeom prst="rect">
+            <a:avLst/>
+          </a:prstGeom>
+          <a:noFill/>
+          <a:ln/>
+        </p:spPr>
+        <p:txBody>
+          <a:bodyPr wrap="square" lIns="0" tIns="0" rIns="0" bIns="0" rtlCol="0" anchor="ctr"/>
+          <a:lstStyle/>
+          <a:p>
+            <a:pPr algn="l" indent="0" marL="0">
+              <a:buNone/>
+            </a:pPr>
+            <a:r>
+              <a:rPr lang="zh-CN" altLang="en-US" sz="820" b="1" spc="120" kern="0" dirty="0">
                 <a:solidFill>
                   <a:srgbClr val="737373"/>
                 </a:solidFill>
@@ -8633,85 +8995,22 @@
                 <a:ea typeface="PingFang SC" pitchFamily="34" charset="-122"/>
                 <a:cs typeface="PingFang SC" pitchFamily="34" charset="-120"/>
               </a:rPr>
-              <a:t>看清现状</a:t>
-            </a:r>
-            <a:endParaRPr lang="zh-CN" sz="1020" dirty="0"/>
-          </a:p>
-        </p:txBody>
-      </p:sp>
-      <p:sp>
-        <p:nvSpPr>
-          <p:cNvPr id="23" name="Shape 21"/>
-          <p:cNvSpPr/>
-          <p:nvPr/>
-        </p:nvSpPr>
-        <p:spPr>
-          <a:xfrm>
-            <a:off x="4873752" y="2267712"/>
-            <a:ext cx="283464" cy="0"/>
-          </a:xfrm>
-          <a:prstGeom prst="line">
-            <a:avLst/>
-          </a:prstGeom>
-          <a:noFill/>
-          <a:ln w="11430">
-            <a:solidFill>
-              <a:srgbClr val="002FA7"/>
-            </a:solidFill>
-            <a:prstDash val="solid"/>
-            <a:tailEnd type="triangle"/>
-          </a:ln>
-        </p:spPr>
-      </p:sp>
-      <p:sp>
-        <p:nvSpPr>
-          <p:cNvPr id="24" name="Text 22"/>
-          <p:cNvSpPr txBox="1"/>
-          <p:nvPr/>
-        </p:nvSpPr>
-        <p:spPr>
-          <a:xfrm>
-            <a:off x="5257800" y="1993392"/>
-            <a:ext cx="347472" cy="219456"/>
-          </a:xfrm>
-          <a:prstGeom prst="rect">
-            <a:avLst/>
-          </a:prstGeom>
-          <a:noFill/>
-          <a:ln/>
-        </p:spPr>
-        <p:txBody>
-          <a:bodyPr wrap="square" lIns="0" tIns="0" rIns="0" bIns="0" rtlCol="0" anchor="ctr"/>
-          <a:lstStyle/>
-          <a:p>
-            <a:pPr algn="l" indent="0" marL="0">
-              <a:buNone/>
-            </a:pPr>
-            <a:r>
-              <a:rPr lang="zh-CN" altLang="en-US" sz="850" b="1" spc="115" kern="0" dirty="0">
-                <a:solidFill>
-                  <a:srgbClr val="002FA7"/>
-                </a:solidFill>
-                <a:latin typeface="PingFang SC" pitchFamily="34" charset="0"/>
-                <a:ea typeface="PingFang SC" pitchFamily="34" charset="-122"/>
-                <a:cs typeface="PingFang SC" pitchFamily="34" charset="-120"/>
-              </a:rPr>
-              <a:t>02</a:t>
-            </a:r>
-            <a:endParaRPr lang="zh-CN" sz="850" dirty="0"/>
-          </a:p>
-        </p:txBody>
-      </p:sp>
-      <p:sp>
-        <p:nvSpPr>
-          <p:cNvPr id="25" name="Text 23"/>
-          <p:cNvSpPr txBox="1"/>
-          <p:nvPr/>
-        </p:nvSpPr>
-        <p:spPr>
-          <a:xfrm>
-            <a:off x="5696712" y="1929384"/>
-            <a:ext cx="1234440" cy="274320"/>
+              <a:t>02 / OD</a:t>
+            </a:r>
+            <a:endParaRPr lang="zh-CN" sz="820" dirty="0"/>
+          </a:p>
+        </p:txBody>
+      </p:sp>
+      <p:sp>
+        <p:nvSpPr>
+          <p:cNvPr id="33" name="Text 31"/>
+          <p:cNvSpPr txBox="1"/>
+          <p:nvPr/>
+        </p:nvSpPr>
+        <p:spPr>
+          <a:xfrm>
+            <a:off x="5553456" y="3218688"/>
+            <a:ext cx="2773680" cy="246888"/>
           </a:xfrm>
           <a:prstGeom prst="rect">
             <a:avLst/>
@@ -8729,7 +9028,7 @@
               <a:buNone/>
             </a:pPr>
             <a:r>
-              <a:rPr lang="zh-CN" altLang="en-US" sz="1320" b="1" dirty="0">
+              <a:rPr lang="zh-CN" altLang="en-US" sz="1360" dirty="0">
                 <a:solidFill>
                   <a:srgbClr val="0A0A0A"/>
                 </a:solidFill>
@@ -8737,22 +9036,127 @@
                 <a:ea typeface="PingFang SC" pitchFamily="34" charset="-122"/>
                 <a:cs typeface="PingFang SC" pitchFamily="34" charset="-120"/>
               </a:rPr>
-              <a:t>战略规划</a:t>
-            </a:r>
-            <a:endParaRPr lang="zh-CN" sz="1320" dirty="0"/>
-          </a:p>
-        </p:txBody>
-      </p:sp>
-      <p:sp>
-        <p:nvSpPr>
-          <p:cNvPr id="26" name="Text 24"/>
-          <p:cNvSpPr txBox="1"/>
-          <p:nvPr/>
-        </p:nvSpPr>
-        <p:spPr>
-          <a:xfrm>
-            <a:off x="6903720" y="1947672"/>
-            <a:ext cx="1143000" cy="237744"/>
+              <a:t>目标与绩效</a:t>
+            </a:r>
+            <a:endParaRPr lang="zh-CN" sz="1360" dirty="0"/>
+          </a:p>
+        </p:txBody>
+      </p:sp>
+      <p:sp>
+        <p:nvSpPr>
+          <p:cNvPr id="34" name="Text 32"/>
+          <p:cNvSpPr txBox="1"/>
+          <p:nvPr/>
+        </p:nvSpPr>
+        <p:spPr>
+          <a:xfrm>
+            <a:off x="5553456" y="3520440"/>
+            <a:ext cx="2773680" cy="210312"/>
+          </a:xfrm>
+          <a:prstGeom prst="rect">
+            <a:avLst/>
+          </a:prstGeom>
+          <a:noFill/>
+          <a:ln/>
+        </p:spPr>
+        <p:txBody>
+          <a:bodyPr wrap="square" lIns="0" tIns="0" rIns="0" bIns="0" rtlCol="0" anchor="ctr">
+            <a:normAutofit/>
+          </a:bodyPr>
+          <a:lstStyle/>
+          <a:p>
+            <a:pPr algn="l" indent="0" marL="0">
+              <a:buNone/>
+            </a:pPr>
+            <a:r>
+              <a:rPr lang="zh-CN" altLang="en-US" sz="960" dirty="0">
+                <a:solidFill>
+                  <a:srgbClr val="525252"/>
+                </a:solidFill>
+                <a:latin typeface="PingFang SC" pitchFamily="34" charset="0"/>
+                <a:ea typeface="PingFang SC" pitchFamily="34" charset="-122"/>
+                <a:cs typeface="PingFang SC" pitchFamily="34" charset="-120"/>
+              </a:rPr>
+              <a:t>让战略目标进入组织运行</a:t>
+            </a:r>
+            <a:endParaRPr lang="zh-CN" sz="960" dirty="0"/>
+          </a:p>
+        </p:txBody>
+      </p:sp>
+      <p:sp>
+        <p:nvSpPr>
+          <p:cNvPr id="35" name="Shape 33"/>
+          <p:cNvSpPr/>
+          <p:nvPr/>
+        </p:nvSpPr>
+        <p:spPr>
+          <a:xfrm>
+            <a:off x="8491728" y="2843784"/>
+            <a:ext cx="3102864" cy="941832"/>
+          </a:xfrm>
+          <a:prstGeom prst="rect">
+            <a:avLst/>
+          </a:prstGeom>
+          <a:solidFill>
+            <a:srgbClr val="F0F0EE"/>
+          </a:solidFill>
+          <a:ln w="5715">
+            <a:solidFill>
+              <a:srgbClr val="D4D4D2"/>
+            </a:solidFill>
+            <a:prstDash val="solid"/>
+          </a:ln>
+        </p:spPr>
+      </p:sp>
+      <p:sp>
+        <p:nvSpPr>
+          <p:cNvPr id="36" name="Text 34"/>
+          <p:cNvSpPr txBox="1"/>
+          <p:nvPr/>
+        </p:nvSpPr>
+        <p:spPr>
+          <a:xfrm>
+            <a:off x="8656320" y="2980944"/>
+            <a:ext cx="804672" cy="219456"/>
+          </a:xfrm>
+          <a:prstGeom prst="rect">
+            <a:avLst/>
+          </a:prstGeom>
+          <a:noFill/>
+          <a:ln/>
+        </p:spPr>
+        <p:txBody>
+          <a:bodyPr wrap="square" lIns="0" tIns="0" rIns="0" bIns="0" rtlCol="0" anchor="ctr"/>
+          <a:lstStyle/>
+          <a:p>
+            <a:pPr algn="l" indent="0" marL="0">
+              <a:buNone/>
+            </a:pPr>
+            <a:r>
+              <a:rPr lang="zh-CN" altLang="en-US" sz="820" b="1" spc="120" kern="0" dirty="0">
+                <a:solidFill>
+                  <a:srgbClr val="737373"/>
+                </a:solidFill>
+                <a:latin typeface="PingFang SC" pitchFamily="34" charset="0"/>
+                <a:ea typeface="PingFang SC" pitchFamily="34" charset="-122"/>
+                <a:cs typeface="PingFang SC" pitchFamily="34" charset="-120"/>
+              </a:rPr>
+              <a:t>03 / OD</a:t>
+            </a:r>
+            <a:endParaRPr lang="zh-CN" sz="820" dirty="0"/>
+          </a:p>
+        </p:txBody>
+      </p:sp>
+      <p:sp>
+        <p:nvSpPr>
+          <p:cNvPr id="37" name="Text 35"/>
+          <p:cNvSpPr txBox="1"/>
+          <p:nvPr/>
+        </p:nvSpPr>
+        <p:spPr>
+          <a:xfrm>
+            <a:off x="8656320" y="3218688"/>
+            <a:ext cx="2773680" cy="246888"/>
           </a:xfrm>
           <a:prstGeom prst="rect">
             <a:avLst/>
@@ -8770,54 +9174,96 @@
               <a:buNone/>
             </a:pPr>
             <a:r>
-              <a:rPr lang="zh-CN" altLang="en-US" sz="1020" dirty="0">
-                <a:solidFill>
-                  <a:srgbClr val="737373"/>
-                </a:solidFill>
-                <a:latin typeface="PingFang SC" pitchFamily="34" charset="0"/>
-                <a:ea typeface="PingFang SC" pitchFamily="34" charset="-122"/>
-                <a:cs typeface="PingFang SC" pitchFamily="34" charset="-120"/>
-              </a:rPr>
-              <a:t>明确方向</a:t>
-            </a:r>
-            <a:endParaRPr lang="zh-CN" sz="1020" dirty="0"/>
-          </a:p>
-        </p:txBody>
-      </p:sp>
-      <p:sp>
-        <p:nvSpPr>
-          <p:cNvPr id="27" name="Shape 25"/>
-          <p:cNvSpPr/>
-          <p:nvPr/>
-        </p:nvSpPr>
-        <p:spPr>
-          <a:xfrm>
-            <a:off x="8028432" y="2267712"/>
-            <a:ext cx="283464" cy="0"/>
-          </a:xfrm>
-          <a:prstGeom prst="line">
-            <a:avLst/>
-          </a:prstGeom>
-          <a:noFill/>
-          <a:ln w="11430">
-            <a:solidFill>
-              <a:srgbClr val="002FA7"/>
-            </a:solidFill>
-            <a:prstDash val="solid"/>
-            <a:tailEnd type="triangle"/>
-          </a:ln>
-        </p:spPr>
-      </p:sp>
-      <p:sp>
-        <p:nvSpPr>
-          <p:cNvPr id="28" name="Text 26"/>
-          <p:cNvSpPr txBox="1"/>
-          <p:nvPr/>
-        </p:nvSpPr>
-        <p:spPr>
-          <a:xfrm>
-            <a:off x="8412480" y="1993392"/>
-            <a:ext cx="347472" cy="219456"/>
+              <a:rPr lang="zh-CN" altLang="en-US" sz="1360" dirty="0">
+                <a:solidFill>
+                  <a:srgbClr val="0A0A0A"/>
+                </a:solidFill>
+                <a:latin typeface="PingFang SC" pitchFamily="34" charset="0"/>
+                <a:ea typeface="PingFang SC" pitchFamily="34" charset="-122"/>
+                <a:cs typeface="PingFang SC" pitchFamily="34" charset="-120"/>
+              </a:rPr>
+              <a:t>文化与氛围</a:t>
+            </a:r>
+            <a:endParaRPr lang="zh-CN" sz="1360" dirty="0"/>
+          </a:p>
+        </p:txBody>
+      </p:sp>
+      <p:sp>
+        <p:nvSpPr>
+          <p:cNvPr id="38" name="Text 36"/>
+          <p:cNvSpPr txBox="1"/>
+          <p:nvPr/>
+        </p:nvSpPr>
+        <p:spPr>
+          <a:xfrm>
+            <a:off x="8656320" y="3520440"/>
+            <a:ext cx="2773680" cy="210312"/>
+          </a:xfrm>
+          <a:prstGeom prst="rect">
+            <a:avLst/>
+          </a:prstGeom>
+          <a:noFill/>
+          <a:ln/>
+        </p:spPr>
+        <p:txBody>
+          <a:bodyPr wrap="square" lIns="0" tIns="0" rIns="0" bIns="0" rtlCol="0" anchor="ctr">
+            <a:normAutofit/>
+          </a:bodyPr>
+          <a:lstStyle/>
+          <a:p>
+            <a:pPr algn="l" indent="0" marL="0">
+              <a:buNone/>
+            </a:pPr>
+            <a:r>
+              <a:rPr lang="zh-CN" altLang="en-US" sz="960" dirty="0">
+                <a:solidFill>
+                  <a:srgbClr val="525252"/>
+                </a:solidFill>
+                <a:latin typeface="PingFang SC" pitchFamily="34" charset="0"/>
+                <a:ea typeface="PingFang SC" pitchFamily="34" charset="-122"/>
+                <a:cs typeface="PingFang SC" pitchFamily="34" charset="-120"/>
+              </a:rPr>
+              <a:t>建立支持战略的组织环境</a:t>
+            </a:r>
+            <a:endParaRPr lang="zh-CN" sz="960" dirty="0"/>
+          </a:p>
+        </p:txBody>
+      </p:sp>
+      <p:sp>
+        <p:nvSpPr>
+          <p:cNvPr id="39" name="Shape 37"/>
+          <p:cNvSpPr/>
+          <p:nvPr/>
+        </p:nvSpPr>
+        <p:spPr>
+          <a:xfrm>
+            <a:off x="594360" y="3785616"/>
+            <a:ext cx="1691640" cy="941832"/>
+          </a:xfrm>
+          <a:prstGeom prst="rect">
+            <a:avLst/>
+          </a:prstGeom>
+          <a:solidFill>
+            <a:srgbClr val="002FA7"/>
+          </a:solidFill>
+          <a:ln w="5715">
+            <a:solidFill>
+              <a:srgbClr val="D4D4D2"/>
+            </a:solidFill>
+            <a:prstDash val="solid"/>
+          </a:ln>
+        </p:spPr>
+      </p:sp>
+      <p:sp>
+        <p:nvSpPr>
+          <p:cNvPr id="40" name="Text 38"/>
+          <p:cNvSpPr txBox="1"/>
+          <p:nvPr/>
+        </p:nvSpPr>
+        <p:spPr>
+          <a:xfrm>
+            <a:off x="758952" y="3941064"/>
+            <a:ext cx="566928" cy="219456"/>
           </a:xfrm>
           <a:prstGeom prst="rect">
             <a:avLst/>
@@ -8833,30 +9279,30 @@
               <a:buNone/>
             </a:pPr>
             <a:r>
-              <a:rPr lang="zh-CN" altLang="en-US" sz="850" b="1" spc="115" kern="0" dirty="0">
-                <a:solidFill>
-                  <a:srgbClr val="002FA7"/>
-                </a:solidFill>
-                <a:latin typeface="PingFang SC" pitchFamily="34" charset="0"/>
-                <a:ea typeface="PingFang SC" pitchFamily="34" charset="-122"/>
-                <a:cs typeface="PingFang SC" pitchFamily="34" charset="-120"/>
-              </a:rPr>
-              <a:t>03</a:t>
-            </a:r>
-            <a:endParaRPr lang="zh-CN" sz="850" dirty="0"/>
-          </a:p>
-        </p:txBody>
-      </p:sp>
-      <p:sp>
-        <p:nvSpPr>
-          <p:cNvPr id="29" name="Text 27"/>
-          <p:cNvSpPr txBox="1"/>
-          <p:nvPr/>
-        </p:nvSpPr>
-        <p:spPr>
-          <a:xfrm>
-            <a:off x="8851392" y="1929384"/>
-            <a:ext cx="1234440" cy="274320"/>
+              <a:rPr lang="zh-CN" altLang="en-US" sz="920" b="1" spc="120" kern="0" dirty="0">
+                <a:solidFill>
+                  <a:srgbClr val="FFFFFF"/>
+                </a:solidFill>
+                <a:latin typeface="PingFang SC" pitchFamily="34" charset="0"/>
+                <a:ea typeface="PingFang SC" pitchFamily="34" charset="-122"/>
+                <a:cs typeface="PingFang SC" pitchFamily="34" charset="-120"/>
+              </a:rPr>
+              <a:t>TD</a:t>
+            </a:r>
+            <a:endParaRPr lang="zh-CN" sz="920" dirty="0"/>
+          </a:p>
+        </p:txBody>
+      </p:sp>
+      <p:sp>
+        <p:nvSpPr>
+          <p:cNvPr id="41" name="Text 39"/>
+          <p:cNvSpPr txBox="1"/>
+          <p:nvPr/>
+        </p:nvSpPr>
+        <p:spPr>
+          <a:xfrm>
+            <a:off x="758952" y="4215384"/>
+            <a:ext cx="1261872" cy="246888"/>
           </a:xfrm>
           <a:prstGeom prst="rect">
             <a:avLst/>
@@ -8874,30 +9320,160 @@
               <a:buNone/>
             </a:pPr>
             <a:r>
-              <a:rPr lang="zh-CN" altLang="en-US" sz="1320" b="1" dirty="0">
-                <a:solidFill>
-                  <a:srgbClr val="0A0A0A"/>
-                </a:solidFill>
-                <a:latin typeface="PingFang SC" pitchFamily="34" charset="0"/>
-                <a:ea typeface="PingFang SC" pitchFamily="34" charset="-122"/>
-                <a:cs typeface="PingFang SC" pitchFamily="34" charset="-120"/>
-              </a:rPr>
-              <a:t>战略解码</a:t>
-            </a:r>
-            <a:endParaRPr lang="zh-CN" sz="1320" dirty="0"/>
-          </a:p>
-        </p:txBody>
-      </p:sp>
-      <p:sp>
-        <p:nvSpPr>
-          <p:cNvPr id="30" name="Text 28"/>
-          <p:cNvSpPr txBox="1"/>
-          <p:nvPr/>
-        </p:nvSpPr>
-        <p:spPr>
-          <a:xfrm>
-            <a:off x="10058400" y="1947672"/>
-            <a:ext cx="1143000" cy="237744"/>
+              <a:rPr lang="zh-CN" altLang="en-US" sz="1450" dirty="0">
+                <a:solidFill>
+                  <a:srgbClr val="FFFFFF"/>
+                </a:solidFill>
+                <a:latin typeface="PingFang SC" pitchFamily="34" charset="0"/>
+                <a:ea typeface="PingFang SC" pitchFamily="34" charset="-122"/>
+                <a:cs typeface="PingFang SC" pitchFamily="34" charset="-120"/>
+              </a:rPr>
+              <a:t>人才发展</a:t>
+            </a:r>
+            <a:endParaRPr lang="zh-CN" sz="1450" dirty="0"/>
+          </a:p>
+        </p:txBody>
+      </p:sp>
+      <p:sp>
+        <p:nvSpPr>
+          <p:cNvPr id="42" name="Text 40"/>
+          <p:cNvSpPr txBox="1"/>
+          <p:nvPr/>
+        </p:nvSpPr>
+        <p:spPr>
+          <a:xfrm>
+            <a:off x="758952" y="4507992"/>
+            <a:ext cx="1243584" cy="219456"/>
+          </a:xfrm>
+          <a:prstGeom prst="rect">
+            <a:avLst/>
+          </a:prstGeom>
+          <a:noFill/>
+          <a:ln/>
+        </p:spPr>
+        <p:txBody>
+          <a:bodyPr wrap="square" lIns="0" tIns="0" rIns="0" bIns="0" rtlCol="0" anchor="ctr"/>
+          <a:lstStyle/>
+          <a:p>
+            <a:pPr algn="l" indent="0" marL="0">
+              <a:buNone/>
+            </a:pPr>
+            <a:r>
+              <a:rPr lang="zh-CN" altLang="en-US" sz="850" b="1" spc="120" kern="0" dirty="0">
+                <a:solidFill>
+                  <a:srgbClr val="DCE4FF"/>
+                </a:solidFill>
+                <a:latin typeface="PingFang SC" pitchFamily="34" charset="0"/>
+                <a:ea typeface="PingFang SC" pitchFamily="34" charset="-122"/>
+                <a:cs typeface="PingFang SC" pitchFamily="34" charset="-120"/>
+              </a:rPr>
+              <a:t>定对象</a:t>
+            </a:r>
+            <a:endParaRPr lang="zh-CN" sz="850" dirty="0"/>
+          </a:p>
+        </p:txBody>
+      </p:sp>
+      <p:sp>
+        <p:nvSpPr>
+          <p:cNvPr id="43" name="Shape 41"/>
+          <p:cNvSpPr/>
+          <p:nvPr/>
+        </p:nvSpPr>
+        <p:spPr>
+          <a:xfrm>
+            <a:off x="2286000" y="3785616"/>
+            <a:ext cx="3102864" cy="941832"/>
+          </a:xfrm>
+          <a:prstGeom prst="rect">
+            <a:avLst/>
+          </a:prstGeom>
+          <a:solidFill>
+            <a:srgbClr val="FAFAF8"/>
+          </a:solidFill>
+          <a:ln w="5715">
+            <a:solidFill>
+              <a:srgbClr val="D4D4D2"/>
+            </a:solidFill>
+            <a:prstDash val="solid"/>
+          </a:ln>
+        </p:spPr>
+      </p:sp>
+      <p:sp>
+        <p:nvSpPr>
+          <p:cNvPr id="44" name="Shape 42"/>
+          <p:cNvSpPr/>
+          <p:nvPr/>
+        </p:nvSpPr>
+        <p:spPr>
+          <a:xfrm>
+            <a:off x="2286000" y="3785616"/>
+            <a:ext cx="3102864" cy="32004"/>
+          </a:xfrm>
+          <a:prstGeom prst="rect">
+            <a:avLst/>
+          </a:prstGeom>
+          <a:solidFill>
+            <a:srgbClr val="002FA7"/>
+          </a:solidFill>
+          <a:ln w="6350">
+            <a:solidFill>
+              <a:srgbClr val="002FA7">
+                <a:alpha val="0"/>
+              </a:srgbClr>
+            </a:solidFill>
+            <a:prstDash val="solid"/>
+          </a:ln>
+        </p:spPr>
+      </p:sp>
+      <p:sp>
+        <p:nvSpPr>
+          <p:cNvPr id="45" name="Text 43"/>
+          <p:cNvSpPr txBox="1"/>
+          <p:nvPr/>
+        </p:nvSpPr>
+        <p:spPr>
+          <a:xfrm>
+            <a:off x="2450592" y="3922776"/>
+            <a:ext cx="804672" cy="219456"/>
+          </a:xfrm>
+          <a:prstGeom prst="rect">
+            <a:avLst/>
+          </a:prstGeom>
+          <a:noFill/>
+          <a:ln/>
+        </p:spPr>
+        <p:txBody>
+          <a:bodyPr wrap="square" lIns="0" tIns="0" rIns="0" bIns="0" rtlCol="0" anchor="ctr"/>
+          <a:lstStyle/>
+          <a:p>
+            <a:pPr algn="l" indent="0" marL="0">
+              <a:buNone/>
+            </a:pPr>
+            <a:r>
+              <a:rPr lang="zh-CN" altLang="en-US" sz="820" b="1" spc="120" kern="0" dirty="0">
+                <a:solidFill>
+                  <a:srgbClr val="002FA7"/>
+                </a:solidFill>
+                <a:latin typeface="PingFang SC" pitchFamily="34" charset="0"/>
+                <a:ea typeface="PingFang SC" pitchFamily="34" charset="-122"/>
+                <a:cs typeface="PingFang SC" pitchFamily="34" charset="-120"/>
+              </a:rPr>
+              <a:t>01 / TD</a:t>
+            </a:r>
+            <a:endParaRPr lang="zh-CN" sz="820" dirty="0"/>
+          </a:p>
+        </p:txBody>
+      </p:sp>
+      <p:sp>
+        <p:nvSpPr>
+          <p:cNvPr id="46" name="Text 44"/>
+          <p:cNvSpPr txBox="1"/>
+          <p:nvPr/>
+        </p:nvSpPr>
+        <p:spPr>
+          <a:xfrm>
+            <a:off x="2450592" y="4160520"/>
+            <a:ext cx="2773680" cy="246888"/>
           </a:xfrm>
           <a:prstGeom prst="rect">
             <a:avLst/>
@@ -8915,40 +9491,106 @@
               <a:buNone/>
             </a:pPr>
             <a:r>
-              <a:rPr lang="zh-CN" altLang="en-US" sz="1020" dirty="0">
-                <a:solidFill>
-                  <a:srgbClr val="737373"/>
-                </a:solidFill>
-                <a:latin typeface="PingFang SC" pitchFamily="34" charset="0"/>
-                <a:ea typeface="PingFang SC" pitchFamily="34" charset="-122"/>
-                <a:cs typeface="PingFang SC" pitchFamily="34" charset="-120"/>
-              </a:rPr>
-              <a:t>转为组织任务</a:t>
-            </a:r>
-            <a:endParaRPr lang="zh-CN" sz="1020" dirty="0"/>
-          </a:p>
-        </p:txBody>
-      </p:sp>
-      <p:sp>
-        <p:nvSpPr>
-          <p:cNvPr id="31" name="Shape 29"/>
-          <p:cNvSpPr/>
-          <p:nvPr/>
-        </p:nvSpPr>
-        <p:spPr>
-          <a:xfrm>
-            <a:off x="2103120" y="2395728"/>
-            <a:ext cx="9262872" cy="201168"/>
-          </a:xfrm>
-          <a:prstGeom prst="rect">
-            <a:avLst/>
-          </a:prstGeom>
-          <a:solidFill>
-            <a:srgbClr val="E8EDFF"/>
+              <a:rPr lang="zh-CN" altLang="en-US" sz="1360" dirty="0">
+                <a:solidFill>
+                  <a:srgbClr val="002FA7"/>
+                </a:solidFill>
+                <a:latin typeface="PingFang SC" pitchFamily="34" charset="0"/>
+                <a:ea typeface="PingFang SC" pitchFamily="34" charset="-122"/>
+                <a:cs typeface="PingFang SC" pitchFamily="34" charset="-120"/>
+              </a:rPr>
+              <a:t>DEFINE · 定标准</a:t>
+            </a:r>
+            <a:endParaRPr lang="zh-CN" sz="1360" dirty="0"/>
+          </a:p>
+        </p:txBody>
+      </p:sp>
+      <p:sp>
+        <p:nvSpPr>
+          <p:cNvPr id="47" name="Text 45"/>
+          <p:cNvSpPr txBox="1"/>
+          <p:nvPr/>
+        </p:nvSpPr>
+        <p:spPr>
+          <a:xfrm>
+            <a:off x="2450592" y="4462272"/>
+            <a:ext cx="2773680" cy="210312"/>
+          </a:xfrm>
+          <a:prstGeom prst="rect">
+            <a:avLst/>
+          </a:prstGeom>
+          <a:noFill/>
+          <a:ln/>
+        </p:spPr>
+        <p:txBody>
+          <a:bodyPr wrap="square" lIns="0" tIns="0" rIns="0" bIns="0" rtlCol="0" anchor="ctr">
+            <a:normAutofit/>
+          </a:bodyPr>
+          <a:lstStyle/>
+          <a:p>
+            <a:pPr algn="l" indent="0" marL="0">
+              <a:buNone/>
+            </a:pPr>
+            <a:r>
+              <a:rPr lang="zh-CN" altLang="en-US" sz="960" dirty="0">
+                <a:solidFill>
+                  <a:srgbClr val="525252"/>
+                </a:solidFill>
+                <a:latin typeface="PingFang SC" pitchFamily="34" charset="0"/>
+                <a:ea typeface="PingFang SC" pitchFamily="34" charset="-122"/>
+                <a:cs typeface="PingFang SC" pitchFamily="34" charset="-120"/>
+              </a:rPr>
+              <a:t>组织 / 关键岗位分析 → 岗位标准</a:t>
+            </a:r>
+            <a:endParaRPr lang="zh-CN" sz="960" dirty="0"/>
+          </a:p>
+        </p:txBody>
+      </p:sp>
+      <p:sp>
+        <p:nvSpPr>
+          <p:cNvPr id="48" name="Shape 46"/>
+          <p:cNvSpPr/>
+          <p:nvPr/>
+        </p:nvSpPr>
+        <p:spPr>
+          <a:xfrm>
+            <a:off x="5388864" y="3785616"/>
+            <a:ext cx="3102864" cy="941832"/>
+          </a:xfrm>
+          <a:prstGeom prst="rect">
+            <a:avLst/>
+          </a:prstGeom>
+          <a:solidFill>
+            <a:srgbClr val="FAFAF8"/>
+          </a:solidFill>
+          <a:ln w="5715">
+            <a:solidFill>
+              <a:srgbClr val="D4D4D2"/>
+            </a:solidFill>
+            <a:prstDash val="solid"/>
+          </a:ln>
+        </p:spPr>
+      </p:sp>
+      <p:sp>
+        <p:nvSpPr>
+          <p:cNvPr id="49" name="Shape 47"/>
+          <p:cNvSpPr/>
+          <p:nvPr/>
+        </p:nvSpPr>
+        <p:spPr>
+          <a:xfrm>
+            <a:off x="5388864" y="3785616"/>
+            <a:ext cx="3102864" cy="32004"/>
+          </a:xfrm>
+          <a:prstGeom prst="rect">
+            <a:avLst/>
+          </a:prstGeom>
+          <a:solidFill>
+            <a:srgbClr val="002FA7"/>
           </a:solidFill>
           <a:ln w="6350">
             <a:solidFill>
-              <a:srgbClr val="E8EDFF">
+              <a:srgbClr val="002FA7">
                 <a:alpha val="0"/>
               </a:srgbClr>
             </a:solidFill>
@@ -8958,14 +9600,14 @@
       </p:sp>
       <p:sp>
         <p:nvSpPr>
-          <p:cNvPr id="32" name="Text 30"/>
-          <p:cNvSpPr txBox="1"/>
-          <p:nvPr/>
-        </p:nvSpPr>
-        <p:spPr>
-          <a:xfrm>
-            <a:off x="2258568" y="2423160"/>
-            <a:ext cx="8951976" cy="219456"/>
+          <p:cNvPr id="50" name="Text 48"/>
+          <p:cNvSpPr txBox="1"/>
+          <p:nvPr/>
+        </p:nvSpPr>
+        <p:spPr>
+          <a:xfrm>
+            <a:off x="5553456" y="3922776"/>
+            <a:ext cx="804672" cy="219456"/>
           </a:xfrm>
           <a:prstGeom prst="rect">
             <a:avLst/>
@@ -8977,11 +9619,11 @@
           <a:bodyPr wrap="square" lIns="0" tIns="0" rIns="0" bIns="0" rtlCol="0" anchor="ctr"/>
           <a:lstStyle/>
           <a:p>
-            <a:pPr algn="ctr" indent="0" marL="0">
-              <a:buNone/>
-            </a:pPr>
-            <a:r>
-              <a:rPr lang="zh-CN" altLang="en-US" sz="850" b="1" spc="115" kern="0" dirty="0">
+            <a:pPr algn="l" indent="0" marL="0">
+              <a:buNone/>
+            </a:pPr>
+            <a:r>
+              <a:rPr lang="zh-CN" altLang="en-US" sz="820" b="1" spc="120" kern="0" dirty="0">
                 <a:solidFill>
                   <a:srgbClr val="002FA7"/>
                 </a:solidFill>
@@ -8989,47 +9631,22 @@
                 <a:ea typeface="PingFang SC" pitchFamily="34" charset="-122"/>
                 <a:cs typeface="PingFang SC" pitchFamily="34" charset="-120"/>
               </a:rPr>
-              <a:t>业务方向向下解码，组织与人才发展反向支撑业务结果</a:t>
-            </a:r>
-            <a:endParaRPr lang="zh-CN" sz="850" dirty="0"/>
-          </a:p>
-        </p:txBody>
-      </p:sp>
-      <p:sp>
-        <p:nvSpPr>
-          <p:cNvPr id="33" name="Shape 31"/>
-          <p:cNvSpPr/>
-          <p:nvPr/>
-        </p:nvSpPr>
-        <p:spPr>
-          <a:xfrm>
-            <a:off x="1874520" y="2871216"/>
-            <a:ext cx="3154680" cy="987552"/>
-          </a:xfrm>
-          <a:prstGeom prst="rect">
-            <a:avLst/>
-          </a:prstGeom>
-          <a:solidFill>
-            <a:srgbClr val="FFFFFF"/>
-          </a:solidFill>
-          <a:ln w="8255">
-            <a:solidFill>
-              <a:srgbClr val="D4D4D2"/>
-            </a:solidFill>
-            <a:prstDash val="solid"/>
-          </a:ln>
-        </p:spPr>
-      </p:sp>
-      <p:sp>
-        <p:nvSpPr>
-          <p:cNvPr id="34" name="Text 32"/>
-          <p:cNvSpPr txBox="1"/>
-          <p:nvPr/>
-        </p:nvSpPr>
-        <p:spPr>
-          <a:xfrm>
-            <a:off x="2075688" y="3127248"/>
-            <a:ext cx="2752344" cy="256032"/>
+              <a:t>02 / TD</a:t>
+            </a:r>
+            <a:endParaRPr lang="zh-CN" sz="820" dirty="0"/>
+          </a:p>
+        </p:txBody>
+      </p:sp>
+      <p:sp>
+        <p:nvSpPr>
+          <p:cNvPr id="51" name="Text 49"/>
+          <p:cNvSpPr txBox="1"/>
+          <p:nvPr/>
+        </p:nvSpPr>
+        <p:spPr>
+          <a:xfrm>
+            <a:off x="5553456" y="4160520"/>
+            <a:ext cx="2773680" cy="246888"/>
           </a:xfrm>
           <a:prstGeom prst="rect">
             <a:avLst/>
@@ -9043,34 +9660,127 @@
           </a:bodyPr>
           <a:lstStyle/>
           <a:p>
-            <a:pPr algn="ctr" indent="0" marL="0">
-              <a:buNone/>
-            </a:pPr>
-            <a:r>
-              <a:rPr lang="zh-CN" altLang="en-US" sz="1320" b="1" dirty="0">
-                <a:solidFill>
-                  <a:srgbClr val="0A0A0A"/>
-                </a:solidFill>
-                <a:latin typeface="PingFang SC" pitchFamily="34" charset="0"/>
-                <a:ea typeface="PingFang SC" pitchFamily="34" charset="-122"/>
-                <a:cs typeface="PingFang SC" pitchFamily="34" charset="-120"/>
-              </a:rPr>
-              <a:t>组织结构与机制</a:t>
-            </a:r>
-            <a:endParaRPr lang="zh-CN" sz="1320" dirty="0"/>
-          </a:p>
-        </p:txBody>
-      </p:sp>
-      <p:sp>
-        <p:nvSpPr>
-          <p:cNvPr id="35" name="Text 33"/>
-          <p:cNvSpPr txBox="1"/>
-          <p:nvPr/>
-        </p:nvSpPr>
-        <p:spPr>
-          <a:xfrm>
-            <a:off x="2075688" y="3465576"/>
-            <a:ext cx="2752344" cy="219456"/>
+            <a:pPr algn="l" indent="0" marL="0">
+              <a:buNone/>
+            </a:pPr>
+            <a:r>
+              <a:rPr lang="zh-CN" altLang="en-US" sz="1360" dirty="0">
+                <a:solidFill>
+                  <a:srgbClr val="002FA7"/>
+                </a:solidFill>
+                <a:latin typeface="PingFang SC" pitchFamily="34" charset="0"/>
+                <a:ea typeface="PingFang SC" pitchFamily="34" charset="-122"/>
+                <a:cs typeface="PingFang SC" pitchFamily="34" charset="-120"/>
+              </a:rPr>
+              <a:t>DISCOVER · 识人才</a:t>
+            </a:r>
+            <a:endParaRPr lang="zh-CN" sz="1360" dirty="0"/>
+          </a:p>
+        </p:txBody>
+      </p:sp>
+      <p:sp>
+        <p:nvSpPr>
+          <p:cNvPr id="52" name="Text 50"/>
+          <p:cNvSpPr txBox="1"/>
+          <p:nvPr/>
+        </p:nvSpPr>
+        <p:spPr>
+          <a:xfrm>
+            <a:off x="5553456" y="4462272"/>
+            <a:ext cx="2773680" cy="210312"/>
+          </a:xfrm>
+          <a:prstGeom prst="rect">
+            <a:avLst/>
+          </a:prstGeom>
+          <a:noFill/>
+          <a:ln/>
+        </p:spPr>
+        <p:txBody>
+          <a:bodyPr wrap="square" lIns="0" tIns="0" rIns="0" bIns="0" rtlCol="0" anchor="ctr">
+            <a:normAutofit/>
+          </a:bodyPr>
+          <a:lstStyle/>
+          <a:p>
+            <a:pPr algn="l" indent="0" marL="0">
+              <a:buNone/>
+            </a:pPr>
+            <a:r>
+              <a:rPr lang="zh-CN" altLang="en-US" sz="960" dirty="0">
+                <a:solidFill>
+                  <a:srgbClr val="525252"/>
+                </a:solidFill>
+                <a:latin typeface="PingFang SC" pitchFamily="34" charset="0"/>
+                <a:ea typeface="PingFang SC" pitchFamily="34" charset="-122"/>
+                <a:cs typeface="PingFang SC" pitchFamily="34" charset="-120"/>
+              </a:rPr>
+              <a:t>评鉴工具 → 人才盘点</a:t>
+            </a:r>
+            <a:endParaRPr lang="zh-CN" sz="960" dirty="0"/>
+          </a:p>
+        </p:txBody>
+      </p:sp>
+      <p:sp>
+        <p:nvSpPr>
+          <p:cNvPr id="53" name="Shape 51"/>
+          <p:cNvSpPr/>
+          <p:nvPr/>
+        </p:nvSpPr>
+        <p:spPr>
+          <a:xfrm>
+            <a:off x="8491728" y="3785616"/>
+            <a:ext cx="3102864" cy="941832"/>
+          </a:xfrm>
+          <a:prstGeom prst="rect">
+            <a:avLst/>
+          </a:prstGeom>
+          <a:solidFill>
+            <a:srgbClr val="FAFAF8"/>
+          </a:solidFill>
+          <a:ln w="5715">
+            <a:solidFill>
+              <a:srgbClr val="D4D4D2"/>
+            </a:solidFill>
+            <a:prstDash val="solid"/>
+          </a:ln>
+        </p:spPr>
+      </p:sp>
+      <p:sp>
+        <p:nvSpPr>
+          <p:cNvPr id="54" name="Shape 52"/>
+          <p:cNvSpPr/>
+          <p:nvPr/>
+        </p:nvSpPr>
+        <p:spPr>
+          <a:xfrm>
+            <a:off x="8491728" y="3785616"/>
+            <a:ext cx="3102864" cy="32004"/>
+          </a:xfrm>
+          <a:prstGeom prst="rect">
+            <a:avLst/>
+          </a:prstGeom>
+          <a:solidFill>
+            <a:srgbClr val="002FA7"/>
+          </a:solidFill>
+          <a:ln w="6350">
+            <a:solidFill>
+              <a:srgbClr val="002FA7">
+                <a:alpha val="0"/>
+              </a:srgbClr>
+            </a:solidFill>
+            <a:prstDash val="solid"/>
+          </a:ln>
+        </p:spPr>
+      </p:sp>
+      <p:sp>
+        <p:nvSpPr>
+          <p:cNvPr id="55" name="Text 53"/>
+          <p:cNvSpPr txBox="1"/>
+          <p:nvPr/>
+        </p:nvSpPr>
+        <p:spPr>
+          <a:xfrm>
+            <a:off x="8656320" y="3922776"/>
+            <a:ext cx="804672" cy="219456"/>
           </a:xfrm>
           <a:prstGeom prst="rect">
             <a:avLst/>
@@ -9082,59 +9792,34 @@
           <a:bodyPr wrap="square" lIns="0" tIns="0" rIns="0" bIns="0" rtlCol="0" anchor="ctr"/>
           <a:lstStyle/>
           <a:p>
-            <a:pPr algn="ctr" indent="0" marL="0">
-              <a:buNone/>
-            </a:pPr>
-            <a:r>
-              <a:rPr lang="zh-CN" altLang="en-US" sz="850" b="1" spc="115" kern="0" dirty="0">
-                <a:solidFill>
-                  <a:srgbClr val="737373"/>
-                </a:solidFill>
-                <a:latin typeface="PingFang SC" pitchFamily="34" charset="0"/>
-                <a:ea typeface="PingFang SC" pitchFamily="34" charset="-122"/>
-                <a:cs typeface="PingFang SC" pitchFamily="34" charset="-120"/>
-              </a:rPr>
-              <a:t>STRUCTURE</a:t>
-            </a:r>
-            <a:endParaRPr lang="zh-CN" sz="850" dirty="0"/>
-          </a:p>
-        </p:txBody>
-      </p:sp>
-      <p:sp>
-        <p:nvSpPr>
-          <p:cNvPr id="36" name="Shape 34"/>
-          <p:cNvSpPr/>
-          <p:nvPr/>
-        </p:nvSpPr>
-        <p:spPr>
-          <a:xfrm>
-            <a:off x="5148072" y="2871216"/>
-            <a:ext cx="3154680" cy="987552"/>
-          </a:xfrm>
-          <a:prstGeom prst="rect">
-            <a:avLst/>
-          </a:prstGeom>
-          <a:solidFill>
-            <a:srgbClr val="E8EDFF"/>
-          </a:solidFill>
-          <a:ln w="12700">
-            <a:solidFill>
-              <a:srgbClr val="002FA7"/>
-            </a:solidFill>
-            <a:prstDash val="solid"/>
-          </a:ln>
-        </p:spPr>
-      </p:sp>
-      <p:sp>
-        <p:nvSpPr>
-          <p:cNvPr id="37" name="Text 35"/>
-          <p:cNvSpPr txBox="1"/>
-          <p:nvPr/>
-        </p:nvSpPr>
-        <p:spPr>
-          <a:xfrm>
-            <a:off x="5349240" y="3127248"/>
-            <a:ext cx="2752344" cy="256032"/>
+            <a:pPr algn="l" indent="0" marL="0">
+              <a:buNone/>
+            </a:pPr>
+            <a:r>
+              <a:rPr lang="zh-CN" altLang="en-US" sz="820" b="1" spc="120" kern="0" dirty="0">
+                <a:solidFill>
+                  <a:srgbClr val="002FA7"/>
+                </a:solidFill>
+                <a:latin typeface="PingFang SC" pitchFamily="34" charset="0"/>
+                <a:ea typeface="PingFang SC" pitchFamily="34" charset="-122"/>
+                <a:cs typeface="PingFang SC" pitchFamily="34" charset="-120"/>
+              </a:rPr>
+              <a:t>03 / TD</a:t>
+            </a:r>
+            <a:endParaRPr lang="zh-CN" sz="820" dirty="0"/>
+          </a:p>
+        </p:txBody>
+      </p:sp>
+      <p:sp>
+        <p:nvSpPr>
+          <p:cNvPr id="56" name="Text 54"/>
+          <p:cNvSpPr txBox="1"/>
+          <p:nvPr/>
+        </p:nvSpPr>
+        <p:spPr>
+          <a:xfrm>
+            <a:off x="8656320" y="4160520"/>
+            <a:ext cx="2773680" cy="246888"/>
           </a:xfrm>
           <a:prstGeom prst="rect">
             <a:avLst/>
@@ -9148,34 +9833,100 @@
           </a:bodyPr>
           <a:lstStyle/>
           <a:p>
-            <a:pPr algn="ctr" indent="0" marL="0">
-              <a:buNone/>
-            </a:pPr>
-            <a:r>
-              <a:rPr lang="zh-CN" altLang="en-US" sz="1320" b="1" dirty="0">
-                <a:solidFill>
-                  <a:srgbClr val="0A0A0A"/>
-                </a:solidFill>
-                <a:latin typeface="PingFang SC" pitchFamily="34" charset="0"/>
-                <a:ea typeface="PingFang SC" pitchFamily="34" charset="-122"/>
-                <a:cs typeface="PingFang SC" pitchFamily="34" charset="-120"/>
-              </a:rPr>
-              <a:t>目标与绩效</a:t>
-            </a:r>
-            <a:endParaRPr lang="zh-CN" sz="1320" dirty="0"/>
-          </a:p>
-        </p:txBody>
-      </p:sp>
-      <p:sp>
-        <p:nvSpPr>
-          <p:cNvPr id="38" name="Text 36"/>
-          <p:cNvSpPr txBox="1"/>
-          <p:nvPr/>
-        </p:nvSpPr>
-        <p:spPr>
-          <a:xfrm>
-            <a:off x="5349240" y="3465576"/>
-            <a:ext cx="2752344" cy="219456"/>
+            <a:pPr algn="l" indent="0" marL="0">
+              <a:buNone/>
+            </a:pPr>
+            <a:r>
+              <a:rPr lang="zh-CN" altLang="en-US" sz="1360" dirty="0">
+                <a:solidFill>
+                  <a:srgbClr val="002FA7"/>
+                </a:solidFill>
+                <a:latin typeface="PingFang SC" pitchFamily="34" charset="0"/>
+                <a:ea typeface="PingFang SC" pitchFamily="34" charset="-122"/>
+                <a:cs typeface="PingFang SC" pitchFamily="34" charset="-120"/>
+              </a:rPr>
+              <a:t>DRIVE · 促发展</a:t>
+            </a:r>
+            <a:endParaRPr lang="zh-CN" sz="1360" dirty="0"/>
+          </a:p>
+        </p:txBody>
+      </p:sp>
+      <p:sp>
+        <p:nvSpPr>
+          <p:cNvPr id="57" name="Text 55"/>
+          <p:cNvSpPr txBox="1"/>
+          <p:nvPr/>
+        </p:nvSpPr>
+        <p:spPr>
+          <a:xfrm>
+            <a:off x="8656320" y="4462272"/>
+            <a:ext cx="2773680" cy="210312"/>
+          </a:xfrm>
+          <a:prstGeom prst="rect">
+            <a:avLst/>
+          </a:prstGeom>
+          <a:noFill/>
+          <a:ln/>
+        </p:spPr>
+        <p:txBody>
+          <a:bodyPr wrap="square" lIns="0" tIns="0" rIns="0" bIns="0" rtlCol="0" anchor="ctr">
+            <a:normAutofit/>
+          </a:bodyPr>
+          <a:lstStyle/>
+          <a:p>
+            <a:pPr algn="l" indent="0" marL="0">
+              <a:buNone/>
+            </a:pPr>
+            <a:r>
+              <a:rPr lang="zh-CN" altLang="en-US" sz="960" dirty="0">
+                <a:solidFill>
+                  <a:srgbClr val="525252"/>
+                </a:solidFill>
+                <a:latin typeface="PingFang SC" pitchFamily="34" charset="0"/>
+                <a:ea typeface="PingFang SC" pitchFamily="34" charset="-122"/>
+                <a:cs typeface="PingFang SC" pitchFamily="34" charset="-120"/>
+              </a:rPr>
+              <a:t>人岗匹配 → 个人 IDP / 组织培养</a:t>
+            </a:r>
+            <a:endParaRPr lang="zh-CN" sz="960" dirty="0"/>
+          </a:p>
+        </p:txBody>
+      </p:sp>
+      <p:sp>
+        <p:nvSpPr>
+          <p:cNvPr id="58" name="Shape 56"/>
+          <p:cNvSpPr/>
+          <p:nvPr/>
+        </p:nvSpPr>
+        <p:spPr>
+          <a:xfrm>
+            <a:off x="594360" y="4727448"/>
+            <a:ext cx="1691640" cy="941832"/>
+          </a:xfrm>
+          <a:prstGeom prst="rect">
+            <a:avLst/>
+          </a:prstGeom>
+          <a:solidFill>
+            <a:srgbClr val="0A0A0A"/>
+          </a:solidFill>
+          <a:ln w="5715">
+            <a:solidFill>
+              <a:srgbClr val="D4D4D2"/>
+            </a:solidFill>
+            <a:prstDash val="solid"/>
+          </a:ln>
+        </p:spPr>
+      </p:sp>
+      <p:sp>
+        <p:nvSpPr>
+          <p:cNvPr id="59" name="Text 57"/>
+          <p:cNvSpPr txBox="1"/>
+          <p:nvPr/>
+        </p:nvSpPr>
+        <p:spPr>
+          <a:xfrm>
+            <a:off x="758952" y="4882896"/>
+            <a:ext cx="566928" cy="219456"/>
           </a:xfrm>
           <a:prstGeom prst="rect">
             <a:avLst/>
@@ -9187,59 +9938,34 @@
           <a:bodyPr wrap="square" lIns="0" tIns="0" rIns="0" bIns="0" rtlCol="0" anchor="ctr"/>
           <a:lstStyle/>
           <a:p>
-            <a:pPr algn="ctr" indent="0" marL="0">
-              <a:buNone/>
-            </a:pPr>
-            <a:r>
-              <a:rPr lang="zh-CN" altLang="en-US" sz="850" b="1" spc="115" kern="0" dirty="0">
-                <a:solidFill>
-                  <a:srgbClr val="002FA7"/>
-                </a:solidFill>
-                <a:latin typeface="PingFang SC" pitchFamily="34" charset="0"/>
-                <a:ea typeface="PingFang SC" pitchFamily="34" charset="-122"/>
-                <a:cs typeface="PingFang SC" pitchFamily="34" charset="-120"/>
-              </a:rPr>
-              <a:t>OBJECT</a:t>
-            </a:r>
-            <a:endParaRPr lang="zh-CN" sz="850" dirty="0"/>
-          </a:p>
-        </p:txBody>
-      </p:sp>
-      <p:sp>
-        <p:nvSpPr>
-          <p:cNvPr id="39" name="Shape 37"/>
-          <p:cNvSpPr/>
-          <p:nvPr/>
-        </p:nvSpPr>
-        <p:spPr>
-          <a:xfrm>
-            <a:off x="8421624" y="2871216"/>
-            <a:ext cx="3154680" cy="987552"/>
-          </a:xfrm>
-          <a:prstGeom prst="rect">
-            <a:avLst/>
-          </a:prstGeom>
-          <a:solidFill>
-            <a:srgbClr val="FFFFFF"/>
-          </a:solidFill>
-          <a:ln w="8255">
-            <a:solidFill>
-              <a:srgbClr val="D4D4D2"/>
-            </a:solidFill>
-            <a:prstDash val="solid"/>
-          </a:ln>
-        </p:spPr>
-      </p:sp>
-      <p:sp>
-        <p:nvSpPr>
-          <p:cNvPr id="40" name="Text 38"/>
-          <p:cNvSpPr txBox="1"/>
-          <p:nvPr/>
-        </p:nvSpPr>
-        <p:spPr>
-          <a:xfrm>
-            <a:off x="8622792" y="3127248"/>
-            <a:ext cx="2752344" cy="256032"/>
+            <a:pPr algn="l" indent="0" marL="0">
+              <a:buNone/>
+            </a:pPr>
+            <a:r>
+              <a:rPr lang="zh-CN" altLang="en-US" sz="920" b="1" spc="120" kern="0" dirty="0">
+                <a:solidFill>
+                  <a:srgbClr val="BEBEBA"/>
+                </a:solidFill>
+                <a:latin typeface="PingFang SC" pitchFamily="34" charset="0"/>
+                <a:ea typeface="PingFang SC" pitchFamily="34" charset="-122"/>
+                <a:cs typeface="PingFang SC" pitchFamily="34" charset="-120"/>
+              </a:rPr>
+              <a:t>LD</a:t>
+            </a:r>
+            <a:endParaRPr lang="zh-CN" sz="920" dirty="0"/>
+          </a:p>
+        </p:txBody>
+      </p:sp>
+      <p:sp>
+        <p:nvSpPr>
+          <p:cNvPr id="60" name="Text 58"/>
+          <p:cNvSpPr txBox="1"/>
+          <p:nvPr/>
+        </p:nvSpPr>
+        <p:spPr>
+          <a:xfrm>
+            <a:off x="758952" y="5157216"/>
+            <a:ext cx="1261872" cy="246888"/>
           </a:xfrm>
           <a:prstGeom prst="rect">
             <a:avLst/>
@@ -9253,11 +9979,155 @@
           </a:bodyPr>
           <a:lstStyle/>
           <a:p>
-            <a:pPr algn="ctr" indent="0" marL="0">
-              <a:buNone/>
-            </a:pPr>
-            <a:r>
-              <a:rPr lang="zh-CN" altLang="en-US" sz="1320" b="1" dirty="0">
+            <a:pPr algn="l" indent="0" marL="0">
+              <a:buNone/>
+            </a:pPr>
+            <a:r>
+              <a:rPr lang="zh-CN" altLang="en-US" sz="1450" dirty="0">
+                <a:solidFill>
+                  <a:srgbClr val="FFFFFF"/>
+                </a:solidFill>
+                <a:latin typeface="PingFang SC" pitchFamily="34" charset="0"/>
+                <a:ea typeface="PingFang SC" pitchFamily="34" charset="-122"/>
+                <a:cs typeface="PingFang SC" pitchFamily="34" charset="-120"/>
+              </a:rPr>
+              <a:t>学习发展</a:t>
+            </a:r>
+            <a:endParaRPr lang="zh-CN" sz="1450" dirty="0"/>
+          </a:p>
+        </p:txBody>
+      </p:sp>
+      <p:sp>
+        <p:nvSpPr>
+          <p:cNvPr id="61" name="Text 59"/>
+          <p:cNvSpPr txBox="1"/>
+          <p:nvPr/>
+        </p:nvSpPr>
+        <p:spPr>
+          <a:xfrm>
+            <a:off x="758952" y="5449824"/>
+            <a:ext cx="1243584" cy="219456"/>
+          </a:xfrm>
+          <a:prstGeom prst="rect">
+            <a:avLst/>
+          </a:prstGeom>
+          <a:noFill/>
+          <a:ln/>
+        </p:spPr>
+        <p:txBody>
+          <a:bodyPr wrap="square" lIns="0" tIns="0" rIns="0" bIns="0" rtlCol="0" anchor="ctr"/>
+          <a:lstStyle/>
+          <a:p>
+            <a:pPr algn="l" indent="0" marL="0">
+              <a:buNone/>
+            </a:pPr>
+            <a:r>
+              <a:rPr lang="zh-CN" altLang="en-US" sz="850" b="1" spc="120" kern="0" dirty="0">
+                <a:solidFill>
+                  <a:srgbClr val="AFAFAC"/>
+                </a:solidFill>
+                <a:latin typeface="PingFang SC" pitchFamily="34" charset="0"/>
+                <a:ea typeface="PingFang SC" pitchFamily="34" charset="-122"/>
+                <a:cs typeface="PingFang SC" pitchFamily="34" charset="-120"/>
+              </a:rPr>
+              <a:t>定行动</a:t>
+            </a:r>
+            <a:endParaRPr lang="zh-CN" sz="850" dirty="0"/>
+          </a:p>
+        </p:txBody>
+      </p:sp>
+      <p:sp>
+        <p:nvSpPr>
+          <p:cNvPr id="62" name="Shape 60"/>
+          <p:cNvSpPr/>
+          <p:nvPr/>
+        </p:nvSpPr>
+        <p:spPr>
+          <a:xfrm>
+            <a:off x="2286000" y="4727448"/>
+            <a:ext cx="3102864" cy="941832"/>
+          </a:xfrm>
+          <a:prstGeom prst="rect">
+            <a:avLst/>
+          </a:prstGeom>
+          <a:solidFill>
+            <a:srgbClr val="F0F0EE"/>
+          </a:solidFill>
+          <a:ln w="5715">
+            <a:solidFill>
+              <a:srgbClr val="D4D4D2"/>
+            </a:solidFill>
+            <a:prstDash val="solid"/>
+          </a:ln>
+        </p:spPr>
+      </p:sp>
+      <p:sp>
+        <p:nvSpPr>
+          <p:cNvPr id="63" name="Text 61"/>
+          <p:cNvSpPr txBox="1"/>
+          <p:nvPr/>
+        </p:nvSpPr>
+        <p:spPr>
+          <a:xfrm>
+            <a:off x="2450592" y="4864608"/>
+            <a:ext cx="804672" cy="219456"/>
+          </a:xfrm>
+          <a:prstGeom prst="rect">
+            <a:avLst/>
+          </a:prstGeom>
+          <a:noFill/>
+          <a:ln/>
+        </p:spPr>
+        <p:txBody>
+          <a:bodyPr wrap="square" lIns="0" tIns="0" rIns="0" bIns="0" rtlCol="0" anchor="ctr"/>
+          <a:lstStyle/>
+          <a:p>
+            <a:pPr algn="l" indent="0" marL="0">
+              <a:buNone/>
+            </a:pPr>
+            <a:r>
+              <a:rPr lang="zh-CN" altLang="en-US" sz="820" b="1" spc="120" kern="0" dirty="0">
+                <a:solidFill>
+                  <a:srgbClr val="737373"/>
+                </a:solidFill>
+                <a:latin typeface="PingFang SC" pitchFamily="34" charset="0"/>
+                <a:ea typeface="PingFang SC" pitchFamily="34" charset="-122"/>
+                <a:cs typeface="PingFang SC" pitchFamily="34" charset="-120"/>
+              </a:rPr>
+              <a:t>01 / LD</a:t>
+            </a:r>
+            <a:endParaRPr lang="zh-CN" sz="820" dirty="0"/>
+          </a:p>
+        </p:txBody>
+      </p:sp>
+      <p:sp>
+        <p:nvSpPr>
+          <p:cNvPr id="64" name="Text 62"/>
+          <p:cNvSpPr txBox="1"/>
+          <p:nvPr/>
+        </p:nvSpPr>
+        <p:spPr>
+          <a:xfrm>
+            <a:off x="2450592" y="5102352"/>
+            <a:ext cx="2773680" cy="246888"/>
+          </a:xfrm>
+          <a:prstGeom prst="rect">
+            <a:avLst/>
+          </a:prstGeom>
+          <a:noFill/>
+          <a:ln/>
+        </p:spPr>
+        <p:txBody>
+          <a:bodyPr wrap="square" lIns="0" tIns="0" rIns="0" bIns="0" rtlCol="0" anchor="t">
+            <a:normAutofit/>
+          </a:bodyPr>
+          <a:lstStyle/>
+          <a:p>
+            <a:pPr algn="l" indent="0" marL="0">
+              <a:buNone/>
+            </a:pPr>
+            <a:r>
+              <a:rPr lang="zh-CN" altLang="en-US" sz="1360" dirty="0">
                 <a:solidFill>
                   <a:srgbClr val="0A0A0A"/>
                 </a:solidFill>
@@ -9265,284 +10135,22 @@
                 <a:ea typeface="PingFang SC" pitchFamily="34" charset="-122"/>
                 <a:cs typeface="PingFang SC" pitchFamily="34" charset="-120"/>
               </a:rPr>
-              <a:t>文化与氛围</a:t>
-            </a:r>
-            <a:endParaRPr lang="zh-CN" sz="1320" dirty="0"/>
-          </a:p>
-        </p:txBody>
-      </p:sp>
-      <p:sp>
-        <p:nvSpPr>
-          <p:cNvPr id="41" name="Text 39"/>
-          <p:cNvSpPr txBox="1"/>
-          <p:nvPr/>
-        </p:nvSpPr>
-        <p:spPr>
-          <a:xfrm>
-            <a:off x="8622792" y="3465576"/>
-            <a:ext cx="2752344" cy="219456"/>
-          </a:xfrm>
-          <a:prstGeom prst="rect">
-            <a:avLst/>
-          </a:prstGeom>
-          <a:noFill/>
-          <a:ln/>
-        </p:spPr>
-        <p:txBody>
-          <a:bodyPr wrap="square" lIns="0" tIns="0" rIns="0" bIns="0" rtlCol="0" anchor="ctr"/>
-          <a:lstStyle/>
-          <a:p>
-            <a:pPr algn="ctr" indent="0" marL="0">
-              <a:buNone/>
-            </a:pPr>
-            <a:r>
-              <a:rPr lang="zh-CN" altLang="en-US" sz="850" b="1" spc="115" kern="0" dirty="0">
-                <a:solidFill>
-                  <a:srgbClr val="737373"/>
-                </a:solidFill>
-                <a:latin typeface="PingFang SC" pitchFamily="34" charset="0"/>
-                <a:ea typeface="PingFang SC" pitchFamily="34" charset="-122"/>
-                <a:cs typeface="PingFang SC" pitchFamily="34" charset="-120"/>
-              </a:rPr>
-              <a:t>CULTURE</a:t>
-            </a:r>
-            <a:endParaRPr lang="zh-CN" sz="850" dirty="0"/>
-          </a:p>
-        </p:txBody>
-      </p:sp>
-      <p:sp>
-        <p:nvSpPr>
-          <p:cNvPr id="42" name="Shape 40"/>
-          <p:cNvSpPr/>
-          <p:nvPr/>
-        </p:nvSpPr>
-        <p:spPr>
-          <a:xfrm>
-            <a:off x="1874520" y="3950208"/>
-            <a:ext cx="3154680" cy="283464"/>
-          </a:xfrm>
-          <a:prstGeom prst="rect">
-            <a:avLst/>
-          </a:prstGeom>
-          <a:solidFill>
-            <a:srgbClr val="EEF3E8"/>
-          </a:solidFill>
-          <a:ln w="6350">
-            <a:solidFill>
-              <a:srgbClr val="EEF3E8">
-                <a:alpha val="0"/>
-              </a:srgbClr>
-            </a:solidFill>
-            <a:prstDash val="solid"/>
-          </a:ln>
-        </p:spPr>
-      </p:sp>
-      <p:sp>
-        <p:nvSpPr>
-          <p:cNvPr id="43" name="Text 41"/>
-          <p:cNvSpPr txBox="1"/>
-          <p:nvPr/>
-        </p:nvSpPr>
-        <p:spPr>
-          <a:xfrm>
-            <a:off x="2011680" y="4005072"/>
-            <a:ext cx="2880360" cy="219456"/>
-          </a:xfrm>
-          <a:prstGeom prst="rect">
-            <a:avLst/>
-          </a:prstGeom>
-          <a:noFill/>
-          <a:ln/>
-        </p:spPr>
-        <p:txBody>
-          <a:bodyPr wrap="square" lIns="0" tIns="0" rIns="0" bIns="0" rtlCol="0" anchor="ctr"/>
-          <a:lstStyle/>
-          <a:p>
-            <a:pPr algn="ctr" indent="0" marL="0">
-              <a:buNone/>
-            </a:pPr>
-            <a:r>
-              <a:rPr lang="zh-CN" altLang="en-US" sz="850" b="1" spc="115" kern="0" dirty="0">
-                <a:solidFill>
-                  <a:srgbClr val="44652B"/>
-                </a:solidFill>
-                <a:latin typeface="PingFang SC" pitchFamily="34" charset="0"/>
-                <a:ea typeface="PingFang SC" pitchFamily="34" charset="-122"/>
-                <a:cs typeface="PingFang SC" pitchFamily="34" charset="-120"/>
-              </a:rPr>
-              <a:t>DEFINE · 定标准</a:t>
-            </a:r>
-            <a:endParaRPr lang="zh-CN" sz="850" dirty="0"/>
-          </a:p>
-        </p:txBody>
-      </p:sp>
-      <p:sp>
-        <p:nvSpPr>
-          <p:cNvPr id="44" name="Shape 42"/>
-          <p:cNvSpPr/>
-          <p:nvPr/>
-        </p:nvSpPr>
-        <p:spPr>
-          <a:xfrm>
-            <a:off x="5148072" y="3950208"/>
-            <a:ext cx="3154680" cy="283464"/>
-          </a:xfrm>
-          <a:prstGeom prst="rect">
-            <a:avLst/>
-          </a:prstGeom>
-          <a:solidFill>
-            <a:srgbClr val="002FA7"/>
-          </a:solidFill>
-          <a:ln w="6350">
-            <a:solidFill>
-              <a:srgbClr val="002FA7">
-                <a:alpha val="0"/>
-              </a:srgbClr>
-            </a:solidFill>
-            <a:prstDash val="solid"/>
-          </a:ln>
-        </p:spPr>
-      </p:sp>
-      <p:sp>
-        <p:nvSpPr>
-          <p:cNvPr id="45" name="Text 43"/>
-          <p:cNvSpPr txBox="1"/>
-          <p:nvPr/>
-        </p:nvSpPr>
-        <p:spPr>
-          <a:xfrm>
-            <a:off x="5285232" y="4005072"/>
-            <a:ext cx="2880360" cy="219456"/>
-          </a:xfrm>
-          <a:prstGeom prst="rect">
-            <a:avLst/>
-          </a:prstGeom>
-          <a:noFill/>
-          <a:ln/>
-        </p:spPr>
-        <p:txBody>
-          <a:bodyPr wrap="square" lIns="0" tIns="0" rIns="0" bIns="0" rtlCol="0" anchor="ctr"/>
-          <a:lstStyle/>
-          <a:p>
-            <a:pPr algn="ctr" indent="0" marL="0">
-              <a:buNone/>
-            </a:pPr>
-            <a:r>
-              <a:rPr lang="zh-CN" altLang="en-US" sz="850" b="1" spc="115" kern="0" dirty="0">
-                <a:solidFill>
-                  <a:srgbClr val="FFFFFF"/>
-                </a:solidFill>
-                <a:latin typeface="PingFang SC" pitchFamily="34" charset="0"/>
-                <a:ea typeface="PingFang SC" pitchFamily="34" charset="-122"/>
-                <a:cs typeface="PingFang SC" pitchFamily="34" charset="-120"/>
-              </a:rPr>
-              <a:t>DISCOVER · 识人才</a:t>
-            </a:r>
-            <a:endParaRPr lang="zh-CN" sz="850" dirty="0"/>
-          </a:p>
-        </p:txBody>
-      </p:sp>
-      <p:sp>
-        <p:nvSpPr>
-          <p:cNvPr id="46" name="Shape 44"/>
-          <p:cNvSpPr/>
-          <p:nvPr/>
-        </p:nvSpPr>
-        <p:spPr>
-          <a:xfrm>
-            <a:off x="8421624" y="3950208"/>
-            <a:ext cx="3154680" cy="283464"/>
-          </a:xfrm>
-          <a:prstGeom prst="rect">
-            <a:avLst/>
-          </a:prstGeom>
-          <a:solidFill>
-            <a:srgbClr val="EEF3E8"/>
-          </a:solidFill>
-          <a:ln w="6350">
-            <a:solidFill>
-              <a:srgbClr val="EEF3E8">
-                <a:alpha val="0"/>
-              </a:srgbClr>
-            </a:solidFill>
-            <a:prstDash val="solid"/>
-          </a:ln>
-        </p:spPr>
-      </p:sp>
-      <p:sp>
-        <p:nvSpPr>
-          <p:cNvPr id="47" name="Text 45"/>
-          <p:cNvSpPr txBox="1"/>
-          <p:nvPr/>
-        </p:nvSpPr>
-        <p:spPr>
-          <a:xfrm>
-            <a:off x="8558784" y="4005072"/>
-            <a:ext cx="2880360" cy="219456"/>
-          </a:xfrm>
-          <a:prstGeom prst="rect">
-            <a:avLst/>
-          </a:prstGeom>
-          <a:noFill/>
-          <a:ln/>
-        </p:spPr>
-        <p:txBody>
-          <a:bodyPr wrap="square" lIns="0" tIns="0" rIns="0" bIns="0" rtlCol="0" anchor="ctr"/>
-          <a:lstStyle/>
-          <a:p>
-            <a:pPr algn="ctr" indent="0" marL="0">
-              <a:buNone/>
-            </a:pPr>
-            <a:r>
-              <a:rPr lang="zh-CN" altLang="en-US" sz="850" b="1" spc="115" kern="0" dirty="0">
-                <a:solidFill>
-                  <a:srgbClr val="44652B"/>
-                </a:solidFill>
-                <a:latin typeface="PingFang SC" pitchFamily="34" charset="0"/>
-                <a:ea typeface="PingFang SC" pitchFamily="34" charset="-122"/>
-                <a:cs typeface="PingFang SC" pitchFamily="34" charset="-120"/>
-              </a:rPr>
-              <a:t>DRIVE · 促发展</a:t>
-            </a:r>
-            <a:endParaRPr lang="zh-CN" sz="850" dirty="0"/>
-          </a:p>
-        </p:txBody>
-      </p:sp>
-      <p:sp>
-        <p:nvSpPr>
-          <p:cNvPr id="48" name="Shape 46"/>
-          <p:cNvSpPr/>
-          <p:nvPr/>
-        </p:nvSpPr>
-        <p:spPr>
-          <a:xfrm>
-            <a:off x="1874520" y="4315968"/>
-            <a:ext cx="3154680" cy="320040"/>
-          </a:xfrm>
-          <a:prstGeom prst="rect">
-            <a:avLst/>
-          </a:prstGeom>
-          <a:solidFill>
-            <a:srgbClr val="FFFFFF"/>
-          </a:solidFill>
-          <a:ln w="6985">
-            <a:solidFill>
-              <a:srgbClr val="D4D4D2"/>
-            </a:solidFill>
-            <a:prstDash val="solid"/>
-          </a:ln>
-        </p:spPr>
-      </p:sp>
-      <p:sp>
-        <p:nvSpPr>
-          <p:cNvPr id="49" name="Text 47"/>
-          <p:cNvSpPr txBox="1"/>
-          <p:nvPr/>
-        </p:nvSpPr>
-        <p:spPr>
-          <a:xfrm>
-            <a:off x="2011680" y="4389120"/>
-            <a:ext cx="1700784" cy="173736"/>
+              <a:t>CONDUCT · 学</a:t>
+            </a:r>
+            <a:endParaRPr lang="zh-CN" sz="1360" dirty="0"/>
+          </a:p>
+        </p:txBody>
+      </p:sp>
+      <p:sp>
+        <p:nvSpPr>
+          <p:cNvPr id="65" name="Text 63"/>
+          <p:cNvSpPr txBox="1"/>
+          <p:nvPr/>
+        </p:nvSpPr>
+        <p:spPr>
+          <a:xfrm>
+            <a:off x="2450592" y="5404104"/>
+            <a:ext cx="2773680" cy="210312"/>
           </a:xfrm>
           <a:prstGeom prst="rect">
             <a:avLst/>
@@ -9560,7 +10168,112 @@
               <a:buNone/>
             </a:pPr>
             <a:r>
-              <a:rPr lang="zh-CN" altLang="en-US" sz="1020" b="1" dirty="0">
+              <a:rPr lang="zh-CN" altLang="en-US" sz="960" dirty="0">
+                <a:solidFill>
+                  <a:srgbClr val="525252"/>
+                </a:solidFill>
+                <a:latin typeface="PingFang SC" pitchFamily="34" charset="0"/>
+                <a:ea typeface="PingFang SC" pitchFamily="34" charset="-122"/>
+                <a:cs typeface="PingFang SC" pitchFamily="34" charset="-120"/>
+              </a:rPr>
+              <a:t>在线学习承接知识与课程</a:t>
+            </a:r>
+            <a:endParaRPr lang="zh-CN" sz="960" dirty="0"/>
+          </a:p>
+        </p:txBody>
+      </p:sp>
+      <p:sp>
+        <p:nvSpPr>
+          <p:cNvPr id="66" name="Shape 64"/>
+          <p:cNvSpPr/>
+          <p:nvPr/>
+        </p:nvSpPr>
+        <p:spPr>
+          <a:xfrm>
+            <a:off x="5388864" y="4727448"/>
+            <a:ext cx="3102864" cy="941832"/>
+          </a:xfrm>
+          <a:prstGeom prst="rect">
+            <a:avLst/>
+          </a:prstGeom>
+          <a:solidFill>
+            <a:srgbClr val="F0F0EE"/>
+          </a:solidFill>
+          <a:ln w="5715">
+            <a:solidFill>
+              <a:srgbClr val="D4D4D2"/>
+            </a:solidFill>
+            <a:prstDash val="solid"/>
+          </a:ln>
+        </p:spPr>
+      </p:sp>
+      <p:sp>
+        <p:nvSpPr>
+          <p:cNvPr id="67" name="Text 65"/>
+          <p:cNvSpPr txBox="1"/>
+          <p:nvPr/>
+        </p:nvSpPr>
+        <p:spPr>
+          <a:xfrm>
+            <a:off x="5553456" y="4864608"/>
+            <a:ext cx="804672" cy="219456"/>
+          </a:xfrm>
+          <a:prstGeom prst="rect">
+            <a:avLst/>
+          </a:prstGeom>
+          <a:noFill/>
+          <a:ln/>
+        </p:spPr>
+        <p:txBody>
+          <a:bodyPr wrap="square" lIns="0" tIns="0" rIns="0" bIns="0" rtlCol="0" anchor="ctr"/>
+          <a:lstStyle/>
+          <a:p>
+            <a:pPr algn="l" indent="0" marL="0">
+              <a:buNone/>
+            </a:pPr>
+            <a:r>
+              <a:rPr lang="zh-CN" altLang="en-US" sz="820" b="1" spc="120" kern="0" dirty="0">
+                <a:solidFill>
+                  <a:srgbClr val="737373"/>
+                </a:solidFill>
+                <a:latin typeface="PingFang SC" pitchFamily="34" charset="0"/>
+                <a:ea typeface="PingFang SC" pitchFamily="34" charset="-122"/>
+                <a:cs typeface="PingFang SC" pitchFamily="34" charset="-120"/>
+              </a:rPr>
+              <a:t>02 / LD</a:t>
+            </a:r>
+            <a:endParaRPr lang="zh-CN" sz="820" dirty="0"/>
+          </a:p>
+        </p:txBody>
+      </p:sp>
+      <p:sp>
+        <p:nvSpPr>
+          <p:cNvPr id="68" name="Text 66"/>
+          <p:cNvSpPr txBox="1"/>
+          <p:nvPr/>
+        </p:nvSpPr>
+        <p:spPr>
+          <a:xfrm>
+            <a:off x="5553456" y="5102352"/>
+            <a:ext cx="2773680" cy="246888"/>
+          </a:xfrm>
+          <a:prstGeom prst="rect">
+            <a:avLst/>
+          </a:prstGeom>
+          <a:noFill/>
+          <a:ln/>
+        </p:spPr>
+        <p:txBody>
+          <a:bodyPr wrap="square" lIns="0" tIns="0" rIns="0" bIns="0" rtlCol="0" anchor="t">
+            <a:normAutofit/>
+          </a:bodyPr>
+          <a:lstStyle/>
+          <a:p>
+            <a:pPr algn="l" indent="0" marL="0">
+              <a:buNone/>
+            </a:pPr>
+            <a:r>
+              <a:rPr lang="zh-CN" altLang="en-US" sz="1360" dirty="0">
                 <a:solidFill>
                   <a:srgbClr val="0A0A0A"/>
                 </a:solidFill>
@@ -9568,22 +10281,22 @@
                 <a:ea typeface="PingFang SC" pitchFamily="34" charset="-122"/>
                 <a:cs typeface="PingFang SC" pitchFamily="34" charset="-120"/>
               </a:rPr>
-              <a:t>组织 / 关键岗位分析</a:t>
-            </a:r>
-            <a:endParaRPr lang="zh-CN" sz="1020" dirty="0"/>
-          </a:p>
-        </p:txBody>
-      </p:sp>
-      <p:sp>
-        <p:nvSpPr>
-          <p:cNvPr id="50" name="Text 48"/>
-          <p:cNvSpPr txBox="1"/>
-          <p:nvPr/>
-        </p:nvSpPr>
-        <p:spPr>
-          <a:xfrm>
-            <a:off x="3584448" y="4389120"/>
-            <a:ext cx="1298448" cy="173736"/>
+              <a:t>CONSTRUCT · 习</a:t>
+            </a:r>
+            <a:endParaRPr lang="zh-CN" sz="1360" dirty="0"/>
+          </a:p>
+        </p:txBody>
+      </p:sp>
+      <p:sp>
+        <p:nvSpPr>
+          <p:cNvPr id="69" name="Text 67"/>
+          <p:cNvSpPr txBox="1"/>
+          <p:nvPr/>
+        </p:nvSpPr>
+        <p:spPr>
+          <a:xfrm>
+            <a:off x="5553456" y="5404104"/>
+            <a:ext cx="2773680" cy="210312"/>
           </a:xfrm>
           <a:prstGeom prst="rect">
             <a:avLst/>
@@ -9597,11 +10310,75 @@
           </a:bodyPr>
           <a:lstStyle/>
           <a:p>
-            <a:pPr algn="r" indent="0" marL="0">
-              <a:buNone/>
-            </a:pPr>
-            <a:r>
-              <a:rPr lang="zh-CN" altLang="en-US" sz="850" dirty="0">
+            <a:pPr algn="l" indent="0" marL="0">
+              <a:buNone/>
+            </a:pPr>
+            <a:r>
+              <a:rPr lang="zh-CN" altLang="en-US" sz="960" dirty="0">
+                <a:solidFill>
+                  <a:srgbClr val="525252"/>
+                </a:solidFill>
+                <a:latin typeface="PingFang SC" pitchFamily="34" charset="0"/>
+                <a:ea typeface="PingFang SC" pitchFamily="34" charset="-122"/>
+                <a:cs typeface="PingFang SC" pitchFamily="34" charset="-120"/>
+              </a:rPr>
+              <a:t>AI 陪练与项目实践</a:t>
+            </a:r>
+            <a:endParaRPr lang="zh-CN" sz="960" dirty="0"/>
+          </a:p>
+        </p:txBody>
+      </p:sp>
+      <p:sp>
+        <p:nvSpPr>
+          <p:cNvPr id="70" name="Shape 68"/>
+          <p:cNvSpPr/>
+          <p:nvPr/>
+        </p:nvSpPr>
+        <p:spPr>
+          <a:xfrm>
+            <a:off x="8491728" y="4727448"/>
+            <a:ext cx="3102864" cy="941832"/>
+          </a:xfrm>
+          <a:prstGeom prst="rect">
+            <a:avLst/>
+          </a:prstGeom>
+          <a:solidFill>
+            <a:srgbClr val="F0F0EE"/>
+          </a:solidFill>
+          <a:ln w="5715">
+            <a:solidFill>
+              <a:srgbClr val="D4D4D2"/>
+            </a:solidFill>
+            <a:prstDash val="solid"/>
+          </a:ln>
+        </p:spPr>
+      </p:sp>
+      <p:sp>
+        <p:nvSpPr>
+          <p:cNvPr id="71" name="Text 69"/>
+          <p:cNvSpPr txBox="1"/>
+          <p:nvPr/>
+        </p:nvSpPr>
+        <p:spPr>
+          <a:xfrm>
+            <a:off x="8656320" y="4864608"/>
+            <a:ext cx="804672" cy="219456"/>
+          </a:xfrm>
+          <a:prstGeom prst="rect">
+            <a:avLst/>
+          </a:prstGeom>
+          <a:noFill/>
+          <a:ln/>
+        </p:spPr>
+        <p:txBody>
+          <a:bodyPr wrap="square" lIns="0" tIns="0" rIns="0" bIns="0" rtlCol="0" anchor="ctr"/>
+          <a:lstStyle/>
+          <a:p>
+            <a:pPr algn="l" indent="0" marL="0">
+              <a:buNone/>
+            </a:pPr>
+            <a:r>
+              <a:rPr lang="zh-CN" altLang="en-US" sz="820" b="1" spc="120" kern="0" dirty="0">
                 <a:solidFill>
                   <a:srgbClr val="737373"/>
                 </a:solidFill>
@@ -9609,47 +10386,63 @@
                 <a:ea typeface="PingFang SC" pitchFamily="34" charset="-122"/>
                 <a:cs typeface="PingFang SC" pitchFamily="34" charset="-120"/>
               </a:rPr>
-              <a:t>确定优先范围</a:t>
-            </a:r>
-            <a:endParaRPr lang="zh-CN" sz="850" dirty="0"/>
-          </a:p>
-        </p:txBody>
-      </p:sp>
-      <p:sp>
-        <p:nvSpPr>
-          <p:cNvPr id="51" name="Shape 49"/>
-          <p:cNvSpPr/>
-          <p:nvPr/>
-        </p:nvSpPr>
-        <p:spPr>
-          <a:xfrm>
-            <a:off x="1874520" y="4709160"/>
-            <a:ext cx="3154680" cy="320040"/>
-          </a:xfrm>
-          <a:prstGeom prst="rect">
-            <a:avLst/>
-          </a:prstGeom>
-          <a:solidFill>
-            <a:srgbClr val="FFFFFF"/>
-          </a:solidFill>
-          <a:ln w="6985">
-            <a:solidFill>
-              <a:srgbClr val="D4D4D2"/>
-            </a:solidFill>
-            <a:prstDash val="solid"/>
-          </a:ln>
-        </p:spPr>
-      </p:sp>
-      <p:sp>
-        <p:nvSpPr>
-          <p:cNvPr id="52" name="Text 50"/>
-          <p:cNvSpPr txBox="1"/>
-          <p:nvPr/>
-        </p:nvSpPr>
-        <p:spPr>
-          <a:xfrm>
-            <a:off x="2011680" y="4782312"/>
-            <a:ext cx="1700784" cy="173736"/>
+              <a:t>03 / LD</a:t>
+            </a:r>
+            <a:endParaRPr lang="zh-CN" sz="820" dirty="0"/>
+          </a:p>
+        </p:txBody>
+      </p:sp>
+      <p:sp>
+        <p:nvSpPr>
+          <p:cNvPr id="72" name="Text 70"/>
+          <p:cNvSpPr txBox="1"/>
+          <p:nvPr/>
+        </p:nvSpPr>
+        <p:spPr>
+          <a:xfrm>
+            <a:off x="8656320" y="5102352"/>
+            <a:ext cx="2773680" cy="246888"/>
+          </a:xfrm>
+          <a:prstGeom prst="rect">
+            <a:avLst/>
+          </a:prstGeom>
+          <a:noFill/>
+          <a:ln/>
+        </p:spPr>
+        <p:txBody>
+          <a:bodyPr wrap="square" lIns="0" tIns="0" rIns="0" bIns="0" rtlCol="0" anchor="t">
+            <a:normAutofit/>
+          </a:bodyPr>
+          <a:lstStyle/>
+          <a:p>
+            <a:pPr algn="l" indent="0" marL="0">
+              <a:buNone/>
+            </a:pPr>
+            <a:r>
+              <a:rPr lang="zh-CN" altLang="en-US" sz="1360" dirty="0">
+                <a:solidFill>
+                  <a:srgbClr val="0A0A0A"/>
+                </a:solidFill>
+                <a:latin typeface="PingFang SC" pitchFamily="34" charset="0"/>
+                <a:ea typeface="PingFang SC" pitchFamily="34" charset="-122"/>
+                <a:cs typeface="PingFang SC" pitchFamily="34" charset="-120"/>
+              </a:rPr>
+              <a:t>CONVERT · 变</a:t>
+            </a:r>
+            <a:endParaRPr lang="zh-CN" sz="1360" dirty="0"/>
+          </a:p>
+        </p:txBody>
+      </p:sp>
+      <p:sp>
+        <p:nvSpPr>
+          <p:cNvPr id="73" name="Text 71"/>
+          <p:cNvSpPr txBox="1"/>
+          <p:nvPr/>
+        </p:nvSpPr>
+        <p:spPr>
+          <a:xfrm>
+            <a:off x="8656320" y="5404104"/>
+            <a:ext cx="2773680" cy="210312"/>
           </a:xfrm>
           <a:prstGeom prst="rect">
             <a:avLst/>
@@ -9667,105 +10460,103 @@
               <a:buNone/>
             </a:pPr>
             <a:r>
-              <a:rPr lang="zh-CN" altLang="en-US" sz="1020" b="1" dirty="0">
-                <a:solidFill>
-                  <a:srgbClr val="0A0A0A"/>
-                </a:solidFill>
-                <a:latin typeface="PingFang SC" pitchFamily="34" charset="0"/>
-                <a:ea typeface="PingFang SC" pitchFamily="34" charset="-122"/>
-                <a:cs typeface="PingFang SC" pitchFamily="34" charset="-120"/>
-              </a:rPr>
-              <a:t>岗位标准</a:t>
-            </a:r>
-            <a:endParaRPr lang="zh-CN" sz="1020" dirty="0"/>
-          </a:p>
-        </p:txBody>
-      </p:sp>
-      <p:sp>
-        <p:nvSpPr>
-          <p:cNvPr id="53" name="Text 51"/>
-          <p:cNvSpPr txBox="1"/>
-          <p:nvPr/>
-        </p:nvSpPr>
-        <p:spPr>
-          <a:xfrm>
-            <a:off x="3584448" y="4782312"/>
-            <a:ext cx="1298448" cy="173736"/>
-          </a:xfrm>
-          <a:prstGeom prst="rect">
-            <a:avLst/>
-          </a:prstGeom>
-          <a:noFill/>
-          <a:ln/>
-        </p:spPr>
-        <p:txBody>
-          <a:bodyPr wrap="square" lIns="0" tIns="0" rIns="0" bIns="0" rtlCol="0" anchor="ctr">
+              <a:rPr lang="zh-CN" altLang="en-US" sz="960" dirty="0">
+                <a:solidFill>
+                  <a:srgbClr val="525252"/>
+                </a:solidFill>
+                <a:latin typeface="PingFang SC" pitchFamily="34" charset="0"/>
+                <a:ea typeface="PingFang SC" pitchFamily="34" charset="-122"/>
+                <a:cs typeface="PingFang SC" pitchFamily="34" charset="-120"/>
+              </a:rPr>
+              <a:t>行动学习推动能力转化</a:t>
+            </a:r>
+            <a:endParaRPr lang="zh-CN" sz="960" dirty="0"/>
+          </a:p>
+        </p:txBody>
+      </p:sp>
+      <p:sp>
+        <p:nvSpPr>
+          <p:cNvPr id="74" name="Shape 72"/>
+          <p:cNvSpPr/>
+          <p:nvPr/>
+        </p:nvSpPr>
+        <p:spPr>
+          <a:xfrm>
+            <a:off x="594360" y="5925312"/>
+            <a:ext cx="11000232" cy="0"/>
+          </a:xfrm>
+          <a:prstGeom prst="line">
+            <a:avLst/>
+          </a:prstGeom>
+          <a:noFill/>
+          <a:ln w="15240">
+            <a:solidFill>
+              <a:srgbClr val="002FA7"/>
+            </a:solidFill>
+            <a:prstDash val="solid"/>
+          </a:ln>
+        </p:spPr>
+      </p:sp>
+      <p:sp>
+        <p:nvSpPr>
+          <p:cNvPr id="75" name="Text 73"/>
+          <p:cNvSpPr txBox="1"/>
+          <p:nvPr/>
+        </p:nvSpPr>
+        <p:spPr>
+          <a:xfrm>
+            <a:off x="594360" y="6071616"/>
+            <a:ext cx="2011680" cy="246888"/>
+          </a:xfrm>
+          <a:prstGeom prst="rect">
+            <a:avLst/>
+          </a:prstGeom>
+          <a:noFill/>
+          <a:ln/>
+        </p:spPr>
+        <p:txBody>
+          <a:bodyPr wrap="square" lIns="0" tIns="0" rIns="0" bIns="0" rtlCol="0" anchor="t">
             <a:normAutofit/>
           </a:bodyPr>
           <a:lstStyle/>
           <a:p>
-            <a:pPr algn="r" indent="0" marL="0">
-              <a:buNone/>
-            </a:pPr>
-            <a:r>
-              <a:rPr lang="zh-CN" altLang="en-US" sz="850" dirty="0">
-                <a:solidFill>
-                  <a:srgbClr val="737373"/>
-                </a:solidFill>
-                <a:latin typeface="PingFang SC" pitchFamily="34" charset="0"/>
-                <a:ea typeface="PingFang SC" pitchFamily="34" charset="-122"/>
-                <a:cs typeface="PingFang SC" pitchFamily="34" charset="-120"/>
-              </a:rPr>
-              <a:t>建立统一尺子</a:t>
-            </a:r>
-            <a:endParaRPr lang="zh-CN" sz="850" dirty="0"/>
-          </a:p>
-        </p:txBody>
-      </p:sp>
-      <p:sp>
-        <p:nvSpPr>
-          <p:cNvPr id="54" name="Shape 52"/>
-          <p:cNvSpPr/>
-          <p:nvPr/>
-        </p:nvSpPr>
-        <p:spPr>
-          <a:xfrm>
-            <a:off x="5148072" y="4315968"/>
-            <a:ext cx="3154680" cy="320040"/>
-          </a:xfrm>
-          <a:prstGeom prst="rect">
-            <a:avLst/>
-          </a:prstGeom>
-          <a:solidFill>
-            <a:srgbClr val="FFFFFF"/>
-          </a:solidFill>
-          <a:ln w="6985">
-            <a:solidFill>
-              <a:srgbClr val="D4D4D2"/>
-            </a:solidFill>
-            <a:prstDash val="solid"/>
-          </a:ln>
-        </p:spPr>
-      </p:sp>
-      <p:sp>
-        <p:nvSpPr>
-          <p:cNvPr id="55" name="Text 53"/>
-          <p:cNvSpPr txBox="1"/>
-          <p:nvPr/>
-        </p:nvSpPr>
-        <p:spPr>
-          <a:xfrm>
-            <a:off x="5285232" y="4389120"/>
-            <a:ext cx="1700784" cy="173736"/>
-          </a:xfrm>
-          <a:prstGeom prst="rect">
-            <a:avLst/>
-          </a:prstGeom>
-          <a:noFill/>
-          <a:ln/>
-        </p:spPr>
-        <p:txBody>
-          <a:bodyPr wrap="square" lIns="0" tIns="0" rIns="0" bIns="0" rtlCol="0" anchor="ctr">
+            <a:pPr algn="l" indent="0" marL="0">
+              <a:buNone/>
+            </a:pPr>
+            <a:r>
+              <a:rPr lang="zh-CN" altLang="en-US" sz="1260" b="1" dirty="0">
+                <a:solidFill>
+                  <a:srgbClr val="002FA7"/>
+                </a:solidFill>
+                <a:latin typeface="PingFang SC" pitchFamily="34" charset="0"/>
+                <a:ea typeface="PingFang SC" pitchFamily="34" charset="-122"/>
+                <a:cs typeface="PingFang SC" pitchFamily="34" charset="-120"/>
+              </a:rPr>
+              <a:t>战略向下解码</a:t>
+            </a:r>
+            <a:endParaRPr lang="zh-CN" sz="1260" dirty="0"/>
+          </a:p>
+        </p:txBody>
+      </p:sp>
+      <p:sp>
+        <p:nvSpPr>
+          <p:cNvPr id="76" name="Text 74"/>
+          <p:cNvSpPr txBox="1"/>
+          <p:nvPr/>
+        </p:nvSpPr>
+        <p:spPr>
+          <a:xfrm>
+            <a:off x="2606040" y="6071616"/>
+            <a:ext cx="8988552" cy="274320"/>
+          </a:xfrm>
+          <a:prstGeom prst="rect">
+            <a:avLst/>
+          </a:prstGeom>
+          <a:noFill/>
+          <a:ln/>
+        </p:spPr>
+        <p:txBody>
+          <a:bodyPr wrap="square" lIns="0" tIns="0" rIns="0" bIns="0" rtlCol="0" anchor="t">
             <a:normAutofit/>
           </a:bodyPr>
           <a:lstStyle/>
@@ -9774,930 +10565,19 @@
               <a:buNone/>
             </a:pPr>
             <a:r>
-              <a:rPr lang="zh-CN" altLang="en-US" sz="1020" b="1" dirty="0">
-                <a:solidFill>
-                  <a:srgbClr val="0A0A0A"/>
-                </a:solidFill>
-                <a:latin typeface="PingFang SC" pitchFamily="34" charset="0"/>
-                <a:ea typeface="PingFang SC" pitchFamily="34" charset="-122"/>
-                <a:cs typeface="PingFang SC" pitchFamily="34" charset="-120"/>
-              </a:rPr>
-              <a:t>评鉴工具</a:t>
-            </a:r>
-            <a:endParaRPr lang="zh-CN" sz="1020" dirty="0"/>
-          </a:p>
-        </p:txBody>
-      </p:sp>
-      <p:sp>
-        <p:nvSpPr>
-          <p:cNvPr id="56" name="Text 54"/>
-          <p:cNvSpPr txBox="1"/>
-          <p:nvPr/>
-        </p:nvSpPr>
-        <p:spPr>
-          <a:xfrm>
-            <a:off x="6858000" y="4389120"/>
-            <a:ext cx="1298448" cy="173736"/>
-          </a:xfrm>
-          <a:prstGeom prst="rect">
-            <a:avLst/>
-          </a:prstGeom>
-          <a:noFill/>
-          <a:ln/>
-        </p:spPr>
-        <p:txBody>
-          <a:bodyPr wrap="square" lIns="0" tIns="0" rIns="0" bIns="0" rtlCol="0" anchor="ctr">
-            <a:normAutofit/>
-          </a:bodyPr>
-          <a:lstStyle/>
-          <a:p>
-            <a:pPr algn="r" indent="0" marL="0">
-              <a:buNone/>
-            </a:pPr>
-            <a:r>
-              <a:rPr lang="zh-CN" altLang="en-US" sz="850" dirty="0">
-                <a:solidFill>
-                  <a:srgbClr val="737373"/>
-                </a:solidFill>
-                <a:latin typeface="PingFang SC" pitchFamily="34" charset="0"/>
-                <a:ea typeface="PingFang SC" pitchFamily="34" charset="-122"/>
-                <a:cs typeface="PingFang SC" pitchFamily="34" charset="-120"/>
-              </a:rPr>
-              <a:t>收集能力、动力、潜力</a:t>
-            </a:r>
-            <a:endParaRPr lang="zh-CN" sz="850" dirty="0"/>
-          </a:p>
-        </p:txBody>
-      </p:sp>
-      <p:sp>
-        <p:nvSpPr>
-          <p:cNvPr id="57" name="Shape 55"/>
-          <p:cNvSpPr/>
-          <p:nvPr/>
-        </p:nvSpPr>
-        <p:spPr>
-          <a:xfrm>
-            <a:off x="5148072" y="4709160"/>
-            <a:ext cx="3154680" cy="320040"/>
-          </a:xfrm>
-          <a:prstGeom prst="rect">
-            <a:avLst/>
-          </a:prstGeom>
-          <a:solidFill>
-            <a:srgbClr val="FFFFFF"/>
-          </a:solidFill>
-          <a:ln w="6985">
-            <a:solidFill>
-              <a:srgbClr val="D4D4D2"/>
-            </a:solidFill>
-            <a:prstDash val="solid"/>
-          </a:ln>
-        </p:spPr>
-      </p:sp>
-      <p:sp>
-        <p:nvSpPr>
-          <p:cNvPr id="58" name="Text 56"/>
-          <p:cNvSpPr txBox="1"/>
-          <p:nvPr/>
-        </p:nvSpPr>
-        <p:spPr>
-          <a:xfrm>
-            <a:off x="5285232" y="4782312"/>
-            <a:ext cx="1700784" cy="173736"/>
-          </a:xfrm>
-          <a:prstGeom prst="rect">
-            <a:avLst/>
-          </a:prstGeom>
-          <a:noFill/>
-          <a:ln/>
-        </p:spPr>
-        <p:txBody>
-          <a:bodyPr wrap="square" lIns="0" tIns="0" rIns="0" bIns="0" rtlCol="0" anchor="ctr">
-            <a:normAutofit/>
-          </a:bodyPr>
-          <a:lstStyle/>
-          <a:p>
-            <a:pPr algn="l" indent="0" marL="0">
-              <a:buNone/>
-            </a:pPr>
-            <a:r>
-              <a:rPr lang="zh-CN" altLang="en-US" sz="1020" b="1" dirty="0">
-                <a:solidFill>
-                  <a:srgbClr val="0A0A0A"/>
-                </a:solidFill>
-                <a:latin typeface="PingFang SC" pitchFamily="34" charset="0"/>
-                <a:ea typeface="PingFang SC" pitchFamily="34" charset="-122"/>
-                <a:cs typeface="PingFang SC" pitchFamily="34" charset="-120"/>
-              </a:rPr>
-              <a:t>人才盘点</a:t>
-            </a:r>
-            <a:endParaRPr lang="zh-CN" sz="1020" dirty="0"/>
-          </a:p>
-        </p:txBody>
-      </p:sp>
-      <p:sp>
-        <p:nvSpPr>
-          <p:cNvPr id="59" name="Text 57"/>
-          <p:cNvSpPr txBox="1"/>
-          <p:nvPr/>
-        </p:nvSpPr>
-        <p:spPr>
-          <a:xfrm>
-            <a:off x="6858000" y="4782312"/>
-            <a:ext cx="1298448" cy="173736"/>
-          </a:xfrm>
-          <a:prstGeom prst="rect">
-            <a:avLst/>
-          </a:prstGeom>
-          <a:noFill/>
-          <a:ln/>
-        </p:spPr>
-        <p:txBody>
-          <a:bodyPr wrap="square" lIns="0" tIns="0" rIns="0" bIns="0" rtlCol="0" anchor="ctr">
-            <a:normAutofit/>
-          </a:bodyPr>
-          <a:lstStyle/>
-          <a:p>
-            <a:pPr algn="r" indent="0" marL="0">
-              <a:buNone/>
-            </a:pPr>
-            <a:r>
-              <a:rPr lang="zh-CN" altLang="en-US" sz="850" dirty="0">
-                <a:solidFill>
-                  <a:srgbClr val="737373"/>
-                </a:solidFill>
-                <a:latin typeface="PingFang SC" pitchFamily="34" charset="0"/>
-                <a:ea typeface="PingFang SC" pitchFamily="34" charset="-122"/>
-                <a:cs typeface="PingFang SC" pitchFamily="34" charset="-120"/>
-              </a:rPr>
-              <a:t>看清群体与个人</a:t>
-            </a:r>
-            <a:endParaRPr lang="zh-CN" sz="850" dirty="0"/>
-          </a:p>
-        </p:txBody>
-      </p:sp>
-      <p:sp>
-        <p:nvSpPr>
-          <p:cNvPr id="60" name="Shape 58"/>
-          <p:cNvSpPr/>
-          <p:nvPr/>
-        </p:nvSpPr>
-        <p:spPr>
-          <a:xfrm>
-            <a:off x="8421624" y="4315968"/>
-            <a:ext cx="3154680" cy="320040"/>
-          </a:xfrm>
-          <a:prstGeom prst="rect">
-            <a:avLst/>
-          </a:prstGeom>
-          <a:solidFill>
-            <a:srgbClr val="FFFFFF"/>
-          </a:solidFill>
-          <a:ln w="6985">
-            <a:solidFill>
-              <a:srgbClr val="D4D4D2"/>
-            </a:solidFill>
-            <a:prstDash val="solid"/>
-          </a:ln>
-        </p:spPr>
-      </p:sp>
-      <p:sp>
-        <p:nvSpPr>
-          <p:cNvPr id="61" name="Text 59"/>
-          <p:cNvSpPr txBox="1"/>
-          <p:nvPr/>
-        </p:nvSpPr>
-        <p:spPr>
-          <a:xfrm>
-            <a:off x="8558784" y="4389120"/>
-            <a:ext cx="1700784" cy="173736"/>
-          </a:xfrm>
-          <a:prstGeom prst="rect">
-            <a:avLst/>
-          </a:prstGeom>
-          <a:noFill/>
-          <a:ln/>
-        </p:spPr>
-        <p:txBody>
-          <a:bodyPr wrap="square" lIns="0" tIns="0" rIns="0" bIns="0" rtlCol="0" anchor="ctr">
-            <a:normAutofit/>
-          </a:bodyPr>
-          <a:lstStyle/>
-          <a:p>
-            <a:pPr algn="l" indent="0" marL="0">
-              <a:buNone/>
-            </a:pPr>
-            <a:r>
-              <a:rPr lang="zh-CN" altLang="en-US" sz="1020" b="1" dirty="0">
-                <a:solidFill>
-                  <a:srgbClr val="0A0A0A"/>
-                </a:solidFill>
-                <a:latin typeface="PingFang SC" pitchFamily="34" charset="0"/>
-                <a:ea typeface="PingFang SC" pitchFamily="34" charset="-122"/>
-                <a:cs typeface="PingFang SC" pitchFamily="34" charset="-120"/>
-              </a:rPr>
-              <a:t>人岗匹配</a:t>
-            </a:r>
-            <a:endParaRPr lang="zh-CN" sz="1020" dirty="0"/>
-          </a:p>
-        </p:txBody>
-      </p:sp>
-      <p:sp>
-        <p:nvSpPr>
-          <p:cNvPr id="62" name="Text 60"/>
-          <p:cNvSpPr txBox="1"/>
-          <p:nvPr/>
-        </p:nvSpPr>
-        <p:spPr>
-          <a:xfrm>
-            <a:off x="10131552" y="4389120"/>
-            <a:ext cx="1298448" cy="173736"/>
-          </a:xfrm>
-          <a:prstGeom prst="rect">
-            <a:avLst/>
-          </a:prstGeom>
-          <a:noFill/>
-          <a:ln/>
-        </p:spPr>
-        <p:txBody>
-          <a:bodyPr wrap="square" lIns="0" tIns="0" rIns="0" bIns="0" rtlCol="0" anchor="ctr">
-            <a:normAutofit/>
-          </a:bodyPr>
-          <a:lstStyle/>
-          <a:p>
-            <a:pPr algn="r" indent="0" marL="0">
-              <a:buNone/>
-            </a:pPr>
-            <a:r>
-              <a:rPr lang="zh-CN" altLang="en-US" sz="850" dirty="0">
-                <a:solidFill>
-                  <a:srgbClr val="737373"/>
-                </a:solidFill>
-                <a:latin typeface="PingFang SC" pitchFamily="34" charset="0"/>
-                <a:ea typeface="PingFang SC" pitchFamily="34" charset="-122"/>
-                <a:cs typeface="PingFang SC" pitchFamily="34" charset="-120"/>
-              </a:rPr>
-              <a:t>识别差距</a:t>
-            </a:r>
-            <a:endParaRPr lang="zh-CN" sz="850" dirty="0"/>
-          </a:p>
-        </p:txBody>
-      </p:sp>
-      <p:sp>
-        <p:nvSpPr>
-          <p:cNvPr id="63" name="Shape 61"/>
-          <p:cNvSpPr/>
-          <p:nvPr/>
-        </p:nvSpPr>
-        <p:spPr>
-          <a:xfrm>
-            <a:off x="8421624" y="4709160"/>
-            <a:ext cx="3154680" cy="320040"/>
-          </a:xfrm>
-          <a:prstGeom prst="rect">
-            <a:avLst/>
-          </a:prstGeom>
-          <a:solidFill>
-            <a:srgbClr val="FFFFFF"/>
-          </a:solidFill>
-          <a:ln w="6985">
-            <a:solidFill>
-              <a:srgbClr val="D4D4D2"/>
-            </a:solidFill>
-            <a:prstDash val="solid"/>
-          </a:ln>
-        </p:spPr>
-      </p:sp>
-      <p:sp>
-        <p:nvSpPr>
-          <p:cNvPr id="64" name="Text 62"/>
-          <p:cNvSpPr txBox="1"/>
-          <p:nvPr/>
-        </p:nvSpPr>
-        <p:spPr>
-          <a:xfrm>
-            <a:off x="8558784" y="4782312"/>
-            <a:ext cx="1700784" cy="173736"/>
-          </a:xfrm>
-          <a:prstGeom prst="rect">
-            <a:avLst/>
-          </a:prstGeom>
-          <a:noFill/>
-          <a:ln/>
-        </p:spPr>
-        <p:txBody>
-          <a:bodyPr wrap="square" lIns="0" tIns="0" rIns="0" bIns="0" rtlCol="0" anchor="ctr">
-            <a:normAutofit/>
-          </a:bodyPr>
-          <a:lstStyle/>
-          <a:p>
-            <a:pPr algn="l" indent="0" marL="0">
-              <a:buNone/>
-            </a:pPr>
-            <a:r>
-              <a:rPr lang="zh-CN" altLang="en-US" sz="1020" b="1" dirty="0">
-                <a:solidFill>
-                  <a:srgbClr val="0A0A0A"/>
-                </a:solidFill>
-                <a:latin typeface="PingFang SC" pitchFamily="34" charset="0"/>
-                <a:ea typeface="PingFang SC" pitchFamily="34" charset="-122"/>
-                <a:cs typeface="PingFang SC" pitchFamily="34" charset="-120"/>
-              </a:rPr>
-              <a:t>个人 IDP / 组织培养</a:t>
-            </a:r>
-            <a:endParaRPr lang="zh-CN" sz="1020" dirty="0"/>
-          </a:p>
-        </p:txBody>
-      </p:sp>
-      <p:sp>
-        <p:nvSpPr>
-          <p:cNvPr id="65" name="Text 63"/>
-          <p:cNvSpPr txBox="1"/>
-          <p:nvPr/>
-        </p:nvSpPr>
-        <p:spPr>
-          <a:xfrm>
-            <a:off x="10131552" y="4782312"/>
-            <a:ext cx="1298448" cy="173736"/>
-          </a:xfrm>
-          <a:prstGeom prst="rect">
-            <a:avLst/>
-          </a:prstGeom>
-          <a:noFill/>
-          <a:ln/>
-        </p:spPr>
-        <p:txBody>
-          <a:bodyPr wrap="square" lIns="0" tIns="0" rIns="0" bIns="0" rtlCol="0" anchor="ctr">
-            <a:normAutofit/>
-          </a:bodyPr>
-          <a:lstStyle/>
-          <a:p>
-            <a:pPr algn="r" indent="0" marL="0">
-              <a:buNone/>
-            </a:pPr>
-            <a:r>
-              <a:rPr lang="zh-CN" altLang="en-US" sz="850" dirty="0">
-                <a:solidFill>
-                  <a:srgbClr val="737373"/>
-                </a:solidFill>
-                <a:latin typeface="PingFang SC" pitchFamily="34" charset="0"/>
-                <a:ea typeface="PingFang SC" pitchFamily="34" charset="-122"/>
-                <a:cs typeface="PingFang SC" pitchFamily="34" charset="-120"/>
-              </a:rPr>
-              <a:t>把差距变成行动</a:t>
-            </a:r>
-            <a:endParaRPr lang="zh-CN" sz="850" dirty="0"/>
-          </a:p>
-        </p:txBody>
-      </p:sp>
-      <p:sp>
-        <p:nvSpPr>
-          <p:cNvPr id="66" name="Shape 64"/>
-          <p:cNvSpPr/>
-          <p:nvPr/>
-        </p:nvSpPr>
-        <p:spPr>
-          <a:xfrm>
-            <a:off x="5029200" y="4480560"/>
-            <a:ext cx="118872" cy="0"/>
-          </a:xfrm>
-          <a:prstGeom prst="line">
-            <a:avLst/>
-          </a:prstGeom>
-          <a:noFill/>
-          <a:ln w="12700">
-            <a:solidFill>
-              <a:srgbClr val="002FA7"/>
-            </a:solidFill>
-            <a:prstDash val="solid"/>
-            <a:tailEnd type="triangle"/>
-          </a:ln>
-        </p:spPr>
-      </p:sp>
-      <p:sp>
-        <p:nvSpPr>
-          <p:cNvPr id="67" name="Shape 65"/>
-          <p:cNvSpPr/>
-          <p:nvPr/>
-        </p:nvSpPr>
-        <p:spPr>
-          <a:xfrm>
-            <a:off x="8302752" y="4480560"/>
-            <a:ext cx="118872" cy="0"/>
-          </a:xfrm>
-          <a:prstGeom prst="line">
-            <a:avLst/>
-          </a:prstGeom>
-          <a:noFill/>
-          <a:ln w="12700">
-            <a:solidFill>
-              <a:srgbClr val="002FA7"/>
-            </a:solidFill>
-            <a:prstDash val="solid"/>
-            <a:tailEnd type="triangle"/>
-          </a:ln>
-        </p:spPr>
-      </p:sp>
-      <p:sp>
-        <p:nvSpPr>
-          <p:cNvPr id="68" name="Text 66"/>
-          <p:cNvSpPr txBox="1"/>
-          <p:nvPr/>
-        </p:nvSpPr>
-        <p:spPr>
-          <a:xfrm>
-            <a:off x="2002536" y="5385816"/>
-            <a:ext cx="2880360" cy="219456"/>
-          </a:xfrm>
-          <a:prstGeom prst="rect">
-            <a:avLst/>
-          </a:prstGeom>
-          <a:noFill/>
-          <a:ln/>
-        </p:spPr>
-        <p:txBody>
-          <a:bodyPr wrap="square" lIns="0" tIns="0" rIns="0" bIns="0" rtlCol="0" anchor="ctr"/>
-          <a:lstStyle/>
-          <a:p>
-            <a:pPr algn="ctr" indent="0" marL="0">
-              <a:buNone/>
-            </a:pPr>
-            <a:r>
-              <a:rPr lang="zh-CN" altLang="en-US" sz="850" b="1" spc="115" kern="0" dirty="0">
-                <a:solidFill>
-                  <a:srgbClr val="8B4A20"/>
-                </a:solidFill>
-                <a:latin typeface="PingFang SC" pitchFamily="34" charset="0"/>
-                <a:ea typeface="PingFang SC" pitchFamily="34" charset="-122"/>
-                <a:cs typeface="PingFang SC" pitchFamily="34" charset="-120"/>
-              </a:rPr>
-              <a:t>CONDUCT · 学</a:t>
-            </a:r>
-            <a:endParaRPr lang="zh-CN" sz="850" dirty="0"/>
-          </a:p>
-        </p:txBody>
-      </p:sp>
-      <p:sp>
-        <p:nvSpPr>
-          <p:cNvPr id="69" name="Shape 67"/>
-          <p:cNvSpPr/>
-          <p:nvPr/>
-        </p:nvSpPr>
-        <p:spPr>
-          <a:xfrm>
-            <a:off x="1874520" y="5641848"/>
-            <a:ext cx="3154680" cy="329184"/>
-          </a:xfrm>
-          <a:prstGeom prst="rect">
-            <a:avLst/>
-          </a:prstGeom>
-          <a:solidFill>
-            <a:srgbClr val="FFFFFF"/>
-          </a:solidFill>
-          <a:ln w="6985">
-            <a:solidFill>
-              <a:srgbClr val="D4D4D2"/>
-            </a:solidFill>
-            <a:prstDash val="solid"/>
-          </a:ln>
-        </p:spPr>
-      </p:sp>
-      <p:sp>
-        <p:nvSpPr>
-          <p:cNvPr id="70" name="Text 68"/>
-          <p:cNvSpPr txBox="1"/>
-          <p:nvPr/>
-        </p:nvSpPr>
-        <p:spPr>
-          <a:xfrm>
-            <a:off x="2039112" y="5715000"/>
-            <a:ext cx="2825496" cy="182880"/>
-          </a:xfrm>
-          <a:prstGeom prst="rect">
-            <a:avLst/>
-          </a:prstGeom>
-          <a:noFill/>
-          <a:ln/>
-        </p:spPr>
-        <p:txBody>
-          <a:bodyPr wrap="square" lIns="0" tIns="0" rIns="0" bIns="0" rtlCol="0" anchor="ctr">
-            <a:normAutofit/>
-          </a:bodyPr>
-          <a:lstStyle/>
-          <a:p>
-            <a:pPr algn="ctr" indent="0" marL="0">
-              <a:buNone/>
-            </a:pPr>
-            <a:r>
-              <a:rPr lang="zh-CN" altLang="en-US" sz="1080" b="1" dirty="0">
-                <a:solidFill>
-                  <a:srgbClr val="0A0A0A"/>
-                </a:solidFill>
-                <a:latin typeface="PingFang SC" pitchFamily="34" charset="0"/>
-                <a:ea typeface="PingFang SC" pitchFamily="34" charset="-122"/>
-                <a:cs typeface="PingFang SC" pitchFamily="34" charset="-120"/>
-              </a:rPr>
-              <a:t>在线学习</a:t>
-            </a:r>
-            <a:endParaRPr lang="zh-CN" sz="1080" dirty="0"/>
-          </a:p>
-        </p:txBody>
-      </p:sp>
-      <p:sp>
-        <p:nvSpPr>
-          <p:cNvPr id="71" name="Shape 69"/>
-          <p:cNvSpPr/>
-          <p:nvPr/>
-        </p:nvSpPr>
-        <p:spPr>
-          <a:xfrm>
-            <a:off x="5029200" y="5806440"/>
-            <a:ext cx="118872" cy="0"/>
-          </a:xfrm>
-          <a:prstGeom prst="line">
-            <a:avLst/>
-          </a:prstGeom>
-          <a:noFill/>
-          <a:ln w="11430">
-            <a:solidFill>
-              <a:srgbClr val="8B4A20"/>
-            </a:solidFill>
-            <a:prstDash val="solid"/>
-            <a:tailEnd type="triangle"/>
-          </a:ln>
-        </p:spPr>
-      </p:sp>
-      <p:sp>
-        <p:nvSpPr>
-          <p:cNvPr id="72" name="Text 70"/>
-          <p:cNvSpPr txBox="1"/>
-          <p:nvPr/>
-        </p:nvSpPr>
-        <p:spPr>
-          <a:xfrm>
-            <a:off x="5276088" y="5385816"/>
-            <a:ext cx="2880360" cy="219456"/>
-          </a:xfrm>
-          <a:prstGeom prst="rect">
-            <a:avLst/>
-          </a:prstGeom>
-          <a:noFill/>
-          <a:ln/>
-        </p:spPr>
-        <p:txBody>
-          <a:bodyPr wrap="square" lIns="0" tIns="0" rIns="0" bIns="0" rtlCol="0" anchor="ctr"/>
-          <a:lstStyle/>
-          <a:p>
-            <a:pPr algn="ctr" indent="0" marL="0">
-              <a:buNone/>
-            </a:pPr>
-            <a:r>
-              <a:rPr lang="zh-CN" altLang="en-US" sz="850" b="1" spc="115" kern="0" dirty="0">
-                <a:solidFill>
-                  <a:srgbClr val="8B4A20"/>
-                </a:solidFill>
-                <a:latin typeface="PingFang SC" pitchFamily="34" charset="0"/>
-                <a:ea typeface="PingFang SC" pitchFamily="34" charset="-122"/>
-                <a:cs typeface="PingFang SC" pitchFamily="34" charset="-120"/>
-              </a:rPr>
-              <a:t>CONSTRUCT · 习</a:t>
-            </a:r>
-            <a:endParaRPr lang="zh-CN" sz="850" dirty="0"/>
-          </a:p>
-        </p:txBody>
-      </p:sp>
-      <p:sp>
-        <p:nvSpPr>
-          <p:cNvPr id="73" name="Shape 71"/>
-          <p:cNvSpPr/>
-          <p:nvPr/>
-        </p:nvSpPr>
-        <p:spPr>
-          <a:xfrm>
-            <a:off x="5148072" y="5641848"/>
-            <a:ext cx="3154680" cy="329184"/>
-          </a:xfrm>
-          <a:prstGeom prst="rect">
-            <a:avLst/>
-          </a:prstGeom>
-          <a:solidFill>
-            <a:srgbClr val="FFFFFF"/>
-          </a:solidFill>
-          <a:ln w="6985">
-            <a:solidFill>
-              <a:srgbClr val="D4D4D2"/>
-            </a:solidFill>
-            <a:prstDash val="solid"/>
-          </a:ln>
-        </p:spPr>
-      </p:sp>
-      <p:sp>
-        <p:nvSpPr>
-          <p:cNvPr id="74" name="Text 72"/>
-          <p:cNvSpPr txBox="1"/>
-          <p:nvPr/>
-        </p:nvSpPr>
-        <p:spPr>
-          <a:xfrm>
-            <a:off x="5312664" y="5715000"/>
-            <a:ext cx="2825496" cy="182880"/>
-          </a:xfrm>
-          <a:prstGeom prst="rect">
-            <a:avLst/>
-          </a:prstGeom>
-          <a:noFill/>
-          <a:ln/>
-        </p:spPr>
-        <p:txBody>
-          <a:bodyPr wrap="square" lIns="0" tIns="0" rIns="0" bIns="0" rtlCol="0" anchor="ctr">
-            <a:normAutofit/>
-          </a:bodyPr>
-          <a:lstStyle/>
-          <a:p>
-            <a:pPr algn="ctr" indent="0" marL="0">
-              <a:buNone/>
-            </a:pPr>
-            <a:r>
-              <a:rPr lang="zh-CN" altLang="en-US" sz="1080" b="1" dirty="0">
-                <a:solidFill>
-                  <a:srgbClr val="0A0A0A"/>
-                </a:solidFill>
-                <a:latin typeface="PingFang SC" pitchFamily="34" charset="0"/>
-                <a:ea typeface="PingFang SC" pitchFamily="34" charset="-122"/>
-                <a:cs typeface="PingFang SC" pitchFamily="34" charset="-120"/>
-              </a:rPr>
-              <a:t>AI 陪练</a:t>
-            </a:r>
-            <a:endParaRPr lang="zh-CN" sz="1080" dirty="0"/>
-          </a:p>
-        </p:txBody>
-      </p:sp>
-      <p:sp>
-        <p:nvSpPr>
-          <p:cNvPr id="75" name="Shape 73"/>
-          <p:cNvSpPr/>
-          <p:nvPr/>
-        </p:nvSpPr>
-        <p:spPr>
-          <a:xfrm>
-            <a:off x="8302752" y="5806440"/>
-            <a:ext cx="118872" cy="0"/>
-          </a:xfrm>
-          <a:prstGeom prst="line">
-            <a:avLst/>
-          </a:prstGeom>
-          <a:noFill/>
-          <a:ln w="11430">
-            <a:solidFill>
-              <a:srgbClr val="8B4A20"/>
-            </a:solidFill>
-            <a:prstDash val="solid"/>
-            <a:tailEnd type="triangle"/>
-          </a:ln>
-        </p:spPr>
-      </p:sp>
-      <p:sp>
-        <p:nvSpPr>
-          <p:cNvPr id="76" name="Text 74"/>
-          <p:cNvSpPr txBox="1"/>
-          <p:nvPr/>
-        </p:nvSpPr>
-        <p:spPr>
-          <a:xfrm>
-            <a:off x="8549640" y="5385816"/>
-            <a:ext cx="2880360" cy="219456"/>
-          </a:xfrm>
-          <a:prstGeom prst="rect">
-            <a:avLst/>
-          </a:prstGeom>
-          <a:noFill/>
-          <a:ln/>
-        </p:spPr>
-        <p:txBody>
-          <a:bodyPr wrap="square" lIns="0" tIns="0" rIns="0" bIns="0" rtlCol="0" anchor="ctr"/>
-          <a:lstStyle/>
-          <a:p>
-            <a:pPr algn="ctr" indent="0" marL="0">
-              <a:buNone/>
-            </a:pPr>
-            <a:r>
-              <a:rPr lang="zh-CN" altLang="en-US" sz="850" b="1" spc="115" kern="0" dirty="0">
-                <a:solidFill>
-                  <a:srgbClr val="8B4A20"/>
-                </a:solidFill>
-                <a:latin typeface="PingFang SC" pitchFamily="34" charset="0"/>
-                <a:ea typeface="PingFang SC" pitchFamily="34" charset="-122"/>
-                <a:cs typeface="PingFang SC" pitchFamily="34" charset="-120"/>
-              </a:rPr>
-              <a:t>CONVERT · 变</a:t>
-            </a:r>
-            <a:endParaRPr lang="zh-CN" sz="850" dirty="0"/>
-          </a:p>
-        </p:txBody>
-      </p:sp>
-      <p:sp>
-        <p:nvSpPr>
-          <p:cNvPr id="77" name="Shape 75"/>
-          <p:cNvSpPr/>
-          <p:nvPr/>
-        </p:nvSpPr>
-        <p:spPr>
-          <a:xfrm>
-            <a:off x="8421624" y="5641848"/>
-            <a:ext cx="3154680" cy="329184"/>
-          </a:xfrm>
-          <a:prstGeom prst="rect">
-            <a:avLst/>
-          </a:prstGeom>
-          <a:solidFill>
-            <a:srgbClr val="FFFFFF"/>
-          </a:solidFill>
-          <a:ln w="6985">
-            <a:solidFill>
-              <a:srgbClr val="D4D4D2"/>
-            </a:solidFill>
-            <a:prstDash val="solid"/>
-          </a:ln>
-        </p:spPr>
-      </p:sp>
-      <p:sp>
-        <p:nvSpPr>
-          <p:cNvPr id="78" name="Text 76"/>
-          <p:cNvSpPr txBox="1"/>
-          <p:nvPr/>
-        </p:nvSpPr>
-        <p:spPr>
-          <a:xfrm>
-            <a:off x="8586216" y="5715000"/>
-            <a:ext cx="2825496" cy="182880"/>
-          </a:xfrm>
-          <a:prstGeom prst="rect">
-            <a:avLst/>
-          </a:prstGeom>
-          <a:noFill/>
-          <a:ln/>
-        </p:spPr>
-        <p:txBody>
-          <a:bodyPr wrap="square" lIns="0" tIns="0" rIns="0" bIns="0" rtlCol="0" anchor="ctr">
-            <a:normAutofit/>
-          </a:bodyPr>
-          <a:lstStyle/>
-          <a:p>
-            <a:pPr algn="ctr" indent="0" marL="0">
-              <a:buNone/>
-            </a:pPr>
-            <a:r>
-              <a:rPr lang="zh-CN" altLang="en-US" sz="1080" b="1" dirty="0">
-                <a:solidFill>
-                  <a:srgbClr val="0A0A0A"/>
-                </a:solidFill>
-                <a:latin typeface="PingFang SC" pitchFamily="34" charset="0"/>
-                <a:ea typeface="PingFang SC" pitchFamily="34" charset="-122"/>
-                <a:cs typeface="PingFang SC" pitchFamily="34" charset="-120"/>
-              </a:rPr>
-              <a:t>行动学习</a:t>
-            </a:r>
-            <a:endParaRPr lang="zh-CN" sz="1080" dirty="0"/>
-          </a:p>
-        </p:txBody>
-      </p:sp>
-      <p:sp>
-        <p:nvSpPr>
-          <p:cNvPr id="79" name="Shape 77"/>
-          <p:cNvSpPr/>
-          <p:nvPr/>
-        </p:nvSpPr>
-        <p:spPr>
-          <a:xfrm>
-            <a:off x="1874520" y="6025896"/>
-            <a:ext cx="9720072" cy="228600"/>
-          </a:xfrm>
-          <a:prstGeom prst="rect">
-            <a:avLst/>
-          </a:prstGeom>
-          <a:solidFill>
-            <a:srgbClr val="F6ECE4"/>
-          </a:solidFill>
-          <a:ln w="6350">
-            <a:solidFill>
-              <a:srgbClr val="F6ECE4">
-                <a:alpha val="0"/>
-              </a:srgbClr>
-            </a:solidFill>
-            <a:prstDash val="solid"/>
-          </a:ln>
-        </p:spPr>
-      </p:sp>
-      <p:sp>
-        <p:nvSpPr>
-          <p:cNvPr id="80" name="Text 78"/>
-          <p:cNvSpPr txBox="1"/>
-          <p:nvPr/>
-        </p:nvSpPr>
-        <p:spPr>
-          <a:xfrm>
-            <a:off x="2057400" y="6053328"/>
-            <a:ext cx="9354312" cy="219456"/>
-          </a:xfrm>
-          <a:prstGeom prst="rect">
-            <a:avLst/>
-          </a:prstGeom>
-          <a:noFill/>
-          <a:ln/>
-        </p:spPr>
-        <p:txBody>
-          <a:bodyPr wrap="square" lIns="0" tIns="0" rIns="0" bIns="0" rtlCol="0" anchor="ctr"/>
-          <a:lstStyle/>
-          <a:p>
-            <a:pPr algn="ctr" indent="0" marL="0">
-              <a:buNone/>
-            </a:pPr>
-            <a:r>
-              <a:rPr lang="zh-CN" altLang="en-US" sz="850" b="1" spc="115" kern="0" dirty="0">
-                <a:solidFill>
-                  <a:srgbClr val="8B4A20"/>
-                </a:solidFill>
-                <a:latin typeface="PingFang SC" pitchFamily="34" charset="0"/>
-                <a:ea typeface="PingFang SC" pitchFamily="34" charset="-122"/>
-                <a:cs typeface="PingFang SC" pitchFamily="34" charset="-120"/>
-              </a:rPr>
-              <a:t>数字化培训管理 · 承接个人与组织培养任务</a:t>
-            </a:r>
-            <a:endParaRPr lang="zh-CN" sz="850" dirty="0"/>
-          </a:p>
-        </p:txBody>
-      </p:sp>
-      <p:sp>
-        <p:nvSpPr>
-          <p:cNvPr id="81" name="Shape 79"/>
-          <p:cNvSpPr/>
-          <p:nvPr/>
-        </p:nvSpPr>
-        <p:spPr>
-          <a:xfrm>
-            <a:off x="6693408" y="2615184"/>
-            <a:ext cx="0" cy="274320"/>
-          </a:xfrm>
-          <a:prstGeom prst="line">
-            <a:avLst/>
-          </a:prstGeom>
-          <a:noFill/>
-          <a:ln w="13335">
-            <a:solidFill>
-              <a:srgbClr val="002FA7"/>
-            </a:solidFill>
-            <a:prstDash val="solid"/>
-            <a:tailEnd type="triangle"/>
-          </a:ln>
-        </p:spPr>
-      </p:sp>
-      <p:sp>
-        <p:nvSpPr>
-          <p:cNvPr id="82" name="Shape 80"/>
-          <p:cNvSpPr/>
-          <p:nvPr/>
-        </p:nvSpPr>
-        <p:spPr>
-          <a:xfrm>
-            <a:off x="6693408" y="3849624"/>
-            <a:ext cx="0" cy="100584"/>
-          </a:xfrm>
-          <a:prstGeom prst="line">
-            <a:avLst/>
-          </a:prstGeom>
-          <a:noFill/>
-          <a:ln w="13335">
-            <a:solidFill>
-              <a:srgbClr val="002FA7"/>
-            </a:solidFill>
-            <a:prstDash val="solid"/>
-            <a:tailEnd type="triangle"/>
-          </a:ln>
-        </p:spPr>
-      </p:sp>
-      <p:sp>
-        <p:nvSpPr>
-          <p:cNvPr id="83" name="Shape 81"/>
-          <p:cNvSpPr/>
-          <p:nvPr/>
-        </p:nvSpPr>
-        <p:spPr>
-          <a:xfrm>
-            <a:off x="6693408" y="5111496"/>
-            <a:ext cx="0" cy="100584"/>
-          </a:xfrm>
-          <a:prstGeom prst="line">
-            <a:avLst/>
-          </a:prstGeom>
-          <a:noFill/>
-          <a:ln w="13335">
-            <a:solidFill>
-              <a:srgbClr val="002FA7"/>
-            </a:solidFill>
-            <a:prstDash val="solid"/>
-            <a:tailEnd type="triangle"/>
-          </a:ln>
-        </p:spPr>
+              <a:rPr lang="zh-CN" altLang="en-US" sz="1110" dirty="0">
+                <a:solidFill>
+                  <a:srgbClr val="525252"/>
+                </a:solidFill>
+                <a:latin typeface="PingFang SC" pitchFamily="34" charset="0"/>
+                <a:ea typeface="PingFang SC" pitchFamily="34" charset="-122"/>
+                <a:cs typeface="PingFang SC" pitchFamily="34" charset="-120"/>
+              </a:rPr>
+              <a:t>业务方向通过组织、人才与学习层层落地；人才与学习结果反向支撑业务达成。</a:t>
+            </a:r>
+            <a:endParaRPr lang="zh-CN" sz="1110" dirty="0"/>
+          </a:p>
+        </p:txBody>
       </p:sp>
     </p:spTree>
   </p:cSld>

</xml_diff>